<commit_message>
CP5 decision: move the two XI.5 avoid rows (Chinese-origin vendor APIs for client data; billing intermediation) to the monitor list; deck slide 16 and explorer updated
Co-Authored-By: Claude Opus 5.5 <noreply@anthropic.com>
Claude-Session: https://claude.ai/code/session_01GYt6k15P64MhHqeyveeQ6D
</commit_message>
<xml_diff>
--- a/Enterprise_GenAI_Stack_Oct2026/03_Slides/Executive_Deck.pptx
+++ b/Enterprise_GenAI_Stack_Oct2026/03_Slides/Executive_Deck.pptx
@@ -134,21 +134,21 @@
   <p:extLst>
     <p:ext uri="{521415D9-36F7-43E2-AB2F-B90AF26B5E84}">
       <p14:sectionLst xmlns:p14="http://schemas.microsoft.com/office/powerpoint/2010/main">
-        <p14:section name="Opening" id="{1ec1667c-26ab-57b7-489b-6451105a77ce}">
+        <p14:section name="Opening" id="{bff11cb5-6f4b-aade-f4d7-fd87315cfb4d}">
           <p14:sldIdLst>
             <p14:sldId id="256"/>
             <p14:sldId id="257"/>
             <p14:sldId id="258"/>
           </p14:sldIdLst>
         </p14:section>
-        <p14:section name="What changed" id="{e1e0d4bd-ff75-578a-4863-9b9b51221afa}">
+        <p14:section name="What changed" id="{315a7aef-9ace-f361-5a61-b5358ff9e899}">
           <p14:sldIdLst>
             <p14:sldId id="259"/>
             <p14:sldId id="260"/>
             <p14:sldId id="261"/>
           </p14:sldIdLst>
         </p14:section>
-        <p14:section name="The architecture" id="{6f21c441-5827-6a92-cfc2-7a3b50a6c1f9}">
+        <p14:section name="The architecture" id="{b54be733-418f-8861-91ee-24e89f674eb3}">
           <p14:sldIdLst>
             <p14:sldId id="262"/>
             <p14:sldId id="263"/>
@@ -156,7 +156,7 @@
             <p14:sldId id="265"/>
           </p14:sldIdLst>
         </p14:section>
-        <p14:section name="What to select" id="{acd31ea1-4f02-9558-d562-32becccd78ce}">
+        <p14:section name="What to select" id="{34ffeacc-ad8a-7c0a-635e-927bcf500b63}">
           <p14:sldIdLst>
             <p14:sldId id="266"/>
             <p14:sldId id="267"/>
@@ -166,7 +166,7 @@
             <p14:sldId id="271"/>
           </p14:sldIdLst>
         </p14:section>
-        <p14:section name="Regulated view" id="{b9e0f522-6c3c-f176-ffd9-2593d240fadf}">
+        <p14:section name="Regulated view" id="{4a537d09-971f-6a5b-25ce-c573a0691854}">
           <p14:sldIdLst>
             <p14:sldId id="272"/>
             <p14:sldId id="273"/>
@@ -174,7 +174,7 @@
             <p14:sldId id="275"/>
           </p14:sldIdLst>
         </p14:section>
-        <p14:section name="Delivery" id="{67d0383e-b003-3ac8-4c6e-58c411b624c6}">
+        <p14:section name="Delivery" id="{0615e4a0-0fce-9aa7-5a65-a8eae61045d7}">
           <p14:sldIdLst>
             <p14:sldId id="276"/>
             <p14:sldId id="277"/>
@@ -184,7 +184,7 @@
             <p14:sldId id="281"/>
           </p14:sldIdLst>
         </p14:section>
-        <p14:section name="Close" id="{8d69c8a6-c67b-08e5-089e-a4e43fdd03c7}">
+        <p14:section name="Close" id="{e9cee19b-7783-27a8-be6f-2837e4ba35e3}">
           <p14:sldIdLst>
             <p14:sldId id="282"/>
             <p14:sldId id="283"/>
@@ -1918,7 +1918,7 @@
           <a:p>
             <a:r>
               <a:rPr lang="en-US" dirty="0"/>
-              <a:t>Synthesis Part XI.5 (evidence-based avoid list, CP4-7) and Stack A 'do not build yet'.</a:t>
+              <a:t>Synthesis Part XI.5 (evidence-based avoid list, CP4-7; two routes moved to monitor at CP5) and Stack A 'do not build yet'.</a:t>
             </a:r>
             <a:endParaRPr lang="en-US" dirty="0"/>
           </a:p>
@@ -10353,144 +10353,6 @@
                           <a:ea typeface="Calibri" pitchFamily="34" charset="-122"/>
                           <a:cs typeface="Calibri" pitchFamily="34" charset="-120"/>
                         </a:rPr>
-                        <a:t>Any Chinese-origin vendor's own API for client data</a:t>
-                      </a:r>
-                      <a:endParaRPr lang="en-US" sz="1500" dirty="0">
-                        <a:latin typeface="Calibri" charset="0"/>
-                        <a:ea typeface="Calibri" charset="0"/>
-                        <a:cs typeface="Calibri" charset="0"/>
-                      </a:endParaRPr>
-                    </a:p>
-                  </a:txBody>
-                  <a:tcPr marL="54864" marR="54864" marT="54864" marB="54864" anchor="ctr">
-                    <a:lnL w="6350" cap="flat" cmpd="sng" algn="ctr">
-                      <a:solidFill>
-                        <a:srgbClr val="D5DCE3"/>
-                      </a:solidFill>
-                      <a:prstDash val="solid"/>
-                      <a:round/>
-                      <a:headEnd type="none" w="med" len="med"/>
-                      <a:tailEnd type="none" w="med" len="med"/>
-                    </a:lnL>
-                    <a:lnR w="6350" cap="flat" cmpd="sng" algn="ctr">
-                      <a:solidFill>
-                        <a:srgbClr val="D5DCE3"/>
-                      </a:solidFill>
-                      <a:prstDash val="solid"/>
-                      <a:round/>
-                      <a:headEnd type="none" w="med" len="med"/>
-                      <a:tailEnd type="none" w="med" len="med"/>
-                    </a:lnR>
-                    <a:lnT w="6350" cap="flat" cmpd="sng" algn="ctr">
-                      <a:solidFill>
-                        <a:srgbClr val="D5DCE3"/>
-                      </a:solidFill>
-                      <a:prstDash val="solid"/>
-                      <a:round/>
-                      <a:headEnd type="none" w="med" len="med"/>
-                      <a:tailEnd type="none" w="med" len="med"/>
-                    </a:lnT>
-                    <a:lnB w="6350" cap="flat" cmpd="sng" algn="ctr">
-                      <a:solidFill>
-                        <a:srgbClr val="D5DCE3"/>
-                      </a:solidFill>
-                      <a:prstDash val="solid"/>
-                      <a:round/>
-                      <a:headEnd type="none" w="med" len="med"/>
-                      <a:tailEnd type="none" w="med" len="med"/>
-                    </a:lnB>
-                    <a:solidFill>
-                      <a:srgbClr val="FFFFFF"/>
-                    </a:solidFill>
-                  </a:tcPr>
-                </a:tc>
-                <a:tc>
-                  <a:txBody>
-                    <a:bodyPr/>
-                    <a:lstStyle/>
-                    <a:p>
-                      <a:pPr indent="0" marL="0">
-                        <a:buNone/>
-                      </a:pPr>
-                      <a:r>
-                        <a:rPr lang="en-US" sz="1500" dirty="0">
-                          <a:solidFill>
-                            <a:srgbClr val="16202E"/>
-                          </a:solidFill>
-                          <a:latin typeface="Calibri" pitchFamily="34" charset="0"/>
-                          <a:ea typeface="Calibri" pitchFamily="34" charset="-122"/>
-                          <a:cs typeface="Calibri" pitchFamily="34" charset="-120"/>
-                        </a:rPr>
-                        <a:t>PRC storage and unremediated regulatory findings</a:t>
-                      </a:r>
-                      <a:endParaRPr lang="en-US" sz="1500" dirty="0">
-                        <a:latin typeface="Calibri" charset="0"/>
-                        <a:ea typeface="Calibri" charset="0"/>
-                        <a:cs typeface="Calibri" charset="0"/>
-                      </a:endParaRPr>
-                    </a:p>
-                  </a:txBody>
-                  <a:tcPr marL="54864" marR="54864" marT="54864" marB="54864" anchor="ctr">
-                    <a:lnL w="6350" cap="flat" cmpd="sng" algn="ctr">
-                      <a:solidFill>
-                        <a:srgbClr val="D5DCE3"/>
-                      </a:solidFill>
-                      <a:prstDash val="solid"/>
-                      <a:round/>
-                      <a:headEnd type="none" w="med" len="med"/>
-                      <a:tailEnd type="none" w="med" len="med"/>
-                    </a:lnL>
-                    <a:lnR w="6350" cap="flat" cmpd="sng" algn="ctr">
-                      <a:solidFill>
-                        <a:srgbClr val="D5DCE3"/>
-                      </a:solidFill>
-                      <a:prstDash val="solid"/>
-                      <a:round/>
-                      <a:headEnd type="none" w="med" len="med"/>
-                      <a:tailEnd type="none" w="med" len="med"/>
-                    </a:lnR>
-                    <a:lnT w="6350" cap="flat" cmpd="sng" algn="ctr">
-                      <a:solidFill>
-                        <a:srgbClr val="D5DCE3"/>
-                      </a:solidFill>
-                      <a:prstDash val="solid"/>
-                      <a:round/>
-                      <a:headEnd type="none" w="med" len="med"/>
-                      <a:tailEnd type="none" w="med" len="med"/>
-                    </a:lnT>
-                    <a:lnB w="6350" cap="flat" cmpd="sng" algn="ctr">
-                      <a:solidFill>
-                        <a:srgbClr val="D5DCE3"/>
-                      </a:solidFill>
-                      <a:prstDash val="solid"/>
-                      <a:round/>
-                      <a:headEnd type="none" w="med" len="med"/>
-                      <a:tailEnd type="none" w="med" len="med"/>
-                    </a:lnB>
-                    <a:solidFill>
-                      <a:srgbClr val="FFFFFF"/>
-                    </a:solidFill>
-                  </a:tcPr>
-                </a:tc>
-              </a:tr>
-              <a:tr h="0">
-                <a:tc>
-                  <a:txBody>
-                    <a:bodyPr/>
-                    <a:lstStyle/>
-                    <a:p>
-                      <a:pPr indent="0" marL="0">
-                        <a:buNone/>
-                      </a:pPr>
-                      <a:r>
-                        <a:rPr lang="en-US" sz="1500" dirty="0">
-                          <a:solidFill>
-                            <a:srgbClr val="16202E"/>
-                          </a:solidFill>
-                          <a:latin typeface="Calibri" pitchFamily="34" charset="0"/>
-                          <a:ea typeface="Calibri" pitchFamily="34" charset="-122"/>
-                          <a:cs typeface="Calibri" pitchFamily="34" charset="-120"/>
-                        </a:rPr>
                         <a:t>Jina weights, MinerU above thresholds, a modified AGPL Firecrawl server</a:t>
                       </a:r>
                       <a:endParaRPr lang="en-US" sz="1500" dirty="0">
@@ -10538,7 +10400,7 @@
                       <a:tailEnd type="none" w="med" len="med"/>
                     </a:lnB>
                     <a:solidFill>
-                      <a:srgbClr val="EEF2F5"/>
+                      <a:srgbClr val="FFFFFF"/>
                     </a:solidFill>
                   </a:tcPr>
                 </a:tc>
@@ -10606,7 +10468,7 @@
                       <a:tailEnd type="none" w="med" len="med"/>
                     </a:lnB>
                     <a:solidFill>
-                      <a:srgbClr val="EEF2F5"/>
+                      <a:srgbClr val="FFFFFF"/>
                     </a:solidFill>
                   </a:tcPr>
                 </a:tc>
@@ -10676,7 +10538,7 @@
                       <a:tailEnd type="none" w="med" len="med"/>
                     </a:lnB>
                     <a:solidFill>
-                      <a:srgbClr val="FFFFFF"/>
+                      <a:srgbClr val="EEF2F5"/>
                     </a:solidFill>
                   </a:tcPr>
                 </a:tc>
@@ -10744,144 +10606,6 @@
                       <a:tailEnd type="none" w="med" len="med"/>
                     </a:lnB>
                     <a:solidFill>
-                      <a:srgbClr val="FFFFFF"/>
-                    </a:solidFill>
-                  </a:tcPr>
-                </a:tc>
-              </a:tr>
-              <a:tr h="0">
-                <a:tc>
-                  <a:txBody>
-                    <a:bodyPr/>
-                    <a:lstStyle/>
-                    <a:p>
-                      <a:pPr indent="0" marL="0">
-                        <a:buNone/>
-                      </a:pPr>
-                      <a:r>
-                        <a:rPr lang="en-US" sz="1500" dirty="0">
-                          <a:solidFill>
-                            <a:srgbClr val="16202E"/>
-                          </a:solidFill>
-                          <a:latin typeface="Calibri" pitchFamily="34" charset="0"/>
-                          <a:ea typeface="Calibri" pitchFamily="34" charset="-122"/>
-                          <a:cs typeface="Calibri" pitchFamily="34" charset="-120"/>
-                        </a:rPr>
-                        <a:t>Billing intermediation through a gateway or router</a:t>
-                      </a:r>
-                      <a:endParaRPr lang="en-US" sz="1500" dirty="0">
-                        <a:latin typeface="Calibri" charset="0"/>
-                        <a:ea typeface="Calibri" charset="0"/>
-                        <a:cs typeface="Calibri" charset="0"/>
-                      </a:endParaRPr>
-                    </a:p>
-                  </a:txBody>
-                  <a:tcPr marL="54864" marR="54864" marT="54864" marB="54864" anchor="ctr">
-                    <a:lnL w="6350" cap="flat" cmpd="sng" algn="ctr">
-                      <a:solidFill>
-                        <a:srgbClr val="D5DCE3"/>
-                      </a:solidFill>
-                      <a:prstDash val="solid"/>
-                      <a:round/>
-                      <a:headEnd type="none" w="med" len="med"/>
-                      <a:tailEnd type="none" w="med" len="med"/>
-                    </a:lnL>
-                    <a:lnR w="6350" cap="flat" cmpd="sng" algn="ctr">
-                      <a:solidFill>
-                        <a:srgbClr val="D5DCE3"/>
-                      </a:solidFill>
-                      <a:prstDash val="solid"/>
-                      <a:round/>
-                      <a:headEnd type="none" w="med" len="med"/>
-                      <a:tailEnd type="none" w="med" len="med"/>
-                    </a:lnR>
-                    <a:lnT w="6350" cap="flat" cmpd="sng" algn="ctr">
-                      <a:solidFill>
-                        <a:srgbClr val="D5DCE3"/>
-                      </a:solidFill>
-                      <a:prstDash val="solid"/>
-                      <a:round/>
-                      <a:headEnd type="none" w="med" len="med"/>
-                      <a:tailEnd type="none" w="med" len="med"/>
-                    </a:lnT>
-                    <a:lnB w="6350" cap="flat" cmpd="sng" algn="ctr">
-                      <a:solidFill>
-                        <a:srgbClr val="D5DCE3"/>
-                      </a:solidFill>
-                      <a:prstDash val="solid"/>
-                      <a:round/>
-                      <a:headEnd type="none" w="med" len="med"/>
-                      <a:tailEnd type="none" w="med" len="med"/>
-                    </a:lnB>
-                    <a:solidFill>
-                      <a:srgbClr val="EEF2F5"/>
-                    </a:solidFill>
-                  </a:tcPr>
-                </a:tc>
-                <a:tc>
-                  <a:txBody>
-                    <a:bodyPr/>
-                    <a:lstStyle/>
-                    <a:p>
-                      <a:pPr indent="0" marL="0">
-                        <a:buNone/>
-                      </a:pPr>
-                      <a:r>
-                        <a:rPr lang="en-US" sz="1500" dirty="0">
-                          <a:solidFill>
-                            <a:srgbClr val="16202E"/>
-                          </a:solidFill>
-                          <a:latin typeface="Calibri" pitchFamily="34" charset="0"/>
-                          <a:ea typeface="Calibri" pitchFamily="34" charset="-122"/>
-                          <a:cs typeface="Calibri" pitchFamily="34" charset="-120"/>
-                        </a:rPr>
-                        <a:t>Puts a vendor between the firm and its model contract</a:t>
-                      </a:r>
-                      <a:endParaRPr lang="en-US" sz="1500" dirty="0">
-                        <a:latin typeface="Calibri" charset="0"/>
-                        <a:ea typeface="Calibri" charset="0"/>
-                        <a:cs typeface="Calibri" charset="0"/>
-                      </a:endParaRPr>
-                    </a:p>
-                  </a:txBody>
-                  <a:tcPr marL="54864" marR="54864" marT="54864" marB="54864" anchor="ctr">
-                    <a:lnL w="6350" cap="flat" cmpd="sng" algn="ctr">
-                      <a:solidFill>
-                        <a:srgbClr val="D5DCE3"/>
-                      </a:solidFill>
-                      <a:prstDash val="solid"/>
-                      <a:round/>
-                      <a:headEnd type="none" w="med" len="med"/>
-                      <a:tailEnd type="none" w="med" len="med"/>
-                    </a:lnL>
-                    <a:lnR w="6350" cap="flat" cmpd="sng" algn="ctr">
-                      <a:solidFill>
-                        <a:srgbClr val="D5DCE3"/>
-                      </a:solidFill>
-                      <a:prstDash val="solid"/>
-                      <a:round/>
-                      <a:headEnd type="none" w="med" len="med"/>
-                      <a:tailEnd type="none" w="med" len="med"/>
-                    </a:lnR>
-                    <a:lnT w="6350" cap="flat" cmpd="sng" algn="ctr">
-                      <a:solidFill>
-                        <a:srgbClr val="D5DCE3"/>
-                      </a:solidFill>
-                      <a:prstDash val="solid"/>
-                      <a:round/>
-                      <a:headEnd type="none" w="med" len="med"/>
-                      <a:tailEnd type="none" w="med" len="med"/>
-                    </a:lnT>
-                    <a:lnB w="6350" cap="flat" cmpd="sng" algn="ctr">
-                      <a:solidFill>
-                        <a:srgbClr val="D5DCE3"/>
-                      </a:solidFill>
-                      <a:prstDash val="solid"/>
-                      <a:round/>
-                      <a:headEnd type="none" w="med" len="med"/>
-                      <a:tailEnd type="none" w="med" len="med"/>
-                    </a:lnB>
-                    <a:solidFill>
                       <a:srgbClr val="EEF2F5"/>
                     </a:solidFill>
                   </a:tcPr>
@@ -10899,8 +10623,8 @@
         </p:nvSpPr>
         <p:spPr>
           <a:xfrm>
-            <a:off x="548640" y="5394960"/>
-            <a:ext cx="11064240" cy="731520"/>
+            <a:off x="548640" y="4846320"/>
+            <a:ext cx="11064240" cy="1188720"/>
           </a:xfrm>
           <a:prstGeom prst="rect">
             <a:avLst/>
@@ -10916,14 +10640,14 @@
               <a:buNone/>
             </a:pPr>
             <a:r>
-              <a:rPr lang="en-US" sz="1400" i="1" dirty="0">
+              <a:rPr lang="en-US" sz="1300" i="1" dirty="0">
                 <a:solidFill>
                   <a:schemeClr val="tx2"/>
                 </a:solidFill>
               </a:rPr>
-              <a:t>Not avoided but not yet: memory, autonomous agents with write tools, multi-agent delegation, fine-tuning, own-GPU fleets, dedicated vector databases without a failed load test.</a:t>
+              <a:t>Moved to monitor by the reader (CP5): Chinese-origin vendors' own APIs for client data (the route rule still applies) and billing intermediation. Not avoided but not yet: memory, autonomous agents with write tools, multi-agent delegation, fine-tuning, own-GPU fleets, dedicated vector databases without a failed load test.</a:t>
             </a:r>
-            <a:endParaRPr lang="en-US" sz="1400" dirty="0"/>
+            <a:endParaRPr lang="en-US" sz="1300" dirty="0"/>
           </a:p>
         </p:txBody>
       </p:sp>

</xml_diff>

<commit_message>
Work in progress: Veyan rebrand, L1→L9 order, Mermaid diagrams for all chapter flows, LinkedIn Post 0 and post visuals, master de-duplicated
- 34 ASCII flows in the chapters converted to editable Mermaid sources in 08_Graphic/diagrams/
- LinkedIn introduction post (Post 0) and visual renderer (tools/render_post_visuals.js); visuals in 08_Graphic/linkedin/
- Master: LinkedIn series and tile-by-tile annex removed (one home each); IV.1 states the model, XII.5 maps it to the popular stack diagram
- Deliverables are rebuilt in the next commit

Co-Authored-By: Claude Opus 5.5 <noreply@anthropic.com>
Claude-Session: https://claude.ai/code/session_01GYt6k15P64MhHqeyveeQ6D
</commit_message>
<xml_diff>
--- a/Enterprise_GenAI_Stack_Oct2026/03_Slides/Executive_Deck.pptx
+++ b/Enterprise_GenAI_Stack_Oct2026/03_Slides/Executive_Deck.pptx
@@ -33,9 +33,10 @@
     <p:sldId id="281" r:id="rId27"/>
     <p:sldId id="282" r:id="rId28"/>
     <p:sldId id="283" r:id="rId29"/>
+    <p:sldId id="284" r:id="rId30"/>
   </p:sldIdLst>
   <p:notesMasterIdLst>
-    <p:notesMasterId r:id="rId30"/>
+    <p:notesMasterId r:id="rId31"/>
   </p:notesMasterIdLst>
   <p:sldSz cx="12192000" cy="6858000"/>
   <p:notesSz cx="6858000" cy="12192000"/>
@@ -134,21 +135,21 @@
   <p:extLst>
     <p:ext uri="{521415D9-36F7-43E2-AB2F-B90AF26B5E84}">
       <p14:sectionLst xmlns:p14="http://schemas.microsoft.com/office/powerpoint/2010/main">
-        <p14:section name="Opening" id="{bff11cb5-6f4b-aade-f4d7-fd87315cfb4d}">
+        <p14:section name="Opening" id="{62390c3e-b397-a9f5-9866-74aecd469602}">
           <p14:sldIdLst>
             <p14:sldId id="256"/>
             <p14:sldId id="257"/>
             <p14:sldId id="258"/>
           </p14:sldIdLst>
         </p14:section>
-        <p14:section name="What changed" id="{315a7aef-9ace-f361-5a61-b5358ff9e899}">
+        <p14:section name="What changed since the popular stack diagram" id="{478231d5-a422-ba7a-6b1d-128eb06b1e6e}">
           <p14:sldIdLst>
             <p14:sldId id="259"/>
             <p14:sldId id="260"/>
             <p14:sldId id="261"/>
           </p14:sldIdLst>
         </p14:section>
-        <p14:section name="The architecture" id="{b54be733-418f-8861-91ee-24e89f674eb3}">
+        <p14:section name="The architecture" id="{cfe541a7-5ca7-ed38-3bbc-e7ce2c50402b}">
           <p14:sldIdLst>
             <p14:sldId id="262"/>
             <p14:sldId id="263"/>
@@ -156,7 +157,7 @@
             <p14:sldId id="265"/>
           </p14:sldIdLst>
         </p14:section>
-        <p14:section name="What to select" id="{34ffeacc-ad8a-7c0a-635e-927bcf500b63}">
+        <p14:section name="What to select" id="{42c4814c-6832-bb9d-47b1-9a65759983a7}">
           <p14:sldIdLst>
             <p14:sldId id="266"/>
             <p14:sldId id="267"/>
@@ -166,7 +167,7 @@
             <p14:sldId id="271"/>
           </p14:sldIdLst>
         </p14:section>
-        <p14:section name="Regulated view" id="{4a537d09-971f-6a5b-25ce-c573a0691854}">
+        <p14:section name="Regulated view" id="{183c93ee-8ba3-3a5f-7d91-763f1952ebe4}">
           <p14:sldIdLst>
             <p14:sldId id="272"/>
             <p14:sldId id="273"/>
@@ -174,7 +175,7 @@
             <p14:sldId id="275"/>
           </p14:sldIdLst>
         </p14:section>
-        <p14:section name="Delivery" id="{0615e4a0-0fce-9aa7-5a65-a8eae61045d7}">
+        <p14:section name="Delivery" id="{ac32cff2-3d31-5e32-9ef4-cce7854c16c0}">
           <p14:sldIdLst>
             <p14:sldId id="276"/>
             <p14:sldId id="277"/>
@@ -184,10 +185,11 @@
             <p14:sldId id="281"/>
           </p14:sldIdLst>
         </p14:section>
-        <p14:section name="Close" id="{e9cee19b-7783-27a8-be6f-2837e4ba35e3}">
+        <p14:section name="Close" id="{7eb4a99d-a9c4-cf37-80dd-5da72dd074d8}">
           <p14:sldIdLst>
             <p14:sldId id="282"/>
             <p14:sldId id="283"/>
+            <p14:sldId id="284"/>
           </p14:sldIdLst>
         </p14:section>
       </p14:sectionLst>
@@ -213,7 +215,7 @@
             <a:pPr>
               <a:defRPr sz="1300" b="0" i="0" u="none" strike="noStrike">
                 <a:solidFill>
-                  <a:srgbClr val="1B2A41"/>
+                  <a:srgbClr val="0B1B33"/>
                 </a:solidFill>
                 <a:latin typeface="+mn-lt"/>
               </a:defRPr>
@@ -221,7 +223,7 @@
             <a:r>
               <a:rPr sz="1300" b="0" i="0" u="none" strike="noStrike">
                 <a:solidFill>
-                  <a:srgbClr val="1B2A41"/>
+                  <a:srgbClr val="0B1B33"/>
                 </a:solidFill>
                 <a:latin typeface="+mn-lt"/>
               </a:rPr>
@@ -256,7 +258,7 @@
           </c:tx>
           <c:spPr>
             <a:solidFill>
-              <a:srgbClr val="0E7C7B"/>
+              <a:srgbClr val="2E6DA4"/>
             </a:solidFill>
             <a:effectLst/>
           </c:spPr>
@@ -592,7 +594,7 @@
           </c:tx>
           <c:spPr>
             <a:solidFill>
-              <a:srgbClr val="C9822B"/>
+              <a:srgbClr val="D4A13A"/>
             </a:solidFill>
             <a:effectLst/>
           </c:spPr>
@@ -802,7 +804,7 @@
             <a:pPr>
               <a:defRPr sz="1100" b="0" i="0" u="none" strike="noStrike">
                 <a:solidFill>
-                  <a:srgbClr val="16202E"/>
+                  <a:srgbClr val="0B1B33"/>
                 </a:solidFill>
                 <a:latin typeface="+mn-lt"/>
               </a:defRPr>
@@ -854,7 +856,7 @@
             <a:pPr>
               <a:defRPr sz="1100" b="0" i="0" u="none" strike="noStrike">
                 <a:solidFill>
-                  <a:srgbClr val="16202E"/>
+                  <a:srgbClr val="0B1B33"/>
                 </a:solidFill>
                 <a:latin typeface="+mn-lt"/>
               </a:defRPr>
@@ -3104,6 +3106,94 @@
 </p:notes>
 </file>
 
+<file path=ppt/notesSlides/notesSlide29.xml><?xml version="1.0" encoding="utf-8"?>
+<p:notes xmlns:a="http://schemas.openxmlformats.org/drawingml/2006/main" xmlns:r="http://schemas.openxmlformats.org/officeDocument/2006/relationships" xmlns:p="http://schemas.openxmlformats.org/presentationml/2006/main">
+  <p:cSld>
+    <p:spTree>
+      <p:nvGrpSpPr>
+        <p:cNvPr id="1" name=""/>
+        <p:cNvGrpSpPr/>
+        <p:nvPr/>
+      </p:nvGrpSpPr>
+      <p:grpSpPr>
+        <a:xfrm>
+          <a:off x="0" y="0"/>
+          <a:ext cx="0" cy="0"/>
+          <a:chOff x="0" y="0"/>
+          <a:chExt cx="0" cy="0"/>
+        </a:xfrm>
+      </p:grpSpPr>
+      <p:sp>
+        <p:nvSpPr>
+          <p:cNvPr id="2" name="Slide Image Placeholder 1"/>
+          <p:cNvSpPr>
+            <a:spLocks noGrp="1" noRot="1" noChangeAspect="1"/>
+          </p:cNvSpPr>
+          <p:nvPr>
+            <p:ph type="sldImg"/>
+          </p:nvPr>
+        </p:nvSpPr>
+        <p:spPr/>
+      </p:sp>
+      <p:sp>
+        <p:nvSpPr>
+          <p:cNvPr id="3" name="Notes Placeholder 2"/>
+          <p:cNvSpPr>
+            <a:spLocks noGrp="1"/>
+          </p:cNvSpPr>
+          <p:nvPr>
+            <p:ph type="body" idx="1"/>
+          </p:nvPr>
+        </p:nvSpPr>
+        <p:spPr/>
+        <p:txBody>
+          <a:bodyPr/>
+          <a:lstStyle/>
+          <a:p>
+            <a:r>
+              <a:rPr lang="en-US" dirty="0"/>
+              <a:t>Veyan. Truth, compounded. hello@veyan.ai</a:t>
+            </a:r>
+            <a:endParaRPr lang="en-US" dirty="0"/>
+          </a:p>
+        </p:txBody>
+      </p:sp>
+      <p:sp>
+        <p:nvSpPr>
+          <p:cNvPr id="4" name="Slide Number Placeholder 3"/>
+          <p:cNvSpPr>
+            <a:spLocks noGrp="1"/>
+          </p:cNvSpPr>
+          <p:nvPr>
+            <p:ph type="sldNum" sz="quarter" idx="10"/>
+          </p:nvPr>
+        </p:nvSpPr>
+        <p:spPr/>
+        <p:txBody>
+          <a:bodyPr/>
+          <a:lstStyle/>
+          <a:p>
+            <a:fld id="{F7021451-1387-4CA6-816F-3879F97B5CBC}" type="slidenum">
+              <a:rPr lang="en-US"/>
+              <a:t>29</a:t>
+            </a:fld>
+            <a:endParaRPr lang="en-US"/>
+          </a:p>
+        </p:txBody>
+      </p:sp>
+    </p:spTree>
+    <p:extLst>
+      <p:ext uri="{BB962C8B-B14F-4D97-AF65-F5344CB8AC3E}">
+        <p14:creationId xmlns:p14="http://schemas.microsoft.com/office/powerpoint/2010/main" val="1024086991"/>
+      </p:ext>
+    </p:extLst>
+  </p:cSld>
+  <p:clrMapOvr>
+    <a:masterClrMapping/>
+  </p:clrMapOvr>
+</p:notes>
+</file>
+
 <file path=ppt/notesSlides/notesSlide3.xml><?xml version="1.0" encoding="utf-8"?>
 <p:notes xmlns:a="http://schemas.openxmlformats.org/drawingml/2006/main" xmlns:r="http://schemas.openxmlformats.org/officeDocument/2006/relationships" xmlns:p="http://schemas.openxmlformats.org/presentationml/2006/main">
   <p:cSld>
@@ -3756,7 +3846,7 @@
     <p:bg>
       <p:bgPr>
         <a:solidFill>
-          <a:schemeClr val="tx2"/>
+          <a:srgbClr val="0B1B33"/>
         </a:solidFill>
       </p:bgPr>
     </p:bg>
@@ -3774,18 +3864,167 @@
           <a:chExt cx="0" cy="0"/>
         </a:xfrm>
       </p:grpSpPr>
-      <p:sp>
-        <p:nvSpPr>
-          <p:cNvPr id="2" name="Text 0"/>
+      <p:pic>
+        <p:nvPicPr>
+          <p:cNvPr id="2" name="Image 0" descr="brand/veyan_hero.png">    </p:cNvPr>
+          <p:cNvPicPr>
+            <a:picLocks noChangeAspect="1"/>
+          </p:cNvPicPr>
+          <p:nvPr/>
+        </p:nvPicPr>
+        <p:blipFill>
+          <a:blip r:embed="rId1"/>
+          <a:stretch>
+            <a:fillRect/>
+          </a:stretch>
+        </p:blipFill>
+        <p:spPr>
+          <a:xfrm>
+            <a:off x="0" y="0"/>
+            <a:ext cx="4700016" cy="6858000"/>
+          </a:xfrm>
+          <a:prstGeom prst="rect">
+            <a:avLst/>
+          </a:prstGeom>
+        </p:spPr>
+      </p:pic>
+      <p:pic>
+        <p:nvPicPr>
+          <p:cNvPr id="3" name="Image 1" descr="brand/veyan_logo_white.png">    </p:cNvPr>
+          <p:cNvPicPr>
+            <a:picLocks noChangeAspect="1"/>
+          </p:cNvPicPr>
+          <p:nvPr/>
+        </p:nvPicPr>
+        <p:blipFill>
+          <a:blip r:embed="rId2"/>
+          <a:stretch>
+            <a:fillRect/>
+          </a:stretch>
+        </p:blipFill>
+        <p:spPr>
+          <a:xfrm>
+            <a:off x="5257800" y="685800"/>
+            <a:ext cx="2651760" cy="721851"/>
+          </a:xfrm>
+          <a:prstGeom prst="rect">
+            <a:avLst/>
+          </a:prstGeom>
+        </p:spPr>
+      </p:pic>
+      <p:sp>
+        <p:nvSpPr>
+          <p:cNvPr id="4" name="Text 0"/>
+          <p:cNvSpPr/>
+          <p:nvPr/>
+        </p:nvSpPr>
+        <p:spPr>
+          <a:xfrm>
+            <a:off x="5257800" y="1600200"/>
+            <a:ext cx="6400800" cy="320040"/>
+          </a:xfrm>
+          <a:prstGeom prst="rect">
+            <a:avLst/>
+          </a:prstGeom>
+          <a:noFill/>
+          <a:ln/>
+        </p:spPr>
+        <p:txBody>
+          <a:bodyPr wrap="square" rtlCol="0" anchor="ctr"/>
+          <a:lstStyle/>
+          <a:p>
+            <a:pPr indent="0" marL="0">
+              <a:buNone/>
+            </a:pPr>
+            <a:r>
+              <a:rPr lang="en-US" sz="1200" spc="600" kern="0" dirty="0">
+                <a:solidFill>
+                  <a:srgbClr val="D4A13A"/>
+                </a:solidFill>
+              </a:rPr>
+              <a:t>THE VIEW AT END OF Q3 2026</a:t>
+            </a:r>
+            <a:endParaRPr lang="en-US" sz="1200" dirty="0"/>
+          </a:p>
+        </p:txBody>
+      </p:sp>
+      <p:sp>
+        <p:nvSpPr>
+          <p:cNvPr id="5" name="Shape 1"/>
+          <p:cNvSpPr/>
+          <p:nvPr/>
+        </p:nvSpPr>
+        <p:spPr>
+          <a:xfrm>
+            <a:off x="5303520" y="2011680"/>
+            <a:ext cx="640080" cy="0"/>
+          </a:xfrm>
+          <a:prstGeom prst="line">
+            <a:avLst/>
+          </a:prstGeom>
+          <a:noFill/>
+          <a:ln w="25400">
+            <a:solidFill>
+              <a:srgbClr val="D4A13A"/>
+            </a:solidFill>
+            <a:prstDash val="solid"/>
+          </a:ln>
+        </p:spPr>
+      </p:sp>
+      <p:sp>
+        <p:nvSpPr>
+          <p:cNvPr id="6" name="Text 2"/>
           <p:cNvSpPr/>
           <p:nvPr>
-            <p:ph idx="100" type="title" hasCustomPrompt="1"/>
+            <p:ph idx="104" type="title" hasCustomPrompt="1"/>
           </p:nvPr>
         </p:nvSpPr>
         <p:spPr>
           <a:xfrm>
-            <a:off x="731520" y="1920240"/>
-            <a:ext cx="10698480" cy="1463040"/>
+            <a:off x="5257800" y="2240280"/>
+            <a:ext cx="6400800" cy="1828800"/>
+          </a:xfrm>
+          <a:prstGeom prst="rect">
+            <a:avLst/>
+          </a:prstGeom>
+          <a:noFill/>
+          <a:ln/>
+        </p:spPr>
+        <p:txBody>
+          <a:bodyPr wrap="square" rtlCol="0"/>
+          <a:lstStyle>
+            <a:lvl1pPr algn="l" indent="0" marL="0">
+              <a:buNone/>
+              <a:defRPr lang="en-US" sz="3600" b="1" dirty="0">
+                <a:solidFill>
+                  <a:schemeClr val="bg1"/>
+                </a:solidFill>
+                <a:latin typeface="Arial" pitchFamily="34" charset="0"/>
+                <a:ea typeface="Arial" pitchFamily="34" charset="-122"/>
+                <a:cs typeface="Arial" pitchFamily="34" charset="-120"/>
+              </a:defRPr>
+            </a:lvl1pPr>
+          </a:lstStyle>
+          <a:p>
+            <a:pPr algn="l" indent="0" marL="0">
+              <a:buNone/>
+            </a:pPr>
+            <a:endParaRPr lang="en-US" sz="3600" dirty="0"/>
+          </a:p>
+        </p:txBody>
+      </p:sp>
+      <p:sp>
+        <p:nvSpPr>
+          <p:cNvPr id="7" name="Text 2"/>
+          <p:cNvSpPr/>
+          <p:nvPr>
+            <p:ph idx="105" type="body" hasCustomPrompt="1"/>
+          </p:nvPr>
+        </p:nvSpPr>
+        <p:spPr>
+          <a:xfrm>
+            <a:off x="5257800" y="4114800"/>
+            <a:ext cx="6400800" cy="1463040"/>
           </a:xfrm>
           <a:prstGeom prst="rect">
             <a:avLst/>
@@ -3798,51 +4037,9 @@
           <a:lstStyle>
             <a:lvl1pPr indent="0" marL="0">
               <a:buNone/>
-              <a:defRPr lang="en-US" sz="4000" b="1" dirty="0">
+              <a:defRPr lang="en-US" sz="1600" dirty="0">
                 <a:solidFill>
-                  <a:schemeClr val="bg1"/>
-                </a:solidFill>
-                <a:latin typeface="Cambria" pitchFamily="34" charset="0"/>
-                <a:ea typeface="Cambria" pitchFamily="34" charset="-122"/>
-                <a:cs typeface="Cambria" pitchFamily="34" charset="-120"/>
-              </a:defRPr>
-            </a:lvl1pPr>
-          </a:lstStyle>
-          <a:p>
-            <a:pPr indent="0" marL="0">
-              <a:buNone/>
-            </a:pPr>
-            <a:endParaRPr lang="en-US" sz="4000" dirty="0"/>
-          </a:p>
-        </p:txBody>
-      </p:sp>
-      <p:sp>
-        <p:nvSpPr>
-          <p:cNvPr id="3" name="Text 0"/>
-          <p:cNvSpPr/>
-          <p:nvPr>
-            <p:ph idx="101" type="body" hasCustomPrompt="1"/>
-          </p:nvPr>
-        </p:nvSpPr>
-        <p:spPr>
-          <a:xfrm>
-            <a:off x="731520" y="3566160"/>
-            <a:ext cx="10698480" cy="1463040"/>
-          </a:xfrm>
-          <a:prstGeom prst="rect">
-            <a:avLst/>
-          </a:prstGeom>
-          <a:noFill/>
-          <a:ln/>
-        </p:spPr>
-        <p:txBody>
-          <a:bodyPr wrap="square" rtlCol="0"/>
-          <a:lstStyle>
-            <a:lvl1pPr indent="0" marL="0">
-              <a:buNone/>
-              <a:defRPr lang="en-US" sz="1800" dirty="0">
-                <a:solidFill>
-                  <a:schemeClr val="bg2"/>
+                  <a:schemeClr val="accent5"/>
                 </a:solidFill>
               </a:defRPr>
             </a:lvl1pPr>
@@ -3851,7 +4048,43 @@
             <a:pPr indent="0" marL="0">
               <a:buNone/>
             </a:pPr>
-            <a:endParaRPr lang="en-US" sz="1800" dirty="0"/>
+            <a:endParaRPr lang="en-US" sz="1600" dirty="0"/>
+          </a:p>
+        </p:txBody>
+      </p:sp>
+      <p:sp>
+        <p:nvSpPr>
+          <p:cNvPr id="8" name="Text 2"/>
+          <p:cNvSpPr/>
+          <p:nvPr/>
+        </p:nvSpPr>
+        <p:spPr>
+          <a:xfrm>
+            <a:off x="5257800" y="6172200"/>
+            <a:ext cx="6400800" cy="274320"/>
+          </a:xfrm>
+          <a:prstGeom prst="rect">
+            <a:avLst/>
+          </a:prstGeom>
+          <a:noFill/>
+          <a:ln/>
+        </p:spPr>
+        <p:txBody>
+          <a:bodyPr wrap="square" rtlCol="0" anchor="ctr"/>
+          <a:lstStyle/>
+          <a:p>
+            <a:pPr indent="0" marL="0">
+              <a:buNone/>
+            </a:pPr>
+            <a:r>
+              <a:rPr lang="en-US" sz="900" spc="300" kern="0" dirty="0">
+                <a:solidFill>
+                  <a:srgbClr val="9DBBDB"/>
+                </a:solidFill>
+              </a:rPr>
+              <a:t>PEOPLE  |  INSIGHTS  |  DECISIONS  |  A BRIGHTER TOMORROW</a:t>
+            </a:r>
+            <a:endParaRPr lang="en-US" sz="900" dirty="0"/>
           </a:p>
         </p:txBody>
       </p:sp>
@@ -3869,7 +4102,7 @@
     <p:bg>
       <p:bgPr>
         <a:solidFill>
-          <a:schemeClr val="tx2"/>
+          <a:srgbClr val="0B1B33"/>
         </a:solidFill>
       </p:bgPr>
     </p:bg>
@@ -3887,18 +4120,131 @@
           <a:chExt cx="0" cy="0"/>
         </a:xfrm>
       </p:grpSpPr>
-      <p:sp>
-        <p:nvSpPr>
-          <p:cNvPr id="2" name="Text 0"/>
+      <p:pic>
+        <p:nvPicPr>
+          <p:cNvPr id="2" name="Image 0" descr="brand/veyan_hero_strip.png">    </p:cNvPr>
+          <p:cNvPicPr>
+            <a:picLocks noChangeAspect="1"/>
+          </p:cNvPicPr>
+          <p:nvPr/>
+        </p:nvPicPr>
+        <p:blipFill>
+          <a:blip r:embed="rId1"/>
+          <a:stretch>
+            <a:fillRect/>
+          </a:stretch>
+        </p:blipFill>
+        <p:spPr>
+          <a:xfrm>
+            <a:off x="8412480" y="0"/>
+            <a:ext cx="3776472" cy="6858000"/>
+          </a:xfrm>
+          <a:prstGeom prst="rect">
+            <a:avLst/>
+          </a:prstGeom>
+        </p:spPr>
+      </p:pic>
+      <p:pic>
+        <p:nvPicPr>
+          <p:cNvPr id="3" name="Image 1" descr="brand/veyan_icon.png">    </p:cNvPr>
+          <p:cNvPicPr>
+            <a:picLocks noChangeAspect="1"/>
+          </p:cNvPicPr>
+          <p:nvPr/>
+        </p:nvPicPr>
+        <p:blipFill>
+          <a:blip r:embed="rId2"/>
+          <a:stretch>
+            <a:fillRect/>
+          </a:stretch>
+        </p:blipFill>
+        <p:spPr>
+          <a:xfrm>
+            <a:off x="731520" y="1234440"/>
+            <a:ext cx="868680" cy="868680"/>
+          </a:xfrm>
+          <a:prstGeom prst="rect">
+            <a:avLst/>
+          </a:prstGeom>
+        </p:spPr>
+      </p:pic>
+      <p:sp>
+        <p:nvSpPr>
+          <p:cNvPr id="4" name="Shape 0"/>
+          <p:cNvSpPr/>
+          <p:nvPr/>
+        </p:nvSpPr>
+        <p:spPr>
+          <a:xfrm>
+            <a:off x="777240" y="3520440"/>
+            <a:ext cx="640080" cy="0"/>
+          </a:xfrm>
+          <a:prstGeom prst="line">
+            <a:avLst/>
+          </a:prstGeom>
+          <a:noFill/>
+          <a:ln w="25400">
+            <a:solidFill>
+              <a:srgbClr val="D4A13A"/>
+            </a:solidFill>
+            <a:prstDash val="solid"/>
+          </a:ln>
+        </p:spPr>
+      </p:sp>
+      <p:sp>
+        <p:nvSpPr>
+          <p:cNvPr id="5" name="Text 1"/>
           <p:cNvSpPr/>
           <p:nvPr>
-            <p:ph idx="100" type="title" hasCustomPrompt="1"/>
+            <p:ph idx="103" type="title" hasCustomPrompt="1"/>
           </p:nvPr>
         </p:nvSpPr>
         <p:spPr>
           <a:xfrm>
-            <a:off x="731520" y="2377440"/>
-            <a:ext cx="10698480" cy="1097280"/>
+            <a:off x="731520" y="2331720"/>
+            <a:ext cx="7315200" cy="1097280"/>
+          </a:xfrm>
+          <a:prstGeom prst="rect">
+            <a:avLst/>
+          </a:prstGeom>
+          <a:noFill/>
+          <a:ln/>
+        </p:spPr>
+        <p:txBody>
+          <a:bodyPr wrap="square" rtlCol="0"/>
+          <a:lstStyle>
+            <a:lvl1pPr algn="l" indent="0" marL="0">
+              <a:buNone/>
+              <a:defRPr lang="en-US" sz="3400" b="1" dirty="0">
+                <a:solidFill>
+                  <a:schemeClr val="bg1"/>
+                </a:solidFill>
+                <a:latin typeface="Arial" pitchFamily="34" charset="0"/>
+                <a:ea typeface="Arial" pitchFamily="34" charset="-122"/>
+                <a:cs typeface="Arial" pitchFamily="34" charset="-120"/>
+              </a:defRPr>
+            </a:lvl1pPr>
+          </a:lstStyle>
+          <a:p>
+            <a:pPr algn="l" indent="0" marL="0">
+              <a:buNone/>
+            </a:pPr>
+            <a:endParaRPr lang="en-US" sz="3400" dirty="0"/>
+          </a:p>
+        </p:txBody>
+      </p:sp>
+      <p:sp>
+        <p:nvSpPr>
+          <p:cNvPr id="6" name="Text 1"/>
+          <p:cNvSpPr/>
+          <p:nvPr>
+            <p:ph idx="104" type="body" hasCustomPrompt="1"/>
+          </p:nvPr>
+        </p:nvSpPr>
+        <p:spPr>
+          <a:xfrm>
+            <a:off x="731520" y="3703320"/>
+            <a:ext cx="7315200" cy="1097280"/>
           </a:xfrm>
           <a:prstGeom prst="rect">
             <a:avLst/>
@@ -3911,49 +4257,7 @@
           <a:lstStyle>
             <a:lvl1pPr indent="0" marL="0">
               <a:buNone/>
-              <a:defRPr lang="en-US" sz="3600" b="1" dirty="0">
-                <a:solidFill>
-                  <a:schemeClr val="bg1"/>
-                </a:solidFill>
-                <a:latin typeface="Cambria" pitchFamily="34" charset="0"/>
-                <a:ea typeface="Cambria" pitchFamily="34" charset="-122"/>
-                <a:cs typeface="Cambria" pitchFamily="34" charset="-120"/>
-              </a:defRPr>
-            </a:lvl1pPr>
-          </a:lstStyle>
-          <a:p>
-            <a:pPr indent="0" marL="0">
-              <a:buNone/>
-            </a:pPr>
-            <a:endParaRPr lang="en-US" sz="3600" dirty="0"/>
-          </a:p>
-        </p:txBody>
-      </p:sp>
-      <p:sp>
-        <p:nvSpPr>
-          <p:cNvPr id="3" name="Text 0"/>
-          <p:cNvSpPr/>
-          <p:nvPr>
-            <p:ph idx="101" type="body" hasCustomPrompt="1"/>
-          </p:nvPr>
-        </p:nvSpPr>
-        <p:spPr>
-          <a:xfrm>
-            <a:off x="731520" y="3566160"/>
-            <a:ext cx="10698480" cy="914400"/>
-          </a:xfrm>
-          <a:prstGeom prst="rect">
-            <a:avLst/>
-          </a:prstGeom>
-          <a:noFill/>
-          <a:ln/>
-        </p:spPr>
-        <p:txBody>
-          <a:bodyPr wrap="square" rtlCol="0"/>
-          <a:lstStyle>
-            <a:lvl1pPr indent="0" marL="0">
-              <a:buNone/>
-              <a:defRPr lang="en-US" sz="1800" dirty="0">
+              <a:defRPr lang="en-US" sz="1700" dirty="0">
                 <a:solidFill>
                   <a:schemeClr val="accent5"/>
                 </a:solidFill>
@@ -3964,7 +4268,7 @@
             <a:pPr indent="0" marL="0">
               <a:buNone/>
             </a:pPr>
-            <a:endParaRPr lang="en-US" sz="1800" dirty="0"/>
+            <a:endParaRPr lang="en-US" sz="1700" dirty="0"/>
           </a:p>
         </p:txBody>
       </p:sp>
@@ -4011,7 +4315,7 @@
         <p:spPr>
           <a:xfrm>
             <a:off x="548640" y="320040"/>
-            <a:ext cx="11064240" cy="822960"/>
+            <a:ext cx="9692640" cy="822960"/>
           </a:xfrm>
           <a:prstGeom prst="rect">
             <a:avLst/>
@@ -4022,36 +4326,107 @@
         <p:txBody>
           <a:bodyPr wrap="square" rtlCol="0"/>
           <a:lstStyle>
-            <a:lvl1pPr indent="0" marL="0">
+            <a:lvl1pPr algn="l" indent="0" marL="0">
               <a:buNone/>
-              <a:defRPr lang="en-US" sz="2800" b="1" dirty="0">
+              <a:defRPr lang="en-US" sz="2600" b="1" dirty="0">
                 <a:solidFill>
                   <a:schemeClr val="tx2"/>
                 </a:solidFill>
-                <a:latin typeface="Cambria" pitchFamily="34" charset="0"/>
-                <a:ea typeface="Cambria" pitchFamily="34" charset="-122"/>
-                <a:cs typeface="Cambria" pitchFamily="34" charset="-120"/>
+                <a:latin typeface="Arial" pitchFamily="34" charset="0"/>
+                <a:ea typeface="Arial" pitchFamily="34" charset="-122"/>
+                <a:cs typeface="Arial" pitchFamily="34" charset="-120"/>
               </a:defRPr>
             </a:lvl1pPr>
           </a:lstStyle>
           <a:p>
-            <a:pPr indent="0" marL="0">
+            <a:pPr algn="l" indent="0" marL="0">
               <a:buNone/>
             </a:pPr>
-            <a:endParaRPr lang="en-US" sz="2800" dirty="0"/>
-          </a:p>
-        </p:txBody>
-      </p:sp>
-      <p:sp>
-        <p:nvSpPr>
-          <p:cNvPr id="3" name="Text 0"/>
+            <a:endParaRPr lang="en-US" sz="2600" dirty="0"/>
+          </a:p>
+        </p:txBody>
+      </p:sp>
+      <p:pic>
+        <p:nvPicPr>
+          <p:cNvPr id="3" name="Image 0" descr="brand/veyan_logo.png">    </p:cNvPr>
+          <p:cNvPicPr>
+            <a:picLocks noChangeAspect="1"/>
+          </p:cNvPicPr>
+          <p:nvPr/>
+        </p:nvPicPr>
+        <p:blipFill>
+          <a:blip r:embed="rId1"/>
+          <a:stretch>
+            <a:fillRect/>
+          </a:stretch>
+        </p:blipFill>
+        <p:spPr>
+          <a:xfrm>
+            <a:off x="10469880" y="457200"/>
+            <a:ext cx="1188720" cy="323589"/>
+          </a:xfrm>
+          <a:prstGeom prst="rect">
+            <a:avLst/>
+          </a:prstGeom>
+        </p:spPr>
+      </p:pic>
+      <p:sp>
+        <p:nvSpPr>
+          <p:cNvPr id="4" name="Shape 0"/>
           <p:cNvSpPr/>
           <p:nvPr/>
         </p:nvSpPr>
         <p:spPr>
           <a:xfrm>
-            <a:off x="548640" y="6400800"/>
-            <a:ext cx="9601200" cy="274320"/>
+            <a:off x="566928" y="1143000"/>
+            <a:ext cx="548640" cy="0"/>
+          </a:xfrm>
+          <a:prstGeom prst="line">
+            <a:avLst/>
+          </a:prstGeom>
+          <a:noFill/>
+          <a:ln w="25400">
+            <a:solidFill>
+              <a:srgbClr val="D4A13A"/>
+            </a:solidFill>
+            <a:prstDash val="solid"/>
+          </a:ln>
+        </p:spPr>
+      </p:sp>
+      <p:pic>
+        <p:nvPicPr>
+          <p:cNvPr id="5" name="Image 1" descr="brand/veyan_icon.png">    </p:cNvPr>
+          <p:cNvPicPr>
+            <a:picLocks noChangeAspect="1"/>
+          </p:cNvPicPr>
+          <p:nvPr/>
+        </p:nvPicPr>
+        <p:blipFill>
+          <a:blip r:embed="rId2"/>
+          <a:stretch>
+            <a:fillRect/>
+          </a:stretch>
+        </p:blipFill>
+        <p:spPr>
+          <a:xfrm>
+            <a:off x="548640" y="6428232"/>
+            <a:ext cx="219456" cy="219456"/>
+          </a:xfrm>
+          <a:prstGeom prst="rect">
+            <a:avLst/>
+          </a:prstGeom>
+        </p:spPr>
+      </p:pic>
+      <p:sp>
+        <p:nvSpPr>
+          <p:cNvPr id="6" name="Text 1"/>
+          <p:cNvSpPr/>
+          <p:nvPr/>
+        </p:nvSpPr>
+        <p:spPr>
+          <a:xfrm>
+            <a:off x="841248" y="6400800"/>
+            <a:ext cx="9326880" cy="274320"/>
           </a:xfrm>
           <a:prstGeom prst="rect">
             <a:avLst/>
@@ -4072,7 +4447,7 @@
                   <a:schemeClr val="accent4"/>
                 </a:solidFill>
               </a:rPr>
-              <a:t>Enterprise GenAI stack review · October 2026 · Personal research, not a description of any firm's platform</a:t>
+              <a:t>Veyan · The Enterprise GenAI Stack · The view at end of Q3 2026 · Not a description of any firm's platform</a:t>
             </a:r>
             <a:endParaRPr lang="en-US" sz="900" dirty="0"/>
           </a:p>
@@ -4123,6 +4498,62 @@
           </a:p>
         </p:txBody>
       </p:sp>
+    </p:spTree>
+  </p:cSld>
+  <p:clrMapOvr>
+    <a:masterClrMapping/>
+  </p:clrMapOvr>
+</p:sldLayout>
+</file>
+
+<file path=ppt/slideLayouts/slideLayout5.xml><?xml version="1.0" encoding="utf-8"?>
+<p:sldLayout xmlns:a="http://schemas.openxmlformats.org/drawingml/2006/main" xmlns:r="http://schemas.openxmlformats.org/officeDocument/2006/relationships" xmlns:p="http://schemas.openxmlformats.org/presentationml/2006/main" preserve="1">
+  <p:cSld name="BRAND">
+    <p:bg>
+      <p:bgPr>
+        <a:solidFill>
+          <a:srgbClr val="0B1B33"/>
+        </a:solidFill>
+      </p:bgPr>
+    </p:bg>
+    <p:spTree>
+      <p:nvGrpSpPr>
+        <p:cNvPr id="1" name=""/>
+        <p:cNvGrpSpPr/>
+        <p:nvPr/>
+      </p:nvGrpSpPr>
+      <p:grpSpPr>
+        <a:xfrm>
+          <a:off x="0" y="0"/>
+          <a:ext cx="0" cy="0"/>
+          <a:chOff x="0" y="0"/>
+          <a:chExt cx="0" cy="0"/>
+        </a:xfrm>
+      </p:grpSpPr>
+      <p:pic>
+        <p:nvPicPr>
+          <p:cNvPr id="2" name="Image 0" descr="brand/veyan_brand_card.jpg">    </p:cNvPr>
+          <p:cNvPicPr>
+            <a:picLocks noChangeAspect="1"/>
+          </p:cNvPicPr>
+          <p:nvPr/>
+        </p:nvPicPr>
+        <p:blipFill>
+          <a:blip r:embed="rId1"/>
+          <a:stretch>
+            <a:fillRect/>
+          </a:stretch>
+        </p:blipFill>
+        <p:spPr>
+          <a:xfrm>
+            <a:off x="0" y="0"/>
+            <a:ext cx="12188952" cy="6858000"/>
+          </a:xfrm>
+          <a:prstGeom prst="rect">
+            <a:avLst/>
+          </a:prstGeom>
+        </p:spPr>
+      </p:pic>
     </p:spTree>
   </p:cSld>
   <p:clrMapOvr>
@@ -4201,6 +4632,7 @@
     <p:sldLayoutId id="2147483650" r:id="rId2"/>
     <p:sldLayoutId id="2147483651" r:id="rId3"/>
     <p:sldLayoutId id="2147483652" r:id="rId4"/>
+    <p:sldLayoutId id="2147483653" r:id="rId5"/>
   </p:sldLayoutIdLst>
   <p:hf sldNum="0" hdr="0" ftr="0" dt="0"/>
   <p:txStyles>
@@ -4475,16 +4907,16 @@
       </p:grpSpPr>
       <p:sp>
         <p:nvSpPr>
-          <p:cNvPr id="2" name="Text 0"/>
+          <p:cNvPr id="2" name="Text 2"/>
           <p:cNvSpPr/>
           <p:nvPr>
-            <p:ph idx="100" type="title" hasCustomPrompt="1"/>
+            <p:ph idx="104" type="title" hasCustomPrompt="1"/>
           </p:nvPr>
         </p:nvSpPr>
         <p:spPr>
           <a:xfrm>
-            <a:off x="731520" y="1920240"/>
-            <a:ext cx="10698480" cy="1463040"/>
+            <a:off x="5257800" y="2240280"/>
+            <a:ext cx="6400800" cy="1828800"/>
           </a:xfrm>
           <a:prstGeom prst="rect">
             <a:avLst/>
@@ -4493,39 +4925,75 @@
           <a:ln/>
         </p:spPr>
         <p:txBody>
-          <a:bodyPr wrap="square" rtlCol="0" anchor="b"/>
+          <a:bodyPr wrap="square" rtlCol="0" anchor="t"/>
+          <a:lstStyle/>
+          <a:p>
+            <a:pPr algn="l" indent="0" marL="0">
+              <a:buNone/>
+            </a:pPr>
+            <a:r>
+              <a:rPr lang="en-US" sz="3600" b="1" dirty="0">
+                <a:solidFill>
+                  <a:schemeClr val="bg1"/>
+                </a:solidFill>
+                <a:latin typeface="Arial" pitchFamily="34" charset="0"/>
+                <a:ea typeface="Arial" pitchFamily="34" charset="-122"/>
+                <a:cs typeface="Arial" pitchFamily="34" charset="-120"/>
+              </a:rPr>
+              <a:t>The Enterprise GenAI Stack</a:t>
+            </a:r>
+            <a:endParaRPr lang="en-US" sz="3600" dirty="0"/>
+          </a:p>
+        </p:txBody>
+      </p:sp>
+      <p:sp>
+        <p:nvSpPr>
+          <p:cNvPr id="3" name="Text 2"/>
+          <p:cNvSpPr/>
+          <p:nvPr>
+            <p:ph idx="105" type="body" hasCustomPrompt="1"/>
+          </p:nvPr>
+        </p:nvSpPr>
+        <p:spPr>
+          <a:xfrm>
+            <a:off x="5257800" y="4114800"/>
+            <a:ext cx="6400800" cy="1463040"/>
+          </a:xfrm>
+          <a:prstGeom prst="rect">
+            <a:avLst/>
+          </a:prstGeom>
+          <a:noFill/>
+          <a:ln/>
+        </p:spPr>
+        <p:txBody>
+          <a:bodyPr wrap="square" rtlCol="0" anchor="t"/>
           <a:lstStyle/>
           <a:p>
             <a:pPr indent="0" marL="0">
               <a:buNone/>
             </a:pPr>
             <a:r>
-              <a:rPr lang="en-US" sz="4000" b="1" dirty="0">
+              <a:rPr lang="en-US" sz="1600" dirty="0">
                 <a:solidFill>
-                  <a:schemeClr val="bg1"/>
+                  <a:schemeClr val="accent5"/>
                 </a:solidFill>
-                <a:latin typeface="Cambria" pitchFamily="34" charset="0"/>
-                <a:ea typeface="Cambria" pitchFamily="34" charset="-122"/>
-                <a:cs typeface="Cambria" pitchFamily="34" charset="-120"/>
               </a:rPr>
-              <a:t>The enterprise GenAI stack, October 2026</a:t>
+              <a:t>What changed since the popular stack diagram, what a regulated asset manager should select, and what to deliberately not build yet.</a:t>
             </a:r>
-            <a:endParaRPr lang="en-US" sz="4000" dirty="0"/>
-          </a:p>
-        </p:txBody>
-      </p:sp>
-      <p:sp>
-        <p:nvSpPr>
-          <p:cNvPr id="3" name="Text 0"/>
-          <p:cNvSpPr/>
-          <p:nvPr>
-            <p:ph idx="101" type="body" hasCustomPrompt="1"/>
-          </p:nvPr>
-        </p:nvSpPr>
-        <p:spPr>
-          <a:xfrm>
-            <a:off x="731520" y="3566160"/>
-            <a:ext cx="10698480" cy="1463040"/>
+            <a:endParaRPr lang="en-US" sz="1600" dirty="0"/>
+          </a:p>
+        </p:txBody>
+      </p:sp>
+      <p:sp>
+        <p:nvSpPr>
+          <p:cNvPr id="4" name="Text 2"/>
+          <p:cNvSpPr txBox="1"/>
+          <p:nvPr/>
+        </p:nvSpPr>
+        <p:spPr>
+          <a:xfrm>
+            <a:off x="5257800" y="5669280"/>
+            <a:ext cx="6400800" cy="365760"/>
           </a:xfrm>
           <a:prstGeom prst="rect">
             <a:avLst/>
@@ -4534,57 +5002,21 @@
           <a:ln/>
         </p:spPr>
         <p:txBody>
-          <a:bodyPr wrap="square" rtlCol="0" anchor="t"/>
+          <a:bodyPr wrap="square" lIns="635" tIns="635" rIns="635" bIns="635" rtlCol="0" anchor="t"/>
           <a:lstStyle/>
           <a:p>
             <a:pPr indent="0" marL="0">
               <a:buNone/>
             </a:pPr>
             <a:r>
-              <a:rPr lang="en-US" sz="1800" dirty="0">
-                <a:solidFill>
-                  <a:schemeClr val="bg2"/>
-                </a:solidFill>
-              </a:rPr>
-              <a:t>What changed since the popular stack diagram, what a regulated asset manager should select, and what to deliberately not build yet</a:t>
-            </a:r>
-            <a:endParaRPr lang="en-US" sz="1800" dirty="0"/>
-          </a:p>
-        </p:txBody>
-      </p:sp>
-      <p:sp>
-        <p:nvSpPr>
-          <p:cNvPr id="4" name="Text 2"/>
-          <p:cNvSpPr txBox="1"/>
-          <p:nvPr/>
-        </p:nvSpPr>
-        <p:spPr>
-          <a:xfrm>
-            <a:off x="731520" y="5760720"/>
-            <a:ext cx="10698480" cy="365760"/>
-          </a:xfrm>
-          <a:prstGeom prst="rect">
-            <a:avLst/>
-          </a:prstGeom>
-          <a:noFill/>
-          <a:ln/>
-        </p:spPr>
-        <p:txBody>
-          <a:bodyPr wrap="square" lIns="635" tIns="635" rIns="635" bIns="635" rtlCol="0" anchor="t"/>
-          <a:lstStyle/>
-          <a:p>
-            <a:pPr indent="0" marL="0">
-              <a:buNone/>
-            </a:pPr>
-            <a:r>
-              <a:rPr lang="en-US" sz="1200" dirty="0">
+              <a:rPr lang="en-US" sz="1100" dirty="0">
                 <a:solidFill>
                   <a:schemeClr val="accent5"/>
                 </a:solidFill>
               </a:rPr>
-              <a:t>Reference architecture review · 9 layers · 8 enterprise controls · 140 products · Personal research</a:t>
+              <a:t>Reference architecture · 9 layers · 8 enterprise controls · 140 products · 1,255 sources</a:t>
             </a:r>
-            <a:endParaRPr lang="en-US" sz="1200" dirty="0"/>
+            <a:endParaRPr lang="en-US" sz="1100" dirty="0"/>
           </a:p>
         </p:txBody>
       </p:sp>
@@ -4624,7 +5056,7 @@
         <p:spPr>
           <a:xfrm>
             <a:off x="548640" y="320040"/>
-            <a:ext cx="11064240" cy="822960"/>
+            <a:ext cx="9692640" cy="822960"/>
           </a:xfrm>
           <a:prstGeom prst="rect">
             <a:avLst/>
@@ -4636,21 +5068,21 @@
           <a:bodyPr wrap="square" rtlCol="0" anchor="ctr"/>
           <a:lstStyle/>
           <a:p>
-            <a:pPr indent="0" marL="0">
+            <a:pPr algn="l" indent="0" marL="0">
               <a:buNone/>
             </a:pPr>
             <a:r>
-              <a:rPr lang="en-US" sz="2800" b="1" dirty="0">
+              <a:rPr lang="en-US" sz="2600" b="1" dirty="0">
                 <a:solidFill>
                   <a:schemeClr val="tx2"/>
                 </a:solidFill>
-                <a:latin typeface="Cambria" pitchFamily="34" charset="0"/>
-                <a:ea typeface="Cambria" pitchFamily="34" charset="-122"/>
-                <a:cs typeface="Cambria" pitchFamily="34" charset="-120"/>
+                <a:latin typeface="Arial" pitchFamily="34" charset="0"/>
+                <a:ea typeface="Arial" pitchFamily="34" charset="-122"/>
+                <a:cs typeface="Arial" pitchFamily="34" charset="-120"/>
               </a:rPr>
               <a:t>Twelve decisions that define the architecture</a:t>
             </a:r>
-            <a:endParaRPr lang="en-US" sz="2800" dirty="0"/>
+            <a:endParaRPr lang="en-US" sz="2600" dirty="0"/>
           </a:p>
         </p:txBody>
       </p:sp>
@@ -5890,16 +6322,57 @@
       </p:grpSpPr>
       <p:sp>
         <p:nvSpPr>
-          <p:cNvPr id="2" name="Text 0"/>
+          <p:cNvPr id="2" name="Text 1"/>
           <p:cNvSpPr/>
           <p:nvPr>
-            <p:ph idx="100" type="title" hasCustomPrompt="1"/>
+            <p:ph idx="103" type="title" hasCustomPrompt="1"/>
           </p:nvPr>
         </p:nvSpPr>
         <p:spPr>
           <a:xfrm>
-            <a:off x="731520" y="2377440"/>
-            <a:ext cx="10698480" cy="1097280"/>
+            <a:off x="731520" y="2331720"/>
+            <a:ext cx="7315200" cy="1097280"/>
+          </a:xfrm>
+          <a:prstGeom prst="rect">
+            <a:avLst/>
+          </a:prstGeom>
+          <a:noFill/>
+          <a:ln/>
+        </p:spPr>
+        <p:txBody>
+          <a:bodyPr wrap="square" rtlCol="0" anchor="b"/>
+          <a:lstStyle/>
+          <a:p>
+            <a:pPr algn="l" indent="0" marL="0">
+              <a:buNone/>
+            </a:pPr>
+            <a:r>
+              <a:rPr lang="en-US" sz="3400" b="1" dirty="0">
+                <a:solidFill>
+                  <a:schemeClr val="bg1"/>
+                </a:solidFill>
+                <a:latin typeface="Arial" pitchFamily="34" charset="0"/>
+                <a:ea typeface="Arial" pitchFamily="34" charset="-122"/>
+                <a:cs typeface="Arial" pitchFamily="34" charset="-120"/>
+              </a:rPr>
+              <a:t>What to select</a:t>
+            </a:r>
+            <a:endParaRPr lang="en-US" sz="3400" dirty="0"/>
+          </a:p>
+        </p:txBody>
+      </p:sp>
+      <p:sp>
+        <p:nvSpPr>
+          <p:cNvPr id="3" name="Text 1"/>
+          <p:cNvSpPr/>
+          <p:nvPr>
+            <p:ph idx="104" type="body" hasCustomPrompt="1"/>
+          </p:nvPr>
+        </p:nvSpPr>
+        <p:spPr>
+          <a:xfrm>
+            <a:off x="731520" y="3703320"/>
+            <a:ext cx="7315200" cy="1097280"/>
           </a:xfrm>
           <a:prstGeom prst="rect">
             <a:avLst/>
@@ -5915,55 +6388,14 @@
               <a:buNone/>
             </a:pPr>
             <a:r>
-              <a:rPr lang="en-US" sz="3600" b="1" dirty="0">
-                <a:solidFill>
-                  <a:schemeClr val="bg1"/>
-                </a:solidFill>
-                <a:latin typeface="Cambria" pitchFamily="34" charset="0"/>
-                <a:ea typeface="Cambria" pitchFamily="34" charset="-122"/>
-                <a:cs typeface="Cambria" pitchFamily="34" charset="-120"/>
-              </a:rPr>
-              <a:t>What to select</a:t>
-            </a:r>
-            <a:endParaRPr lang="en-US" sz="3600" dirty="0"/>
-          </a:p>
-        </p:txBody>
-      </p:sp>
-      <p:sp>
-        <p:nvSpPr>
-          <p:cNvPr id="3" name="Text 0"/>
-          <p:cNvSpPr/>
-          <p:nvPr>
-            <p:ph idx="101" type="body" hasCustomPrompt="1"/>
-          </p:nvPr>
-        </p:nvSpPr>
-        <p:spPr>
-          <a:xfrm>
-            <a:off x="731520" y="3566160"/>
-            <a:ext cx="10698480" cy="914400"/>
-          </a:xfrm>
-          <a:prstGeom prst="rect">
-            <a:avLst/>
-          </a:prstGeom>
-          <a:noFill/>
-          <a:ln/>
-        </p:spPr>
-        <p:txBody>
-          <a:bodyPr wrap="square" rtlCol="0"/>
-          <a:lstStyle/>
-          <a:p>
-            <a:pPr indent="0" marL="0">
-              <a:buNone/>
-            </a:pPr>
-            <a:r>
-              <a:rPr lang="en-US" sz="1800" dirty="0">
+              <a:rPr lang="en-US" sz="1700" dirty="0">
                 <a:solidFill>
                   <a:schemeClr val="accent5"/>
                 </a:solidFill>
               </a:rPr>
               <a:t>138 products scored on eight criteria · 58 Strategic · 67 Tactical · 13 Experimental</a:t>
             </a:r>
-            <a:endParaRPr lang="en-US" sz="1800" dirty="0"/>
+            <a:endParaRPr lang="en-US" sz="1700" dirty="0"/>
           </a:p>
         </p:txBody>
       </p:sp>
@@ -6003,7 +6435,7 @@
         <p:spPr>
           <a:xfrm>
             <a:off x="548640" y="320040"/>
-            <a:ext cx="11064240" cy="822960"/>
+            <a:ext cx="9692640" cy="822960"/>
           </a:xfrm>
           <a:prstGeom prst="rect">
             <a:avLst/>
@@ -6015,21 +6447,21 @@
           <a:bodyPr wrap="square" rtlCol="0" anchor="ctr"/>
           <a:lstStyle/>
           <a:p>
-            <a:pPr indent="0" marL="0">
+            <a:pPr algn="l" indent="0" marL="0">
               <a:buNone/>
             </a:pPr>
             <a:r>
-              <a:rPr lang="en-US" sz="2800" b="1" dirty="0">
+              <a:rPr lang="en-US" sz="2600" b="1" dirty="0">
                 <a:solidFill>
                   <a:schemeClr val="tx2"/>
                 </a:solidFill>
-                <a:latin typeface="Cambria" pitchFamily="34" charset="0"/>
-                <a:ea typeface="Cambria" pitchFamily="34" charset="-122"/>
-                <a:cs typeface="Cambria" pitchFamily="34" charset="-120"/>
+                <a:latin typeface="Arial" pitchFamily="34" charset="0"/>
+                <a:ea typeface="Arial" pitchFamily="34" charset="-122"/>
+                <a:cs typeface="Arial" pitchFamily="34" charset="-120"/>
               </a:rPr>
               <a:t>Where the Strategic choices are</a:t>
             </a:r>
-            <a:endParaRPr lang="en-US" sz="2800" dirty="0"/>
+            <a:endParaRPr lang="en-US" sz="2600" dirty="0"/>
           </a:p>
         </p:txBody>
       </p:sp>
@@ -6328,7 +6760,7 @@
         <p:spPr>
           <a:xfrm>
             <a:off x="548640" y="320040"/>
-            <a:ext cx="11064240" cy="822960"/>
+            <a:ext cx="9692640" cy="822960"/>
           </a:xfrm>
           <a:prstGeom prst="rect">
             <a:avLst/>
@@ -6340,21 +6772,21 @@
           <a:bodyPr wrap="square" rtlCol="0" anchor="ctr"/>
           <a:lstStyle/>
           <a:p>
-            <a:pPr indent="0" marL="0">
+            <a:pPr algn="l" indent="0" marL="0">
               <a:buNone/>
             </a:pPr>
             <a:r>
-              <a:rPr lang="en-US" sz="2800" b="1" dirty="0">
+              <a:rPr lang="en-US" sz="2600" b="1" dirty="0">
                 <a:solidFill>
                   <a:schemeClr val="tx2"/>
                 </a:solidFill>
-                <a:latin typeface="Cambria" pitchFamily="34" charset="0"/>
-                <a:ea typeface="Cambria" pitchFamily="34" charset="-122"/>
-                <a:cs typeface="Cambria" pitchFamily="34" charset="-120"/>
+                <a:latin typeface="Arial" pitchFamily="34" charset="0"/>
+                <a:ea typeface="Arial" pitchFamily="34" charset="-122"/>
+                <a:cs typeface="Arial" pitchFamily="34" charset="-120"/>
               </a:rPr>
               <a:t>The cloud-neutral core we would select today</a:t>
             </a:r>
-            <a:endParaRPr lang="en-US" sz="2800" dirty="0"/>
+            <a:endParaRPr lang="en-US" sz="2600" dirty="0"/>
           </a:p>
         </p:txBody>
       </p:sp>
@@ -6450,7 +6882,7 @@
                       <a:tailEnd type="none" w="med" len="med"/>
                     </a:lnB>
                     <a:solidFill>
-                      <a:srgbClr val="1B2A41"/>
+                      <a:srgbClr val="0B1B33"/>
                     </a:solidFill>
                   </a:tcPr>
                 </a:tc>
@@ -6518,7 +6950,7 @@
                       <a:tailEnd type="none" w="med" len="med"/>
                     </a:lnB>
                     <a:solidFill>
-                      <a:srgbClr val="1B2A41"/>
+                      <a:srgbClr val="0B1B33"/>
                     </a:solidFill>
                   </a:tcPr>
                 </a:tc>
@@ -6586,7 +7018,7 @@
                       <a:tailEnd type="none" w="med" len="med"/>
                     </a:lnB>
                     <a:solidFill>
-                      <a:srgbClr val="1B2A41"/>
+                      <a:srgbClr val="0B1B33"/>
                     </a:solidFill>
                   </a:tcPr>
                 </a:tc>
@@ -6603,7 +7035,7 @@
                       <a:r>
                         <a:rPr lang="en-US" sz="1400" dirty="0">
                           <a:solidFill>
-                            <a:srgbClr val="16202E"/>
+                            <a:srgbClr val="0B1B33"/>
                           </a:solidFill>
                           <a:latin typeface="Calibri" pitchFamily="34" charset="0"/>
                           <a:ea typeface="Calibri" pitchFamily="34" charset="-122"/>
@@ -6656,7 +7088,7 @@
                       <a:tailEnd type="none" w="med" len="med"/>
                     </a:lnB>
                     <a:solidFill>
-                      <a:srgbClr val="EEF2F5"/>
+                      <a:srgbClr val="EEF3F8"/>
                     </a:solidFill>
                   </a:tcPr>
                 </a:tc>
@@ -6671,7 +7103,7 @@
                       <a:r>
                         <a:rPr lang="en-US" sz="1400" dirty="0">
                           <a:solidFill>
-                            <a:srgbClr val="16202E"/>
+                            <a:srgbClr val="0B1B33"/>
                           </a:solidFill>
                           <a:latin typeface="Calibri" pitchFamily="34" charset="0"/>
                           <a:ea typeface="Calibri" pitchFamily="34" charset="-122"/>
@@ -6724,7 +7156,7 @@
                       <a:tailEnd type="none" w="med" len="med"/>
                     </a:lnB>
                     <a:solidFill>
-                      <a:srgbClr val="EEF2F5"/>
+                      <a:srgbClr val="EEF3F8"/>
                     </a:solidFill>
                   </a:tcPr>
                 </a:tc>
@@ -6739,7 +7171,7 @@
                       <a:r>
                         <a:rPr lang="en-US" sz="1400" dirty="0">
                           <a:solidFill>
-                            <a:srgbClr val="16202E"/>
+                            <a:srgbClr val="0B1B33"/>
                           </a:solidFill>
                           <a:latin typeface="Calibri" pitchFamily="34" charset="0"/>
                           <a:ea typeface="Calibri" pitchFamily="34" charset="-122"/>
@@ -6792,7 +7224,7 @@
                       <a:tailEnd type="none" w="med" len="med"/>
                     </a:lnB>
                     <a:solidFill>
-                      <a:srgbClr val="EEF2F5"/>
+                      <a:srgbClr val="EEF3F8"/>
                     </a:solidFill>
                   </a:tcPr>
                 </a:tc>
@@ -6809,7 +7241,7 @@
                       <a:r>
                         <a:rPr lang="en-US" sz="1400" dirty="0">
                           <a:solidFill>
-                            <a:srgbClr val="16202E"/>
+                            <a:srgbClr val="0B1B33"/>
                           </a:solidFill>
                           <a:latin typeface="Calibri" pitchFamily="34" charset="0"/>
                           <a:ea typeface="Calibri" pitchFamily="34" charset="-122"/>
@@ -6877,7 +7309,7 @@
                       <a:r>
                         <a:rPr lang="en-US" sz="1400" dirty="0">
                           <a:solidFill>
-                            <a:srgbClr val="16202E"/>
+                            <a:srgbClr val="0B1B33"/>
                           </a:solidFill>
                           <a:latin typeface="Calibri" pitchFamily="34" charset="0"/>
                           <a:ea typeface="Calibri" pitchFamily="34" charset="-122"/>
@@ -6945,7 +7377,7 @@
                       <a:r>
                         <a:rPr lang="en-US" sz="1400" dirty="0">
                           <a:solidFill>
-                            <a:srgbClr val="16202E"/>
+                            <a:srgbClr val="0B1B33"/>
                           </a:solidFill>
                           <a:latin typeface="Calibri" pitchFamily="34" charset="0"/>
                           <a:ea typeface="Calibri" pitchFamily="34" charset="-122"/>
@@ -7015,7 +7447,7 @@
                       <a:r>
                         <a:rPr lang="en-US" sz="1400" dirty="0">
                           <a:solidFill>
-                            <a:srgbClr val="16202E"/>
+                            <a:srgbClr val="0B1B33"/>
                           </a:solidFill>
                           <a:latin typeface="Calibri" pitchFamily="34" charset="0"/>
                           <a:ea typeface="Calibri" pitchFamily="34" charset="-122"/>
@@ -7068,7 +7500,7 @@
                       <a:tailEnd type="none" w="med" len="med"/>
                     </a:lnB>
                     <a:solidFill>
-                      <a:srgbClr val="EEF2F5"/>
+                      <a:srgbClr val="EEF3F8"/>
                     </a:solidFill>
                   </a:tcPr>
                 </a:tc>
@@ -7083,7 +7515,7 @@
                       <a:r>
                         <a:rPr lang="en-US" sz="1400" dirty="0">
                           <a:solidFill>
-                            <a:srgbClr val="16202E"/>
+                            <a:srgbClr val="0B1B33"/>
                           </a:solidFill>
                           <a:latin typeface="Calibri" pitchFamily="34" charset="0"/>
                           <a:ea typeface="Calibri" pitchFamily="34" charset="-122"/>
@@ -7136,7 +7568,7 @@
                       <a:tailEnd type="none" w="med" len="med"/>
                     </a:lnB>
                     <a:solidFill>
-                      <a:srgbClr val="EEF2F5"/>
+                      <a:srgbClr val="EEF3F8"/>
                     </a:solidFill>
                   </a:tcPr>
                 </a:tc>
@@ -7151,7 +7583,7 @@
                       <a:r>
                         <a:rPr lang="en-US" sz="1400" dirty="0">
                           <a:solidFill>
-                            <a:srgbClr val="16202E"/>
+                            <a:srgbClr val="0B1B33"/>
                           </a:solidFill>
                           <a:latin typeface="Calibri" pitchFamily="34" charset="0"/>
                           <a:ea typeface="Calibri" pitchFamily="34" charset="-122"/>
@@ -7204,7 +7636,7 @@
                       <a:tailEnd type="none" w="med" len="med"/>
                     </a:lnB>
                     <a:solidFill>
-                      <a:srgbClr val="EEF2F5"/>
+                      <a:srgbClr val="EEF3F8"/>
                     </a:solidFill>
                   </a:tcPr>
                 </a:tc>
@@ -7221,7 +7653,7 @@
                       <a:r>
                         <a:rPr lang="en-US" sz="1400" dirty="0">
                           <a:solidFill>
-                            <a:srgbClr val="16202E"/>
+                            <a:srgbClr val="0B1B33"/>
                           </a:solidFill>
                           <a:latin typeface="Calibri" pitchFamily="34" charset="0"/>
                           <a:ea typeface="Calibri" pitchFamily="34" charset="-122"/>
@@ -7289,7 +7721,7 @@
                       <a:r>
                         <a:rPr lang="en-US" sz="1400" dirty="0">
                           <a:solidFill>
-                            <a:srgbClr val="16202E"/>
+                            <a:srgbClr val="0B1B33"/>
                           </a:solidFill>
                           <a:latin typeface="Calibri" pitchFamily="34" charset="0"/>
                           <a:ea typeface="Calibri" pitchFamily="34" charset="-122"/>
@@ -7357,7 +7789,7 @@
                       <a:r>
                         <a:rPr lang="en-US" sz="1400" dirty="0">
                           <a:solidFill>
-                            <a:srgbClr val="16202E"/>
+                            <a:srgbClr val="0B1B33"/>
                           </a:solidFill>
                           <a:latin typeface="Calibri" pitchFamily="34" charset="0"/>
                           <a:ea typeface="Calibri" pitchFamily="34" charset="-122"/>
@@ -7427,7 +7859,7 @@
                       <a:r>
                         <a:rPr lang="en-US" sz="1400" dirty="0">
                           <a:solidFill>
-                            <a:srgbClr val="16202E"/>
+                            <a:srgbClr val="0B1B33"/>
                           </a:solidFill>
                           <a:latin typeface="Calibri" pitchFamily="34" charset="0"/>
                           <a:ea typeface="Calibri" pitchFamily="34" charset="-122"/>
@@ -7480,7 +7912,7 @@
                       <a:tailEnd type="none" w="med" len="med"/>
                     </a:lnB>
                     <a:solidFill>
-                      <a:srgbClr val="EEF2F5"/>
+                      <a:srgbClr val="EEF3F8"/>
                     </a:solidFill>
                   </a:tcPr>
                 </a:tc>
@@ -7495,7 +7927,7 @@
                       <a:r>
                         <a:rPr lang="en-US" sz="1400" dirty="0">
                           <a:solidFill>
-                            <a:srgbClr val="16202E"/>
+                            <a:srgbClr val="0B1B33"/>
                           </a:solidFill>
                           <a:latin typeface="Calibri" pitchFamily="34" charset="0"/>
                           <a:ea typeface="Calibri" pitchFamily="34" charset="-122"/>
@@ -7548,7 +7980,7 @@
                       <a:tailEnd type="none" w="med" len="med"/>
                     </a:lnB>
                     <a:solidFill>
-                      <a:srgbClr val="EEF2F5"/>
+                      <a:srgbClr val="EEF3F8"/>
                     </a:solidFill>
                   </a:tcPr>
                 </a:tc>
@@ -7563,7 +7995,7 @@
                       <a:r>
                         <a:rPr lang="en-US" sz="1400" dirty="0">
                           <a:solidFill>
-                            <a:srgbClr val="16202E"/>
+                            <a:srgbClr val="0B1B33"/>
                           </a:solidFill>
                           <a:latin typeface="Calibri" pitchFamily="34" charset="0"/>
                           <a:ea typeface="Calibri" pitchFamily="34" charset="-122"/>
@@ -7616,7 +8048,7 @@
                       <a:tailEnd type="none" w="med" len="med"/>
                     </a:lnB>
                     <a:solidFill>
-                      <a:srgbClr val="EEF2F5"/>
+                      <a:srgbClr val="EEF3F8"/>
                     </a:solidFill>
                   </a:tcPr>
                 </a:tc>
@@ -7633,7 +8065,7 @@
                       <a:r>
                         <a:rPr lang="en-US" sz="1400" dirty="0">
                           <a:solidFill>
-                            <a:srgbClr val="16202E"/>
+                            <a:srgbClr val="0B1B33"/>
                           </a:solidFill>
                           <a:latin typeface="Calibri" pitchFamily="34" charset="0"/>
                           <a:ea typeface="Calibri" pitchFamily="34" charset="-122"/>
@@ -7701,7 +8133,7 @@
                       <a:r>
                         <a:rPr lang="en-US" sz="1400" dirty="0">
                           <a:solidFill>
-                            <a:srgbClr val="16202E"/>
+                            <a:srgbClr val="0B1B33"/>
                           </a:solidFill>
                           <a:latin typeface="Calibri" pitchFamily="34" charset="0"/>
                           <a:ea typeface="Calibri" pitchFamily="34" charset="-122"/>
@@ -7769,7 +8201,7 @@
                       <a:r>
                         <a:rPr lang="en-US" sz="1400" dirty="0">
                           <a:solidFill>
-                            <a:srgbClr val="16202E"/>
+                            <a:srgbClr val="0B1B33"/>
                           </a:solidFill>
                           <a:latin typeface="Calibri" pitchFamily="34" charset="0"/>
                           <a:ea typeface="Calibri" pitchFamily="34" charset="-122"/>
@@ -7839,7 +8271,7 @@
                       <a:r>
                         <a:rPr lang="en-US" sz="1400" dirty="0">
                           <a:solidFill>
-                            <a:srgbClr val="16202E"/>
+                            <a:srgbClr val="0B1B33"/>
                           </a:solidFill>
                           <a:latin typeface="Calibri" pitchFamily="34" charset="0"/>
                           <a:ea typeface="Calibri" pitchFamily="34" charset="-122"/>
@@ -7892,7 +8324,7 @@
                       <a:tailEnd type="none" w="med" len="med"/>
                     </a:lnB>
                     <a:solidFill>
-                      <a:srgbClr val="EEF2F5"/>
+                      <a:srgbClr val="EEF3F8"/>
                     </a:solidFill>
                   </a:tcPr>
                 </a:tc>
@@ -7907,7 +8339,7 @@
                       <a:r>
                         <a:rPr lang="en-US" sz="1400" dirty="0">
                           <a:solidFill>
-                            <a:srgbClr val="16202E"/>
+                            <a:srgbClr val="0B1B33"/>
                           </a:solidFill>
                           <a:latin typeface="Calibri" pitchFamily="34" charset="0"/>
                           <a:ea typeface="Calibri" pitchFamily="34" charset="-122"/>
@@ -7960,7 +8392,7 @@
                       <a:tailEnd type="none" w="med" len="med"/>
                     </a:lnB>
                     <a:solidFill>
-                      <a:srgbClr val="EEF2F5"/>
+                      <a:srgbClr val="EEF3F8"/>
                     </a:solidFill>
                   </a:tcPr>
                 </a:tc>
@@ -7975,7 +8407,7 @@
                       <a:r>
                         <a:rPr lang="en-US" sz="1400" dirty="0">
                           <a:solidFill>
-                            <a:srgbClr val="16202E"/>
+                            <a:srgbClr val="0B1B33"/>
                           </a:solidFill>
                           <a:latin typeface="Calibri" pitchFamily="34" charset="0"/>
                           <a:ea typeface="Calibri" pitchFamily="34" charset="-122"/>
@@ -8028,7 +8460,7 @@
                       <a:tailEnd type="none" w="med" len="med"/>
                     </a:lnB>
                     <a:solidFill>
-                      <a:srgbClr val="EEF2F5"/>
+                      <a:srgbClr val="EEF3F8"/>
                     </a:solidFill>
                   </a:tcPr>
                 </a:tc>
@@ -8045,7 +8477,7 @@
                       <a:r>
                         <a:rPr lang="en-US" sz="1400" dirty="0">
                           <a:solidFill>
-                            <a:srgbClr val="16202E"/>
+                            <a:srgbClr val="0B1B33"/>
                           </a:solidFill>
                           <a:latin typeface="Calibri" pitchFamily="34" charset="0"/>
                           <a:ea typeface="Calibri" pitchFamily="34" charset="-122"/>
@@ -8113,7 +8545,7 @@
                       <a:r>
                         <a:rPr lang="en-US" sz="1400" dirty="0">
                           <a:solidFill>
-                            <a:srgbClr val="16202E"/>
+                            <a:srgbClr val="0B1B33"/>
                           </a:solidFill>
                           <a:latin typeface="Calibri" pitchFamily="34" charset="0"/>
                           <a:ea typeface="Calibri" pitchFamily="34" charset="-122"/>
@@ -8181,7 +8613,7 @@
                       <a:r>
                         <a:rPr lang="en-US" sz="1400" dirty="0">
                           <a:solidFill>
-                            <a:srgbClr val="16202E"/>
+                            <a:srgbClr val="0B1B33"/>
                           </a:solidFill>
                           <a:latin typeface="Calibri" pitchFamily="34" charset="0"/>
                           <a:ea typeface="Calibri" pitchFamily="34" charset="-122"/>
@@ -8251,7 +8683,7 @@
                       <a:r>
                         <a:rPr lang="en-US" sz="1400" dirty="0">
                           <a:solidFill>
-                            <a:srgbClr val="16202E"/>
+                            <a:srgbClr val="0B1B33"/>
                           </a:solidFill>
                           <a:latin typeface="Calibri" pitchFamily="34" charset="0"/>
                           <a:ea typeface="Calibri" pitchFamily="34" charset="-122"/>
@@ -8304,7 +8736,7 @@
                       <a:tailEnd type="none" w="med" len="med"/>
                     </a:lnB>
                     <a:solidFill>
-                      <a:srgbClr val="EEF2F5"/>
+                      <a:srgbClr val="EEF3F8"/>
                     </a:solidFill>
                   </a:tcPr>
                 </a:tc>
@@ -8319,7 +8751,7 @@
                       <a:r>
                         <a:rPr lang="en-US" sz="1400" dirty="0">
                           <a:solidFill>
-                            <a:srgbClr val="16202E"/>
+                            <a:srgbClr val="0B1B33"/>
                           </a:solidFill>
                           <a:latin typeface="Calibri" pitchFamily="34" charset="0"/>
                           <a:ea typeface="Calibri" pitchFamily="34" charset="-122"/>
@@ -8372,7 +8804,7 @@
                       <a:tailEnd type="none" w="med" len="med"/>
                     </a:lnB>
                     <a:solidFill>
-                      <a:srgbClr val="EEF2F5"/>
+                      <a:srgbClr val="EEF3F8"/>
                     </a:solidFill>
                   </a:tcPr>
                 </a:tc>
@@ -8387,7 +8819,7 @@
                       <a:r>
                         <a:rPr lang="en-US" sz="1400" dirty="0">
                           <a:solidFill>
-                            <a:srgbClr val="16202E"/>
+                            <a:srgbClr val="0B1B33"/>
                           </a:solidFill>
                           <a:latin typeface="Calibri" pitchFamily="34" charset="0"/>
                           <a:ea typeface="Calibri" pitchFamily="34" charset="-122"/>
@@ -8440,7 +8872,7 @@
                       <a:tailEnd type="none" w="med" len="med"/>
                     </a:lnB>
                     <a:solidFill>
-                      <a:srgbClr val="EEF2F5"/>
+                      <a:srgbClr val="EEF3F8"/>
                     </a:solidFill>
                   </a:tcPr>
                 </a:tc>
@@ -8457,7 +8889,7 @@
                       <a:r>
                         <a:rPr lang="en-US" sz="1400" dirty="0">
                           <a:solidFill>
-                            <a:srgbClr val="16202E"/>
+                            <a:srgbClr val="0B1B33"/>
                           </a:solidFill>
                           <a:latin typeface="Calibri" pitchFamily="34" charset="0"/>
                           <a:ea typeface="Calibri" pitchFamily="34" charset="-122"/>
@@ -8525,7 +8957,7 @@
                       <a:r>
                         <a:rPr lang="en-US" sz="1400" dirty="0">
                           <a:solidFill>
-                            <a:srgbClr val="16202E"/>
+                            <a:srgbClr val="0B1B33"/>
                           </a:solidFill>
                           <a:latin typeface="Calibri" pitchFamily="34" charset="0"/>
                           <a:ea typeface="Calibri" pitchFamily="34" charset="-122"/>
@@ -8593,7 +9025,7 @@
                       <a:r>
                         <a:rPr lang="en-US" sz="1400" dirty="0">
                           <a:solidFill>
-                            <a:srgbClr val="16202E"/>
+                            <a:srgbClr val="0B1B33"/>
                           </a:solidFill>
                           <a:latin typeface="Calibri" pitchFamily="34" charset="0"/>
                           <a:ea typeface="Calibri" pitchFamily="34" charset="-122"/>
@@ -8736,7 +9168,7 @@
         <p:spPr>
           <a:xfrm>
             <a:off x="548640" y="320040"/>
-            <a:ext cx="11064240" cy="822960"/>
+            <a:ext cx="9692640" cy="822960"/>
           </a:xfrm>
           <a:prstGeom prst="rect">
             <a:avLst/>
@@ -8748,21 +9180,21 @@
           <a:bodyPr wrap="square" rtlCol="0" anchor="ctr"/>
           <a:lstStyle/>
           <a:p>
-            <a:pPr indent="0" marL="0">
+            <a:pPr algn="l" indent="0" marL="0">
               <a:buNone/>
             </a:pPr>
             <a:r>
-              <a:rPr lang="en-US" sz="2800" b="1" dirty="0">
+              <a:rPr lang="en-US" sz="2600" b="1" dirty="0">
                 <a:solidFill>
                   <a:schemeClr val="tx2"/>
                 </a:solidFill>
-                <a:latin typeface="Cambria" pitchFamily="34" charset="0"/>
-                <a:ea typeface="Cambria" pitchFamily="34" charset="-122"/>
-                <a:cs typeface="Cambria" pitchFamily="34" charset="-120"/>
+                <a:latin typeface="Arial" pitchFamily="34" charset="0"/>
+                <a:ea typeface="Arial" pitchFamily="34" charset="-122"/>
+                <a:cs typeface="Arial" pitchFamily="34" charset="-120"/>
               </a:rPr>
               <a:t>Treat models as a portfolio, not a bet</a:t>
             </a:r>
-            <a:endParaRPr lang="en-US" sz="2800" dirty="0"/>
+            <a:endParaRPr lang="en-US" sz="2600" dirty="0"/>
           </a:p>
         </p:txBody>
       </p:sp>
@@ -9319,7 +9751,7 @@
         <p:spPr>
           <a:xfrm>
             <a:off x="548640" y="320040"/>
-            <a:ext cx="11064240" cy="822960"/>
+            <a:ext cx="9692640" cy="822960"/>
           </a:xfrm>
           <a:prstGeom prst="rect">
             <a:avLst/>
@@ -9331,21 +9763,21 @@
           <a:bodyPr wrap="square" rtlCol="0" anchor="ctr"/>
           <a:lstStyle/>
           <a:p>
-            <a:pPr indent="0" marL="0">
+            <a:pPr algn="l" indent="0" marL="0">
               <a:buNone/>
             </a:pPr>
             <a:r>
-              <a:rPr lang="en-US" sz="2800" b="1" dirty="0">
+              <a:rPr lang="en-US" sz="2600" b="1" dirty="0">
                 <a:solidFill>
                   <a:schemeClr val="tx2"/>
                 </a:solidFill>
-                <a:latin typeface="Cambria" pitchFamily="34" charset="0"/>
-                <a:ea typeface="Cambria" pitchFamily="34" charset="-122"/>
-                <a:cs typeface="Cambria" pitchFamily="34" charset="-120"/>
+                <a:latin typeface="Arial" pitchFamily="34" charset="0"/>
+                <a:ea typeface="Arial" pitchFamily="34" charset="-122"/>
+                <a:cs typeface="Arial" pitchFamily="34" charset="-120"/>
               </a:rPr>
-              <a:t>Keep, remove, add</a:t>
+              <a:t>Keep, remove, add: against the popular stack diagram</a:t>
             </a:r>
-            <a:endParaRPr lang="en-US" sz="2800" dirty="0"/>
+            <a:endParaRPr lang="en-US" sz="2600" dirty="0"/>
           </a:p>
         </p:txBody>
       </p:sp>
@@ -9727,7 +10159,7 @@
         <p:spPr>
           <a:xfrm>
             <a:off x="548640" y="320040"/>
-            <a:ext cx="11064240" cy="822960"/>
+            <a:ext cx="9692640" cy="822960"/>
           </a:xfrm>
           <a:prstGeom prst="rect">
             <a:avLst/>
@@ -9739,21 +10171,21 @@
           <a:bodyPr wrap="square" rtlCol="0" anchor="ctr"/>
           <a:lstStyle/>
           <a:p>
-            <a:pPr indent="0" marL="0">
+            <a:pPr algn="l" indent="0" marL="0">
               <a:buNone/>
             </a:pPr>
             <a:r>
-              <a:rPr lang="en-US" sz="2800" b="1" dirty="0">
+              <a:rPr lang="en-US" sz="2600" b="1" dirty="0">
                 <a:solidFill>
                   <a:schemeClr val="tx2"/>
                 </a:solidFill>
-                <a:latin typeface="Cambria" pitchFamily="34" charset="0"/>
-                <a:ea typeface="Cambria" pitchFamily="34" charset="-122"/>
-                <a:cs typeface="Cambria" pitchFamily="34" charset="-120"/>
+                <a:latin typeface="Arial" pitchFamily="34" charset="0"/>
+                <a:ea typeface="Arial" pitchFamily="34" charset="-122"/>
+                <a:cs typeface="Arial" pitchFamily="34" charset="-120"/>
               </a:rPr>
               <a:t>Deliberately not selected, on evidence</a:t>
             </a:r>
-            <a:endParaRPr lang="en-US" sz="2800" dirty="0"/>
+            <a:endParaRPr lang="en-US" sz="2600" dirty="0"/>
           </a:p>
         </p:txBody>
       </p:sp>
@@ -9848,7 +10280,7 @@
                       <a:tailEnd type="none" w="med" len="med"/>
                     </a:lnB>
                     <a:solidFill>
-                      <a:srgbClr val="1B2A41"/>
+                      <a:srgbClr val="0B1B33"/>
                     </a:solidFill>
                   </a:tcPr>
                 </a:tc>
@@ -9916,7 +10348,7 @@
                       <a:tailEnd type="none" w="med" len="med"/>
                     </a:lnB>
                     <a:solidFill>
-                      <a:srgbClr val="1B2A41"/>
+                      <a:srgbClr val="0B1B33"/>
                     </a:solidFill>
                   </a:tcPr>
                 </a:tc>
@@ -9933,7 +10365,7 @@
                       <a:r>
                         <a:rPr lang="en-US" sz="1500" dirty="0">
                           <a:solidFill>
-                            <a:srgbClr val="16202E"/>
+                            <a:srgbClr val="0B1B33"/>
                           </a:solidFill>
                           <a:latin typeface="Calibri" pitchFamily="34" charset="0"/>
                           <a:ea typeface="Calibri" pitchFamily="34" charset="-122"/>
@@ -9986,7 +10418,7 @@
                       <a:tailEnd type="none" w="med" len="med"/>
                     </a:lnB>
                     <a:solidFill>
-                      <a:srgbClr val="EEF2F5"/>
+                      <a:srgbClr val="EEF3F8"/>
                     </a:solidFill>
                   </a:tcPr>
                 </a:tc>
@@ -10001,7 +10433,7 @@
                       <a:r>
                         <a:rPr lang="en-US" sz="1500" dirty="0">
                           <a:solidFill>
-                            <a:srgbClr val="16202E"/>
+                            <a:srgbClr val="0B1B33"/>
                           </a:solidFill>
                           <a:latin typeface="Calibri" pitchFamily="34" charset="0"/>
                           <a:ea typeface="Calibri" pitchFamily="34" charset="-122"/>
@@ -10054,7 +10486,7 @@
                       <a:tailEnd type="none" w="med" len="med"/>
                     </a:lnB>
                     <a:solidFill>
-                      <a:srgbClr val="EEF2F5"/>
+                      <a:srgbClr val="EEF3F8"/>
                     </a:solidFill>
                   </a:tcPr>
                 </a:tc>
@@ -10071,7 +10503,7 @@
                       <a:r>
                         <a:rPr lang="en-US" sz="1500" dirty="0">
                           <a:solidFill>
-                            <a:srgbClr val="16202E"/>
+                            <a:srgbClr val="0B1B33"/>
                           </a:solidFill>
                           <a:latin typeface="Calibri" pitchFamily="34" charset="0"/>
                           <a:ea typeface="Calibri" pitchFamily="34" charset="-122"/>
@@ -10139,7 +10571,7 @@
                       <a:r>
                         <a:rPr lang="en-US" sz="1500" dirty="0">
                           <a:solidFill>
-                            <a:srgbClr val="16202E"/>
+                            <a:srgbClr val="0B1B33"/>
                           </a:solidFill>
                           <a:latin typeface="Calibri" pitchFamily="34" charset="0"/>
                           <a:ea typeface="Calibri" pitchFamily="34" charset="-122"/>
@@ -10209,7 +10641,7 @@
                       <a:r>
                         <a:rPr lang="en-US" sz="1500" dirty="0">
                           <a:solidFill>
-                            <a:srgbClr val="16202E"/>
+                            <a:srgbClr val="0B1B33"/>
                           </a:solidFill>
                           <a:latin typeface="Calibri" pitchFamily="34" charset="0"/>
                           <a:ea typeface="Calibri" pitchFamily="34" charset="-122"/>
@@ -10262,7 +10694,7 @@
                       <a:tailEnd type="none" w="med" len="med"/>
                     </a:lnB>
                     <a:solidFill>
-                      <a:srgbClr val="EEF2F5"/>
+                      <a:srgbClr val="EEF3F8"/>
                     </a:solidFill>
                   </a:tcPr>
                 </a:tc>
@@ -10277,7 +10709,7 @@
                       <a:r>
                         <a:rPr lang="en-US" sz="1500" dirty="0">
                           <a:solidFill>
-                            <a:srgbClr val="16202E"/>
+                            <a:srgbClr val="0B1B33"/>
                           </a:solidFill>
                           <a:latin typeface="Calibri" pitchFamily="34" charset="0"/>
                           <a:ea typeface="Calibri" pitchFamily="34" charset="-122"/>
@@ -10330,7 +10762,7 @@
                       <a:tailEnd type="none" w="med" len="med"/>
                     </a:lnB>
                     <a:solidFill>
-                      <a:srgbClr val="EEF2F5"/>
+                      <a:srgbClr val="EEF3F8"/>
                     </a:solidFill>
                   </a:tcPr>
                 </a:tc>
@@ -10347,7 +10779,7 @@
                       <a:r>
                         <a:rPr lang="en-US" sz="1500" dirty="0">
                           <a:solidFill>
-                            <a:srgbClr val="16202E"/>
+                            <a:srgbClr val="0B1B33"/>
                           </a:solidFill>
                           <a:latin typeface="Calibri" pitchFamily="34" charset="0"/>
                           <a:ea typeface="Calibri" pitchFamily="34" charset="-122"/>
@@ -10415,7 +10847,7 @@
                       <a:r>
                         <a:rPr lang="en-US" sz="1500" dirty="0">
                           <a:solidFill>
-                            <a:srgbClr val="16202E"/>
+                            <a:srgbClr val="0B1B33"/>
                           </a:solidFill>
                           <a:latin typeface="Calibri" pitchFamily="34" charset="0"/>
                           <a:ea typeface="Calibri" pitchFamily="34" charset="-122"/>
@@ -10485,7 +10917,7 @@
                       <a:r>
                         <a:rPr lang="en-US" sz="1500" dirty="0">
                           <a:solidFill>
-                            <a:srgbClr val="16202E"/>
+                            <a:srgbClr val="0B1B33"/>
                           </a:solidFill>
                           <a:latin typeface="Calibri" pitchFamily="34" charset="0"/>
                           <a:ea typeface="Calibri" pitchFamily="34" charset="-122"/>
@@ -10538,7 +10970,7 @@
                       <a:tailEnd type="none" w="med" len="med"/>
                     </a:lnB>
                     <a:solidFill>
-                      <a:srgbClr val="EEF2F5"/>
+                      <a:srgbClr val="EEF3F8"/>
                     </a:solidFill>
                   </a:tcPr>
                 </a:tc>
@@ -10553,7 +10985,7 @@
                       <a:r>
                         <a:rPr lang="en-US" sz="1500" dirty="0">
                           <a:solidFill>
-                            <a:srgbClr val="16202E"/>
+                            <a:srgbClr val="0B1B33"/>
                           </a:solidFill>
                           <a:latin typeface="Calibri" pitchFamily="34" charset="0"/>
                           <a:ea typeface="Calibri" pitchFamily="34" charset="-122"/>
@@ -10606,7 +11038,7 @@
                       <a:tailEnd type="none" w="med" len="med"/>
                     </a:lnB>
                     <a:solidFill>
-                      <a:srgbClr val="EEF2F5"/>
+                      <a:srgbClr val="EEF3F8"/>
                     </a:solidFill>
                   </a:tcPr>
                 </a:tc>
@@ -10723,16 +11155,57 @@
       </p:grpSpPr>
       <p:sp>
         <p:nvSpPr>
-          <p:cNvPr id="2" name="Text 0"/>
+          <p:cNvPr id="2" name="Text 1"/>
           <p:cNvSpPr/>
           <p:nvPr>
-            <p:ph idx="100" type="title" hasCustomPrompt="1"/>
+            <p:ph idx="103" type="title" hasCustomPrompt="1"/>
           </p:nvPr>
         </p:nvSpPr>
         <p:spPr>
           <a:xfrm>
-            <a:off x="731520" y="2377440"/>
-            <a:ext cx="10698480" cy="1097280"/>
+            <a:off x="731520" y="2331720"/>
+            <a:ext cx="7315200" cy="1097280"/>
+          </a:xfrm>
+          <a:prstGeom prst="rect">
+            <a:avLst/>
+          </a:prstGeom>
+          <a:noFill/>
+          <a:ln/>
+        </p:spPr>
+        <p:txBody>
+          <a:bodyPr wrap="square" rtlCol="0" anchor="b"/>
+          <a:lstStyle/>
+          <a:p>
+            <a:pPr algn="l" indent="0" marL="0">
+              <a:buNone/>
+            </a:pPr>
+            <a:r>
+              <a:rPr lang="en-US" sz="3400" b="1" dirty="0">
+                <a:solidFill>
+                  <a:schemeClr val="bg1"/>
+                </a:solidFill>
+                <a:latin typeface="Arial" pitchFamily="34" charset="0"/>
+                <a:ea typeface="Arial" pitchFamily="34" charset="-122"/>
+                <a:cs typeface="Arial" pitchFamily="34" charset="-120"/>
+              </a:rPr>
+              <a:t>The regulated firm's view</a:t>
+            </a:r>
+            <a:endParaRPr lang="en-US" sz="3400" dirty="0"/>
+          </a:p>
+        </p:txBody>
+      </p:sp>
+      <p:sp>
+        <p:nvSpPr>
+          <p:cNvPr id="3" name="Text 1"/>
+          <p:cNvSpPr/>
+          <p:nvPr>
+            <p:ph idx="104" type="body" hasCustomPrompt="1"/>
+          </p:nvPr>
+        </p:nvSpPr>
+        <p:spPr>
+          <a:xfrm>
+            <a:off x="731520" y="3703320"/>
+            <a:ext cx="7315200" cy="1097280"/>
           </a:xfrm>
           <a:prstGeom prst="rect">
             <a:avLst/>
@@ -10748,55 +11221,14 @@
               <a:buNone/>
             </a:pPr>
             <a:r>
-              <a:rPr lang="en-US" sz="3600" b="1" dirty="0">
-                <a:solidFill>
-                  <a:schemeClr val="bg1"/>
-                </a:solidFill>
-                <a:latin typeface="Cambria" pitchFamily="34" charset="0"/>
-                <a:ea typeface="Cambria" pitchFamily="34" charset="-122"/>
-                <a:cs typeface="Cambria" pitchFamily="34" charset="-120"/>
-              </a:rPr>
-              <a:t>The regulated firm's view</a:t>
-            </a:r>
-            <a:endParaRPr lang="en-US" sz="3600" dirty="0"/>
-          </a:p>
-        </p:txBody>
-      </p:sp>
-      <p:sp>
-        <p:nvSpPr>
-          <p:cNvPr id="3" name="Text 0"/>
-          <p:cNvSpPr/>
-          <p:nvPr>
-            <p:ph idx="101" type="body" hasCustomPrompt="1"/>
-          </p:nvPr>
-        </p:nvSpPr>
-        <p:spPr>
-          <a:xfrm>
-            <a:off x="731520" y="3566160"/>
-            <a:ext cx="10698480" cy="914400"/>
-          </a:xfrm>
-          <a:prstGeom prst="rect">
-            <a:avLst/>
-          </a:prstGeom>
-          <a:noFill/>
-          <a:ln/>
-        </p:spPr>
-        <p:txBody>
-          <a:bodyPr wrap="square" rtlCol="0"/>
-          <a:lstStyle/>
-          <a:p>
-            <a:pPr indent="0" marL="0">
-              <a:buNone/>
-            </a:pPr>
-            <a:r>
-              <a:rPr lang="en-US" sz="1800" dirty="0">
+              <a:rPr lang="en-US" sz="1700" dirty="0">
                 <a:solidFill>
                   <a:schemeClr val="accent5"/>
                 </a:solidFill>
               </a:rPr>
               <a:t>What supervisors will ask for, and the worked example that makes it concrete</a:t>
             </a:r>
-            <a:endParaRPr lang="en-US" sz="1800" dirty="0"/>
+            <a:endParaRPr lang="en-US" sz="1700" dirty="0"/>
           </a:p>
         </p:txBody>
       </p:sp>
@@ -10836,7 +11268,7 @@
         <p:spPr>
           <a:xfrm>
             <a:off x="548640" y="320040"/>
-            <a:ext cx="11064240" cy="822960"/>
+            <a:ext cx="9692640" cy="822960"/>
           </a:xfrm>
           <a:prstGeom prst="rect">
             <a:avLst/>
@@ -10848,21 +11280,21 @@
           <a:bodyPr wrap="square" rtlCol="0" anchor="ctr"/>
           <a:lstStyle/>
           <a:p>
-            <a:pPr indent="0" marL="0">
+            <a:pPr algn="l" indent="0" marL="0">
               <a:buNone/>
             </a:pPr>
             <a:r>
-              <a:rPr lang="en-US" sz="2800" b="1" dirty="0">
+              <a:rPr lang="en-US" sz="2600" b="1" dirty="0">
                 <a:solidFill>
                   <a:schemeClr val="tx2"/>
                 </a:solidFill>
-                <a:latin typeface="Cambria" pitchFamily="34" charset="0"/>
-                <a:ea typeface="Cambria" pitchFamily="34" charset="-122"/>
-                <a:cs typeface="Cambria" pitchFamily="34" charset="-120"/>
+                <a:latin typeface="Arial" pitchFamily="34" charset="0"/>
+                <a:ea typeface="Arial" pitchFamily="34" charset="-122"/>
+                <a:cs typeface="Arial" pitchFamily="34" charset="-120"/>
               </a:rPr>
               <a:t>What a supervisor or validator will ask to see</a:t>
             </a:r>
-            <a:endParaRPr lang="en-US" sz="2800" dirty="0"/>
+            <a:endParaRPr lang="en-US" sz="2600" dirty="0"/>
           </a:p>
         </p:txBody>
       </p:sp>
@@ -11541,7 +11973,7 @@
         <p:spPr>
           <a:xfrm>
             <a:off x="548640" y="320040"/>
-            <a:ext cx="11064240" cy="822960"/>
+            <a:ext cx="9692640" cy="822960"/>
           </a:xfrm>
           <a:prstGeom prst="rect">
             <a:avLst/>
@@ -11553,21 +11985,21 @@
           <a:bodyPr wrap="square" rtlCol="0" anchor="ctr"/>
           <a:lstStyle/>
           <a:p>
-            <a:pPr indent="0" marL="0">
+            <a:pPr algn="l" indent="0" marL="0">
               <a:buNone/>
             </a:pPr>
             <a:r>
-              <a:rPr lang="en-US" sz="2800" b="1" dirty="0">
+              <a:rPr lang="en-US" sz="2600" b="1" dirty="0">
                 <a:solidFill>
                   <a:schemeClr val="tx2"/>
                 </a:solidFill>
-                <a:latin typeface="Cambria" pitchFamily="34" charset="0"/>
-                <a:ea typeface="Cambria" pitchFamily="34" charset="-122"/>
-                <a:cs typeface="Cambria" pitchFamily="34" charset="-120"/>
+                <a:latin typeface="Arial" pitchFamily="34" charset="0"/>
+                <a:ea typeface="Arial" pitchFamily="34" charset="-122"/>
+                <a:cs typeface="Arial" pitchFamily="34" charset="-120"/>
               </a:rPr>
               <a:t>Worked example: the attribution-commentary agent</a:t>
             </a:r>
-            <a:endParaRPr lang="en-US" sz="2800" dirty="0"/>
+            <a:endParaRPr lang="en-US" sz="2600" dirty="0"/>
           </a:p>
         </p:txBody>
       </p:sp>
@@ -12480,7 +12912,7 @@
         <p:spPr>
           <a:xfrm>
             <a:off x="548640" y="320040"/>
-            <a:ext cx="11064240" cy="822960"/>
+            <a:ext cx="9692640" cy="822960"/>
           </a:xfrm>
           <a:prstGeom prst="rect">
             <a:avLst/>
@@ -12492,21 +12924,21 @@
           <a:bodyPr wrap="square" rtlCol="0" anchor="ctr"/>
           <a:lstStyle/>
           <a:p>
-            <a:pPr indent="0" marL="0">
+            <a:pPr algn="l" indent="0" marL="0">
               <a:buNone/>
             </a:pPr>
             <a:r>
-              <a:rPr lang="en-US" sz="2800" b="1" dirty="0">
+              <a:rPr lang="en-US" sz="2600" b="1" dirty="0">
                 <a:solidFill>
                   <a:schemeClr val="tx2"/>
                 </a:solidFill>
-                <a:latin typeface="Cambria" pitchFamily="34" charset="0"/>
-                <a:ea typeface="Cambria" pitchFamily="34" charset="-122"/>
-                <a:cs typeface="Cambria" pitchFamily="34" charset="-120"/>
+                <a:latin typeface="Arial" pitchFamily="34" charset="0"/>
+                <a:ea typeface="Arial" pitchFamily="34" charset="-122"/>
+                <a:cs typeface="Arial" pitchFamily="34" charset="-120"/>
               </a:rPr>
               <a:t>The answer in one sentence</a:t>
             </a:r>
-            <a:endParaRPr lang="en-US" sz="2800" dirty="0"/>
+            <a:endParaRPr lang="en-US" sz="2600" dirty="0"/>
           </a:p>
         </p:txBody>
       </p:sp>
@@ -12566,9 +12998,9 @@
                 <a:solidFill>
                   <a:schemeClr val="bg1"/>
                 </a:solidFill>
-                <a:latin typeface="Cambria" pitchFamily="34" charset="0"/>
-                <a:ea typeface="Cambria" pitchFamily="34" charset="-122"/>
-                <a:cs typeface="Cambria" pitchFamily="34" charset="-120"/>
+                <a:latin typeface="Arial" pitchFamily="34" charset="0"/>
+                <a:ea typeface="Arial" pitchFamily="34" charset="-122"/>
+                <a:cs typeface="Arial" pitchFamily="34" charset="-120"/>
               </a:rPr>
               <a:t>Build a firm-owned control and evidence plane first. Run regulated work as deterministic workflows with one bounded model step and a human approval gate. Consume models as a two-vendor portfolio. Treat every product beneath the plane as replaceable.</a:t>
             </a:r>
@@ -12954,7 +13386,7 @@
         <p:spPr>
           <a:xfrm>
             <a:off x="548640" y="320040"/>
-            <a:ext cx="11064240" cy="822960"/>
+            <a:ext cx="9692640" cy="822960"/>
           </a:xfrm>
           <a:prstGeom prst="rect">
             <a:avLst/>
@@ -12966,21 +13398,21 @@
           <a:bodyPr wrap="square" rtlCol="0" anchor="ctr"/>
           <a:lstStyle/>
           <a:p>
-            <a:pPr indent="0" marL="0">
+            <a:pPr algn="l" indent="0" marL="0">
               <a:buNone/>
             </a:pPr>
             <a:r>
-              <a:rPr lang="en-US" sz="2800" b="1" dirty="0">
+              <a:rPr lang="en-US" sz="2600" b="1" dirty="0">
                 <a:solidFill>
                   <a:schemeClr val="tx2"/>
                 </a:solidFill>
-                <a:latin typeface="Cambria" pitchFamily="34" charset="0"/>
-                <a:ea typeface="Cambria" pitchFamily="34" charset="-122"/>
-                <a:cs typeface="Cambria" pitchFamily="34" charset="-120"/>
+                <a:latin typeface="Arial" pitchFamily="34" charset="0"/>
+                <a:ea typeface="Arial" pitchFamily="34" charset="-122"/>
+                <a:cs typeface="Arial" pitchFamily="34" charset="-120"/>
               </a:rPr>
               <a:t>What the agent must never do matters more than what it can do</a:t>
             </a:r>
-            <a:endParaRPr lang="en-US" sz="2800" dirty="0"/>
+            <a:endParaRPr lang="en-US" sz="2600" dirty="0"/>
           </a:p>
         </p:txBody>
       </p:sp>
@@ -13687,16 +14119,57 @@
       </p:grpSpPr>
       <p:sp>
         <p:nvSpPr>
-          <p:cNvPr id="2" name="Text 0"/>
+          <p:cNvPr id="2" name="Text 1"/>
           <p:cNvSpPr/>
           <p:nvPr>
-            <p:ph idx="100" type="title" hasCustomPrompt="1"/>
+            <p:ph idx="103" type="title" hasCustomPrompt="1"/>
           </p:nvPr>
         </p:nvSpPr>
         <p:spPr>
           <a:xfrm>
-            <a:off x="731520" y="2377440"/>
-            <a:ext cx="10698480" cy="1097280"/>
+            <a:off x="731520" y="2331720"/>
+            <a:ext cx="7315200" cy="1097280"/>
+          </a:xfrm>
+          <a:prstGeom prst="rect">
+            <a:avLst/>
+          </a:prstGeom>
+          <a:noFill/>
+          <a:ln/>
+        </p:spPr>
+        <p:txBody>
+          <a:bodyPr wrap="square" rtlCol="0" anchor="b"/>
+          <a:lstStyle/>
+          <a:p>
+            <a:pPr algn="l" indent="0" marL="0">
+              <a:buNone/>
+            </a:pPr>
+            <a:r>
+              <a:rPr lang="en-US" sz="3400" b="1" dirty="0">
+                <a:solidFill>
+                  <a:schemeClr val="bg1"/>
+                </a:solidFill>
+                <a:latin typeface="Arial" pitchFamily="34" charset="0"/>
+                <a:ea typeface="Arial" pitchFamily="34" charset="-122"/>
+                <a:cs typeface="Arial" pitchFamily="34" charset="-120"/>
+              </a:rPr>
+              <a:t>Delivery</a:t>
+            </a:r>
+            <a:endParaRPr lang="en-US" sz="3400" dirty="0"/>
+          </a:p>
+        </p:txBody>
+      </p:sp>
+      <p:sp>
+        <p:nvSpPr>
+          <p:cNvPr id="3" name="Text 1"/>
+          <p:cNvSpPr/>
+          <p:nvPr>
+            <p:ph idx="104" type="body" hasCustomPrompt="1"/>
+          </p:nvPr>
+        </p:nvSpPr>
+        <p:spPr>
+          <a:xfrm>
+            <a:off x="731520" y="3703320"/>
+            <a:ext cx="7315200" cy="1097280"/>
           </a:xfrm>
           <a:prstGeom prst="rect">
             <a:avLst/>
@@ -13712,55 +14185,14 @@
               <a:buNone/>
             </a:pPr>
             <a:r>
-              <a:rPr lang="en-US" sz="3600" b="1" dirty="0">
-                <a:solidFill>
-                  <a:schemeClr val="bg1"/>
-                </a:solidFill>
-                <a:latin typeface="Cambria" pitchFamily="34" charset="0"/>
-                <a:ea typeface="Cambria" pitchFamily="34" charset="-122"/>
-                <a:cs typeface="Cambria" pitchFamily="34" charset="-120"/>
-              </a:rPr>
-              <a:t>Delivery</a:t>
-            </a:r>
-            <a:endParaRPr lang="en-US" sz="3600" dirty="0"/>
-          </a:p>
-        </p:txBody>
-      </p:sp>
-      <p:sp>
-        <p:nvSpPr>
-          <p:cNvPr id="3" name="Text 0"/>
-          <p:cNvSpPr/>
-          <p:nvPr>
-            <p:ph idx="101" type="body" hasCustomPrompt="1"/>
-          </p:nvPr>
-        </p:nvSpPr>
-        <p:spPr>
-          <a:xfrm>
-            <a:off x="731520" y="3566160"/>
-            <a:ext cx="10698480" cy="914400"/>
-          </a:xfrm>
-          <a:prstGeom prst="rect">
-            <a:avLst/>
-          </a:prstGeom>
-          <a:noFill/>
-          <a:ln/>
-        </p:spPr>
-        <p:txBody>
-          <a:bodyPr wrap="square" rtlCol="0"/>
-          <a:lstStyle/>
-          <a:p>
-            <a:pPr indent="0" marL="0">
-              <a:buNone/>
-            </a:pPr>
-            <a:r>
-              <a:rPr lang="en-US" sz="1800" dirty="0">
+              <a:rPr lang="en-US" sz="1700" dirty="0">
                 <a:solidFill>
                   <a:schemeClr val="accent5"/>
                 </a:solidFill>
               </a:rPr>
               <a:t>Four reference stacks · build vs buy · lock-in · an 18-month roadmap</a:t>
             </a:r>
-            <a:endParaRPr lang="en-US" sz="1800" dirty="0"/>
+            <a:endParaRPr lang="en-US" sz="1700" dirty="0"/>
           </a:p>
         </p:txBody>
       </p:sp>
@@ -13800,7 +14232,7 @@
         <p:spPr>
           <a:xfrm>
             <a:off x="548640" y="320040"/>
-            <a:ext cx="11064240" cy="822960"/>
+            <a:ext cx="9692640" cy="822960"/>
           </a:xfrm>
           <a:prstGeom prst="rect">
             <a:avLst/>
@@ -13812,21 +14244,21 @@
           <a:bodyPr wrap="square" rtlCol="0" anchor="ctr"/>
           <a:lstStyle/>
           <a:p>
-            <a:pPr indent="0" marL="0">
+            <a:pPr algn="l" indent="0" marL="0">
               <a:buNone/>
             </a:pPr>
             <a:r>
-              <a:rPr lang="en-US" sz="2800" b="1" dirty="0">
+              <a:rPr lang="en-US" sz="2600" b="1" dirty="0">
                 <a:solidFill>
                   <a:schemeClr val="tx2"/>
                 </a:solidFill>
-                <a:latin typeface="Cambria" pitchFamily="34" charset="0"/>
-                <a:ea typeface="Cambria" pitchFamily="34" charset="-122"/>
-                <a:cs typeface="Cambria" pitchFamily="34" charset="-120"/>
+                <a:latin typeface="Arial" pitchFamily="34" charset="0"/>
+                <a:ea typeface="Arial" pitchFamily="34" charset="-122"/>
+                <a:cs typeface="Arial" pitchFamily="34" charset="-120"/>
               </a:rPr>
               <a:t>Four reference stacks: Stack A leads</a:t>
             </a:r>
-            <a:endParaRPr lang="en-US" sz="2800" dirty="0"/>
+            <a:endParaRPr lang="en-US" sz="2600" dirty="0"/>
           </a:p>
         </p:txBody>
       </p:sp>
@@ -14442,7 +14874,7 @@
         <p:spPr>
           <a:xfrm>
             <a:off x="548640" y="320040"/>
-            <a:ext cx="11064240" cy="822960"/>
+            <a:ext cx="9692640" cy="822960"/>
           </a:xfrm>
           <a:prstGeom prst="rect">
             <a:avLst/>
@@ -14454,21 +14886,21 @@
           <a:bodyPr wrap="square" rtlCol="0" anchor="ctr"/>
           <a:lstStyle/>
           <a:p>
-            <a:pPr indent="0" marL="0">
+            <a:pPr algn="l" indent="0" marL="0">
               <a:buNone/>
             </a:pPr>
             <a:r>
-              <a:rPr lang="en-US" sz="2800" b="1" dirty="0">
+              <a:rPr lang="en-US" sz="2600" b="1" dirty="0">
                 <a:solidFill>
                   <a:schemeClr val="tx2"/>
                 </a:solidFill>
-                <a:latin typeface="Cambria" pitchFamily="34" charset="0"/>
-                <a:ea typeface="Cambria" pitchFamily="34" charset="-122"/>
-                <a:cs typeface="Cambria" pitchFamily="34" charset="-120"/>
+                <a:latin typeface="Arial" pitchFamily="34" charset="0"/>
+                <a:ea typeface="Arial" pitchFamily="34" charset="-122"/>
+                <a:cs typeface="Arial" pitchFamily="34" charset="-120"/>
               </a:rPr>
               <a:t>Build the control statement; buy the commodity</a:t>
             </a:r>
-            <a:endParaRPr lang="en-US" sz="2800" dirty="0"/>
+            <a:endParaRPr lang="en-US" sz="2600" dirty="0"/>
           </a:p>
         </p:txBody>
       </p:sp>
@@ -14564,7 +14996,7 @@
                       <a:tailEnd type="none" w="med" len="med"/>
                     </a:lnB>
                     <a:solidFill>
-                      <a:srgbClr val="1B2A41"/>
+                      <a:srgbClr val="0B1B33"/>
                     </a:solidFill>
                   </a:tcPr>
                 </a:tc>
@@ -14632,7 +15064,7 @@
                       <a:tailEnd type="none" w="med" len="med"/>
                     </a:lnB>
                     <a:solidFill>
-                      <a:srgbClr val="1B2A41"/>
+                      <a:srgbClr val="0B1B33"/>
                     </a:solidFill>
                   </a:tcPr>
                 </a:tc>
@@ -14700,7 +15132,7 @@
                       <a:tailEnd type="none" w="med" len="med"/>
                     </a:lnB>
                     <a:solidFill>
-                      <a:srgbClr val="1B2A41"/>
+                      <a:srgbClr val="0B1B33"/>
                     </a:solidFill>
                   </a:tcPr>
                 </a:tc>
@@ -14717,7 +15149,7 @@
                       <a:r>
                         <a:rPr lang="en-US" sz="1500" dirty="0">
                           <a:solidFill>
-                            <a:srgbClr val="16202E"/>
+                            <a:srgbClr val="0B1B33"/>
                           </a:solidFill>
                           <a:latin typeface="Calibri" pitchFamily="34" charset="0"/>
                           <a:ea typeface="Calibri" pitchFamily="34" charset="-122"/>
@@ -14770,7 +15202,7 @@
                       <a:tailEnd type="none" w="med" len="med"/>
                     </a:lnB>
                     <a:solidFill>
-                      <a:srgbClr val="EEF2F5"/>
+                      <a:srgbClr val="EEF3F8"/>
                     </a:solidFill>
                   </a:tcPr>
                 </a:tc>
@@ -14785,7 +15217,7 @@
                       <a:r>
                         <a:rPr lang="en-US" sz="1500" dirty="0">
                           <a:solidFill>
-                            <a:srgbClr val="16202E"/>
+                            <a:srgbClr val="0B1B33"/>
                           </a:solidFill>
                           <a:latin typeface="Calibri" pitchFamily="34" charset="0"/>
                           <a:ea typeface="Calibri" pitchFamily="34" charset="-122"/>
@@ -14838,7 +15270,7 @@
                       <a:tailEnd type="none" w="med" len="med"/>
                     </a:lnB>
                     <a:solidFill>
-                      <a:srgbClr val="EEF2F5"/>
+                      <a:srgbClr val="EEF3F8"/>
                     </a:solidFill>
                   </a:tcPr>
                 </a:tc>
@@ -14853,7 +15285,7 @@
                       <a:r>
                         <a:rPr lang="en-US" sz="1500" dirty="0">
                           <a:solidFill>
-                            <a:srgbClr val="16202E"/>
+                            <a:srgbClr val="0B1B33"/>
                           </a:solidFill>
                           <a:latin typeface="Calibri" pitchFamily="34" charset="0"/>
                           <a:ea typeface="Calibri" pitchFamily="34" charset="-122"/>
@@ -14906,7 +15338,7 @@
                       <a:tailEnd type="none" w="med" len="med"/>
                     </a:lnB>
                     <a:solidFill>
-                      <a:srgbClr val="EEF2F5"/>
+                      <a:srgbClr val="EEF3F8"/>
                     </a:solidFill>
                   </a:tcPr>
                 </a:tc>
@@ -14923,7 +15355,7 @@
                       <a:r>
                         <a:rPr lang="en-US" sz="1500" dirty="0">
                           <a:solidFill>
-                            <a:srgbClr val="16202E"/>
+                            <a:srgbClr val="0B1B33"/>
                           </a:solidFill>
                           <a:latin typeface="Calibri" pitchFamily="34" charset="0"/>
                           <a:ea typeface="Calibri" pitchFamily="34" charset="-122"/>
@@ -14991,7 +15423,7 @@
                       <a:r>
                         <a:rPr lang="en-US" sz="1500" dirty="0">
                           <a:solidFill>
-                            <a:srgbClr val="16202E"/>
+                            <a:srgbClr val="0B1B33"/>
                           </a:solidFill>
                           <a:latin typeface="Calibri" pitchFamily="34" charset="0"/>
                           <a:ea typeface="Calibri" pitchFamily="34" charset="-122"/>
@@ -15059,7 +15491,7 @@
                       <a:r>
                         <a:rPr lang="en-US" sz="1500" dirty="0">
                           <a:solidFill>
-                            <a:srgbClr val="16202E"/>
+                            <a:srgbClr val="0B1B33"/>
                           </a:solidFill>
                           <a:latin typeface="Calibri" pitchFamily="34" charset="0"/>
                           <a:ea typeface="Calibri" pitchFamily="34" charset="-122"/>
@@ -15129,7 +15561,7 @@
                       <a:r>
                         <a:rPr lang="en-US" sz="1500" dirty="0">
                           <a:solidFill>
-                            <a:srgbClr val="16202E"/>
+                            <a:srgbClr val="0B1B33"/>
                           </a:solidFill>
                           <a:latin typeface="Calibri" pitchFamily="34" charset="0"/>
                           <a:ea typeface="Calibri" pitchFamily="34" charset="-122"/>
@@ -15182,7 +15614,7 @@
                       <a:tailEnd type="none" w="med" len="med"/>
                     </a:lnB>
                     <a:solidFill>
-                      <a:srgbClr val="EEF2F5"/>
+                      <a:srgbClr val="EEF3F8"/>
                     </a:solidFill>
                   </a:tcPr>
                 </a:tc>
@@ -15197,7 +15629,7 @@
                       <a:r>
                         <a:rPr lang="en-US" sz="1500" dirty="0">
                           <a:solidFill>
-                            <a:srgbClr val="16202E"/>
+                            <a:srgbClr val="0B1B33"/>
                           </a:solidFill>
                           <a:latin typeface="Calibri" pitchFamily="34" charset="0"/>
                           <a:ea typeface="Calibri" pitchFamily="34" charset="-122"/>
@@ -15250,7 +15682,7 @@
                       <a:tailEnd type="none" w="med" len="med"/>
                     </a:lnB>
                     <a:solidFill>
-                      <a:srgbClr val="EEF2F5"/>
+                      <a:srgbClr val="EEF3F8"/>
                     </a:solidFill>
                   </a:tcPr>
                 </a:tc>
@@ -15265,7 +15697,7 @@
                       <a:r>
                         <a:rPr lang="en-US" sz="1500" dirty="0">
                           <a:solidFill>
-                            <a:srgbClr val="16202E"/>
+                            <a:srgbClr val="0B1B33"/>
                           </a:solidFill>
                           <a:latin typeface="Calibri" pitchFamily="34" charset="0"/>
                           <a:ea typeface="Calibri" pitchFamily="34" charset="-122"/>
@@ -15318,7 +15750,7 @@
                       <a:tailEnd type="none" w="med" len="med"/>
                     </a:lnB>
                     <a:solidFill>
-                      <a:srgbClr val="EEF2F5"/>
+                      <a:srgbClr val="EEF3F8"/>
                     </a:solidFill>
                   </a:tcPr>
                 </a:tc>
@@ -15335,7 +15767,7 @@
                       <a:r>
                         <a:rPr lang="en-US" sz="1500" dirty="0">
                           <a:solidFill>
-                            <a:srgbClr val="16202E"/>
+                            <a:srgbClr val="0B1B33"/>
                           </a:solidFill>
                           <a:latin typeface="Calibri" pitchFamily="34" charset="0"/>
                           <a:ea typeface="Calibri" pitchFamily="34" charset="-122"/>
@@ -15403,7 +15835,7 @@
                       <a:r>
                         <a:rPr lang="en-US" sz="1500" dirty="0">
                           <a:solidFill>
-                            <a:srgbClr val="16202E"/>
+                            <a:srgbClr val="0B1B33"/>
                           </a:solidFill>
                           <a:latin typeface="Calibri" pitchFamily="34" charset="0"/>
                           <a:ea typeface="Calibri" pitchFamily="34" charset="-122"/>
@@ -15471,7 +15903,7 @@
                       <a:r>
                         <a:rPr lang="en-US" sz="1500" dirty="0">
                           <a:solidFill>
-                            <a:srgbClr val="16202E"/>
+                            <a:srgbClr val="0B1B33"/>
                           </a:solidFill>
                           <a:latin typeface="Calibri" pitchFamily="34" charset="0"/>
                           <a:ea typeface="Calibri" pitchFamily="34" charset="-122"/>
@@ -15541,7 +15973,7 @@
                       <a:r>
                         <a:rPr lang="en-US" sz="1500" dirty="0">
                           <a:solidFill>
-                            <a:srgbClr val="16202E"/>
+                            <a:srgbClr val="0B1B33"/>
                           </a:solidFill>
                           <a:latin typeface="Calibri" pitchFamily="34" charset="0"/>
                           <a:ea typeface="Calibri" pitchFamily="34" charset="-122"/>
@@ -15594,7 +16026,7 @@
                       <a:tailEnd type="none" w="med" len="med"/>
                     </a:lnB>
                     <a:solidFill>
-                      <a:srgbClr val="EEF2F5"/>
+                      <a:srgbClr val="EEF3F8"/>
                     </a:solidFill>
                   </a:tcPr>
                 </a:tc>
@@ -15609,7 +16041,7 @@
                       <a:r>
                         <a:rPr lang="en-US" sz="1500" dirty="0">
                           <a:solidFill>
-                            <a:srgbClr val="16202E"/>
+                            <a:srgbClr val="0B1B33"/>
                           </a:solidFill>
                           <a:latin typeface="Calibri" pitchFamily="34" charset="0"/>
                           <a:ea typeface="Calibri" pitchFamily="34" charset="-122"/>
@@ -15662,7 +16094,7 @@
                       <a:tailEnd type="none" w="med" len="med"/>
                     </a:lnB>
                     <a:solidFill>
-                      <a:srgbClr val="EEF2F5"/>
+                      <a:srgbClr val="EEF3F8"/>
                     </a:solidFill>
                   </a:tcPr>
                 </a:tc>
@@ -15677,7 +16109,7 @@
                       <a:r>
                         <a:rPr lang="en-US" sz="1500" dirty="0">
                           <a:solidFill>
-                            <a:srgbClr val="16202E"/>
+                            <a:srgbClr val="0B1B33"/>
                           </a:solidFill>
                           <a:latin typeface="Calibri" pitchFamily="34" charset="0"/>
                           <a:ea typeface="Calibri" pitchFamily="34" charset="-122"/>
@@ -15730,7 +16162,7 @@
                       <a:tailEnd type="none" w="med" len="med"/>
                     </a:lnB>
                     <a:solidFill>
-                      <a:srgbClr val="EEF2F5"/>
+                      <a:srgbClr val="EEF3F8"/>
                     </a:solidFill>
                   </a:tcPr>
                 </a:tc>
@@ -15747,7 +16179,7 @@
                       <a:r>
                         <a:rPr lang="en-US" sz="1500" dirty="0">
                           <a:solidFill>
-                            <a:srgbClr val="16202E"/>
+                            <a:srgbClr val="0B1B33"/>
                           </a:solidFill>
                           <a:latin typeface="Calibri" pitchFamily="34" charset="0"/>
                           <a:ea typeface="Calibri" pitchFamily="34" charset="-122"/>
@@ -15815,7 +16247,7 @@
                       <a:r>
                         <a:rPr lang="en-US" sz="1500" dirty="0">
                           <a:solidFill>
-                            <a:srgbClr val="16202E"/>
+                            <a:srgbClr val="0B1B33"/>
                           </a:solidFill>
                           <a:latin typeface="Calibri" pitchFamily="34" charset="0"/>
                           <a:ea typeface="Calibri" pitchFamily="34" charset="-122"/>
@@ -15883,7 +16315,7 @@
                       <a:r>
                         <a:rPr lang="en-US" sz="1500" dirty="0">
                           <a:solidFill>
-                            <a:srgbClr val="16202E"/>
+                            <a:srgbClr val="0B1B33"/>
                           </a:solidFill>
                           <a:latin typeface="Calibri" pitchFamily="34" charset="0"/>
                           <a:ea typeface="Calibri" pitchFamily="34" charset="-122"/>
@@ -15953,7 +16385,7 @@
                       <a:r>
                         <a:rPr lang="en-US" sz="1500" dirty="0">
                           <a:solidFill>
-                            <a:srgbClr val="16202E"/>
+                            <a:srgbClr val="0B1B33"/>
                           </a:solidFill>
                           <a:latin typeface="Calibri" pitchFamily="34" charset="0"/>
                           <a:ea typeface="Calibri" pitchFamily="34" charset="-122"/>
@@ -16006,7 +16438,7 @@
                       <a:tailEnd type="none" w="med" len="med"/>
                     </a:lnB>
                     <a:solidFill>
-                      <a:srgbClr val="EEF2F5"/>
+                      <a:srgbClr val="EEF3F8"/>
                     </a:solidFill>
                   </a:tcPr>
                 </a:tc>
@@ -16021,7 +16453,7 @@
                       <a:r>
                         <a:rPr lang="en-US" sz="1500" dirty="0">
                           <a:solidFill>
-                            <a:srgbClr val="16202E"/>
+                            <a:srgbClr val="0B1B33"/>
                           </a:solidFill>
                           <a:latin typeface="Calibri" pitchFamily="34" charset="0"/>
                           <a:ea typeface="Calibri" pitchFamily="34" charset="-122"/>
@@ -16074,7 +16506,7 @@
                       <a:tailEnd type="none" w="med" len="med"/>
                     </a:lnB>
                     <a:solidFill>
-                      <a:srgbClr val="EEF2F5"/>
+                      <a:srgbClr val="EEF3F8"/>
                     </a:solidFill>
                   </a:tcPr>
                 </a:tc>
@@ -16089,7 +16521,7 @@
                       <a:r>
                         <a:rPr lang="en-US" sz="1500" dirty="0">
                           <a:solidFill>
-                            <a:srgbClr val="16202E"/>
+                            <a:srgbClr val="0B1B33"/>
                           </a:solidFill>
                           <a:latin typeface="Calibri" pitchFamily="34" charset="0"/>
                           <a:ea typeface="Calibri" pitchFamily="34" charset="-122"/>
@@ -16142,7 +16574,7 @@
                       <a:tailEnd type="none" w="med" len="med"/>
                     </a:lnB>
                     <a:solidFill>
-                      <a:srgbClr val="EEF2F5"/>
+                      <a:srgbClr val="EEF3F8"/>
                     </a:solidFill>
                   </a:tcPr>
                 </a:tc>
@@ -16159,7 +16591,7 @@
                       <a:r>
                         <a:rPr lang="en-US" sz="1500" dirty="0">
                           <a:solidFill>
-                            <a:srgbClr val="16202E"/>
+                            <a:srgbClr val="0B1B33"/>
                           </a:solidFill>
                           <a:latin typeface="Calibri" pitchFamily="34" charset="0"/>
                           <a:ea typeface="Calibri" pitchFamily="34" charset="-122"/>
@@ -16227,7 +16659,7 @@
                       <a:r>
                         <a:rPr lang="en-US" sz="1500" dirty="0">
                           <a:solidFill>
-                            <a:srgbClr val="16202E"/>
+                            <a:srgbClr val="0B1B33"/>
                           </a:solidFill>
                           <a:latin typeface="Calibri" pitchFamily="34" charset="0"/>
                           <a:ea typeface="Calibri" pitchFamily="34" charset="-122"/>
@@ -16295,7 +16727,7 @@
                       <a:r>
                         <a:rPr lang="en-US" sz="1500" dirty="0">
                           <a:solidFill>
-                            <a:srgbClr val="16202E"/>
+                            <a:srgbClr val="0B1B33"/>
                           </a:solidFill>
                           <a:latin typeface="Calibri" pitchFamily="34" charset="0"/>
                           <a:ea typeface="Calibri" pitchFamily="34" charset="-122"/>
@@ -16365,7 +16797,7 @@
                       <a:r>
                         <a:rPr lang="en-US" sz="1500" dirty="0">
                           <a:solidFill>
-                            <a:srgbClr val="16202E"/>
+                            <a:srgbClr val="0B1B33"/>
                           </a:solidFill>
                           <a:latin typeface="Calibri" pitchFamily="34" charset="0"/>
                           <a:ea typeface="Calibri" pitchFamily="34" charset="-122"/>
@@ -16418,7 +16850,7 @@
                       <a:tailEnd type="none" w="med" len="med"/>
                     </a:lnB>
                     <a:solidFill>
-                      <a:srgbClr val="EEF2F5"/>
+                      <a:srgbClr val="EEF3F8"/>
                     </a:solidFill>
                   </a:tcPr>
                 </a:tc>
@@ -16433,7 +16865,7 @@
                       <a:r>
                         <a:rPr lang="en-US" sz="1500" dirty="0">
                           <a:solidFill>
-                            <a:srgbClr val="16202E"/>
+                            <a:srgbClr val="0B1B33"/>
                           </a:solidFill>
                           <a:latin typeface="Calibri" pitchFamily="34" charset="0"/>
                           <a:ea typeface="Calibri" pitchFamily="34" charset="-122"/>
@@ -16486,7 +16918,7 @@
                       <a:tailEnd type="none" w="med" len="med"/>
                     </a:lnB>
                     <a:solidFill>
-                      <a:srgbClr val="EEF2F5"/>
+                      <a:srgbClr val="EEF3F8"/>
                     </a:solidFill>
                   </a:tcPr>
                 </a:tc>
@@ -16501,7 +16933,7 @@
                       <a:r>
                         <a:rPr lang="en-US" sz="1500" dirty="0">
                           <a:solidFill>
-                            <a:srgbClr val="16202E"/>
+                            <a:srgbClr val="0B1B33"/>
                           </a:solidFill>
                           <a:latin typeface="Calibri" pitchFamily="34" charset="0"/>
                           <a:ea typeface="Calibri" pitchFamily="34" charset="-122"/>
@@ -16554,7 +16986,7 @@
                       <a:tailEnd type="none" w="med" len="med"/>
                     </a:lnB>
                     <a:solidFill>
-                      <a:srgbClr val="EEF2F5"/>
+                      <a:srgbClr val="EEF3F8"/>
                     </a:solidFill>
                   </a:tcPr>
                 </a:tc>
@@ -16644,7 +17076,7 @@
         <p:spPr>
           <a:xfrm>
             <a:off x="548640" y="320040"/>
-            <a:ext cx="11064240" cy="822960"/>
+            <a:ext cx="9692640" cy="822960"/>
           </a:xfrm>
           <a:prstGeom prst="rect">
             <a:avLst/>
@@ -16656,21 +17088,21 @@
           <a:bodyPr wrap="square" rtlCol="0" anchor="ctr"/>
           <a:lstStyle/>
           <a:p>
-            <a:pPr indent="0" marL="0">
+            <a:pPr algn="l" indent="0" marL="0">
               <a:buNone/>
             </a:pPr>
             <a:r>
-              <a:rPr lang="en-US" sz="2800" b="1" dirty="0">
+              <a:rPr lang="en-US" sz="2600" b="1" dirty="0">
                 <a:solidFill>
                   <a:schemeClr val="tx2"/>
                 </a:solidFill>
-                <a:latin typeface="Cambria" pitchFamily="34" charset="0"/>
-                <a:ea typeface="Cambria" pitchFamily="34" charset="-122"/>
-                <a:cs typeface="Cambria" pitchFamily="34" charset="-120"/>
+                <a:latin typeface="Arial" pitchFamily="34" charset="0"/>
+                <a:ea typeface="Arial" pitchFamily="34" charset="-122"/>
+                <a:cs typeface="Arial" pitchFamily="34" charset="-120"/>
               </a:rPr>
               <a:t>Which lock-in is acceptable, and which is not</a:t>
             </a:r>
-            <a:endParaRPr lang="en-US" sz="2800" dirty="0"/>
+            <a:endParaRPr lang="en-US" sz="2600" dirty="0"/>
           </a:p>
         </p:txBody>
       </p:sp>
@@ -16766,7 +17198,7 @@
                       <a:tailEnd type="none" w="med" len="med"/>
                     </a:lnB>
                     <a:solidFill>
-                      <a:srgbClr val="1B2A41"/>
+                      <a:srgbClr val="0B1B33"/>
                     </a:solidFill>
                   </a:tcPr>
                 </a:tc>
@@ -16834,7 +17266,7 @@
                       <a:tailEnd type="none" w="med" len="med"/>
                     </a:lnB>
                     <a:solidFill>
-                      <a:srgbClr val="1B2A41"/>
+                      <a:srgbClr val="0B1B33"/>
                     </a:solidFill>
                   </a:tcPr>
                 </a:tc>
@@ -16902,7 +17334,7 @@
                       <a:tailEnd type="none" w="med" len="med"/>
                     </a:lnB>
                     <a:solidFill>
-                      <a:srgbClr val="1B2A41"/>
+                      <a:srgbClr val="0B1B33"/>
                     </a:solidFill>
                   </a:tcPr>
                 </a:tc>
@@ -16919,7 +17351,7 @@
                       <a:r>
                         <a:rPr lang="en-US" sz="1600" dirty="0">
                           <a:solidFill>
-                            <a:srgbClr val="16202E"/>
+                            <a:srgbClr val="0B1B33"/>
                           </a:solidFill>
                           <a:latin typeface="Calibri" pitchFamily="34" charset="0"/>
                           <a:ea typeface="Calibri" pitchFamily="34" charset="-122"/>
@@ -16972,7 +17404,7 @@
                       <a:tailEnd type="none" w="med" len="med"/>
                     </a:lnB>
                     <a:solidFill>
-                      <a:srgbClr val="EEF2F5"/>
+                      <a:srgbClr val="EEF3F8"/>
                     </a:solidFill>
                   </a:tcPr>
                 </a:tc>
@@ -16987,7 +17419,7 @@
                       <a:r>
                         <a:rPr lang="en-US" sz="1600" dirty="0">
                           <a:solidFill>
-                            <a:srgbClr val="16202E"/>
+                            <a:srgbClr val="0B1B33"/>
                           </a:solidFill>
                           <a:latin typeface="Calibri" pitchFamily="34" charset="0"/>
                           <a:ea typeface="Calibri" pitchFamily="34" charset="-122"/>
@@ -17040,7 +17472,7 @@
                       <a:tailEnd type="none" w="med" len="med"/>
                     </a:lnB>
                     <a:solidFill>
-                      <a:srgbClr val="EEF2F5"/>
+                      <a:srgbClr val="EEF3F8"/>
                     </a:solidFill>
                   </a:tcPr>
                 </a:tc>
@@ -17055,7 +17487,7 @@
                       <a:r>
                         <a:rPr lang="en-US" sz="1600" dirty="0">
                           <a:solidFill>
-                            <a:srgbClr val="16202E"/>
+                            <a:srgbClr val="0B1B33"/>
                           </a:solidFill>
                           <a:latin typeface="Calibri" pitchFamily="34" charset="0"/>
                           <a:ea typeface="Calibri" pitchFamily="34" charset="-122"/>
@@ -17108,7 +17540,7 @@
                       <a:tailEnd type="none" w="med" len="med"/>
                     </a:lnB>
                     <a:solidFill>
-                      <a:srgbClr val="EEF2F5"/>
+                      <a:srgbClr val="EEF3F8"/>
                     </a:solidFill>
                   </a:tcPr>
                 </a:tc>
@@ -17125,7 +17557,7 @@
                       <a:r>
                         <a:rPr lang="en-US" sz="1600" dirty="0">
                           <a:solidFill>
-                            <a:srgbClr val="16202E"/>
+                            <a:srgbClr val="0B1B33"/>
                           </a:solidFill>
                           <a:latin typeface="Calibri" pitchFamily="34" charset="0"/>
                           <a:ea typeface="Calibri" pitchFamily="34" charset="-122"/>
@@ -17193,7 +17625,7 @@
                       <a:r>
                         <a:rPr lang="en-US" sz="1600" dirty="0">
                           <a:solidFill>
-                            <a:srgbClr val="16202E"/>
+                            <a:srgbClr val="0B1B33"/>
                           </a:solidFill>
                           <a:latin typeface="Calibri" pitchFamily="34" charset="0"/>
                           <a:ea typeface="Calibri" pitchFamily="34" charset="-122"/>
@@ -17261,7 +17693,7 @@
                       <a:r>
                         <a:rPr lang="en-US" sz="1600" dirty="0">
                           <a:solidFill>
-                            <a:srgbClr val="16202E"/>
+                            <a:srgbClr val="0B1B33"/>
                           </a:solidFill>
                           <a:latin typeface="Calibri" pitchFamily="34" charset="0"/>
                           <a:ea typeface="Calibri" pitchFamily="34" charset="-122"/>
@@ -17331,7 +17763,7 @@
                       <a:r>
                         <a:rPr lang="en-US" sz="1600" dirty="0">
                           <a:solidFill>
-                            <a:srgbClr val="16202E"/>
+                            <a:srgbClr val="0B1B33"/>
                           </a:solidFill>
                           <a:latin typeface="Calibri" pitchFamily="34" charset="0"/>
                           <a:ea typeface="Calibri" pitchFamily="34" charset="-122"/>
@@ -17384,7 +17816,7 @@
                       <a:tailEnd type="none" w="med" len="med"/>
                     </a:lnB>
                     <a:solidFill>
-                      <a:srgbClr val="EEF2F5"/>
+                      <a:srgbClr val="EEF3F8"/>
                     </a:solidFill>
                   </a:tcPr>
                 </a:tc>
@@ -17399,7 +17831,7 @@
                       <a:r>
                         <a:rPr lang="en-US" sz="1600" dirty="0">
                           <a:solidFill>
-                            <a:srgbClr val="16202E"/>
+                            <a:srgbClr val="0B1B33"/>
                           </a:solidFill>
                           <a:latin typeface="Calibri" pitchFamily="34" charset="0"/>
                           <a:ea typeface="Calibri" pitchFamily="34" charset="-122"/>
@@ -17452,7 +17884,7 @@
                       <a:tailEnd type="none" w="med" len="med"/>
                     </a:lnB>
                     <a:solidFill>
-                      <a:srgbClr val="EEF2F5"/>
+                      <a:srgbClr val="EEF3F8"/>
                     </a:solidFill>
                   </a:tcPr>
                 </a:tc>
@@ -17467,7 +17899,7 @@
                       <a:r>
                         <a:rPr lang="en-US" sz="1600" dirty="0">
                           <a:solidFill>
-                            <a:srgbClr val="16202E"/>
+                            <a:srgbClr val="0B1B33"/>
                           </a:solidFill>
                           <a:latin typeface="Calibri" pitchFamily="34" charset="0"/>
                           <a:ea typeface="Calibri" pitchFamily="34" charset="-122"/>
@@ -17520,7 +17952,7 @@
                       <a:tailEnd type="none" w="med" len="med"/>
                     </a:lnB>
                     <a:solidFill>
-                      <a:srgbClr val="EEF2F5"/>
+                      <a:srgbClr val="EEF3F8"/>
                     </a:solidFill>
                   </a:tcPr>
                 </a:tc>
@@ -17537,7 +17969,7 @@
                       <a:r>
                         <a:rPr lang="en-US" sz="1600" dirty="0">
                           <a:solidFill>
-                            <a:srgbClr val="16202E"/>
+                            <a:srgbClr val="0B1B33"/>
                           </a:solidFill>
                           <a:latin typeface="Calibri" pitchFamily="34" charset="0"/>
                           <a:ea typeface="Calibri" pitchFamily="34" charset="-122"/>
@@ -17605,7 +18037,7 @@
                       <a:r>
                         <a:rPr lang="en-US" sz="1600" dirty="0">
                           <a:solidFill>
-                            <a:srgbClr val="16202E"/>
+                            <a:srgbClr val="0B1B33"/>
                           </a:solidFill>
                           <a:latin typeface="Calibri" pitchFamily="34" charset="0"/>
                           <a:ea typeface="Calibri" pitchFamily="34" charset="-122"/>
@@ -17673,7 +18105,7 @@
                       <a:r>
                         <a:rPr lang="en-US" sz="1600" dirty="0">
                           <a:solidFill>
-                            <a:srgbClr val="16202E"/>
+                            <a:srgbClr val="0B1B33"/>
                           </a:solidFill>
                           <a:latin typeface="Calibri" pitchFamily="34" charset="0"/>
                           <a:ea typeface="Calibri" pitchFamily="34" charset="-122"/>
@@ -17743,7 +18175,7 @@
                       <a:r>
                         <a:rPr lang="en-US" sz="1600" dirty="0">
                           <a:solidFill>
-                            <a:srgbClr val="16202E"/>
+                            <a:srgbClr val="0B1B33"/>
                           </a:solidFill>
                           <a:latin typeface="Calibri" pitchFamily="34" charset="0"/>
                           <a:ea typeface="Calibri" pitchFamily="34" charset="-122"/>
@@ -17796,7 +18228,7 @@
                       <a:tailEnd type="none" w="med" len="med"/>
                     </a:lnB>
                     <a:solidFill>
-                      <a:srgbClr val="EEF2F5"/>
+                      <a:srgbClr val="EEF3F8"/>
                     </a:solidFill>
                   </a:tcPr>
                 </a:tc>
@@ -17811,7 +18243,7 @@
                       <a:r>
                         <a:rPr lang="en-US" sz="1600" dirty="0">
                           <a:solidFill>
-                            <a:srgbClr val="16202E"/>
+                            <a:srgbClr val="0B1B33"/>
                           </a:solidFill>
                           <a:latin typeface="Calibri" pitchFamily="34" charset="0"/>
                           <a:ea typeface="Calibri" pitchFamily="34" charset="-122"/>
@@ -17864,7 +18296,7 @@
                       <a:tailEnd type="none" w="med" len="med"/>
                     </a:lnB>
                     <a:solidFill>
-                      <a:srgbClr val="EEF2F5"/>
+                      <a:srgbClr val="EEF3F8"/>
                     </a:solidFill>
                   </a:tcPr>
                 </a:tc>
@@ -17879,7 +18311,7 @@
                       <a:r>
                         <a:rPr lang="en-US" sz="1600" dirty="0">
                           <a:solidFill>
-                            <a:srgbClr val="16202E"/>
+                            <a:srgbClr val="0B1B33"/>
                           </a:solidFill>
                           <a:latin typeface="Calibri" pitchFamily="34" charset="0"/>
                           <a:ea typeface="Calibri" pitchFamily="34" charset="-122"/>
@@ -17932,7 +18364,7 @@
                       <a:tailEnd type="none" w="med" len="med"/>
                     </a:lnB>
                     <a:solidFill>
-                      <a:srgbClr val="EEF2F5"/>
+                      <a:srgbClr val="EEF3F8"/>
                     </a:solidFill>
                   </a:tcPr>
                 </a:tc>
@@ -17949,7 +18381,7 @@
                       <a:r>
                         <a:rPr lang="en-US" sz="1600" dirty="0">
                           <a:solidFill>
-                            <a:srgbClr val="16202E"/>
+                            <a:srgbClr val="0B1B33"/>
                           </a:solidFill>
                           <a:latin typeface="Calibri" pitchFamily="34" charset="0"/>
                           <a:ea typeface="Calibri" pitchFamily="34" charset="-122"/>
@@ -18017,7 +18449,7 @@
                       <a:r>
                         <a:rPr lang="en-US" sz="1600" dirty="0">
                           <a:solidFill>
-                            <a:srgbClr val="16202E"/>
+                            <a:srgbClr val="0B1B33"/>
                           </a:solidFill>
                           <a:latin typeface="Calibri" pitchFamily="34" charset="0"/>
                           <a:ea typeface="Calibri" pitchFamily="34" charset="-122"/>
@@ -18085,7 +18517,7 @@
                       <a:r>
                         <a:rPr lang="en-US" sz="1600" dirty="0">
                           <a:solidFill>
-                            <a:srgbClr val="16202E"/>
+                            <a:srgbClr val="0B1B33"/>
                           </a:solidFill>
                           <a:latin typeface="Calibri" pitchFamily="34" charset="0"/>
                           <a:ea typeface="Calibri" pitchFamily="34" charset="-122"/>
@@ -18155,7 +18587,7 @@
                       <a:r>
                         <a:rPr lang="en-US" sz="1600" dirty="0">
                           <a:solidFill>
-                            <a:srgbClr val="16202E"/>
+                            <a:srgbClr val="0B1B33"/>
                           </a:solidFill>
                           <a:latin typeface="Calibri" pitchFamily="34" charset="0"/>
                           <a:ea typeface="Calibri" pitchFamily="34" charset="-122"/>
@@ -18208,7 +18640,7 @@
                       <a:tailEnd type="none" w="med" len="med"/>
                     </a:lnB>
                     <a:solidFill>
-                      <a:srgbClr val="EEF2F5"/>
+                      <a:srgbClr val="EEF3F8"/>
                     </a:solidFill>
                   </a:tcPr>
                 </a:tc>
@@ -18223,7 +18655,7 @@
                       <a:r>
                         <a:rPr lang="en-US" sz="1600" dirty="0">
                           <a:solidFill>
-                            <a:srgbClr val="16202E"/>
+                            <a:srgbClr val="0B1B33"/>
                           </a:solidFill>
                           <a:latin typeface="Calibri" pitchFamily="34" charset="0"/>
                           <a:ea typeface="Calibri" pitchFamily="34" charset="-122"/>
@@ -18276,7 +18708,7 @@
                       <a:tailEnd type="none" w="med" len="med"/>
                     </a:lnB>
                     <a:solidFill>
-                      <a:srgbClr val="EEF2F5"/>
+                      <a:srgbClr val="EEF3F8"/>
                     </a:solidFill>
                   </a:tcPr>
                 </a:tc>
@@ -18291,7 +18723,7 @@
                       <a:r>
                         <a:rPr lang="en-US" sz="1600" dirty="0">
                           <a:solidFill>
-                            <a:srgbClr val="16202E"/>
+                            <a:srgbClr val="0B1B33"/>
                           </a:solidFill>
                           <a:latin typeface="Calibri" pitchFamily="34" charset="0"/>
                           <a:ea typeface="Calibri" pitchFamily="34" charset="-122"/>
@@ -18344,7 +18776,7 @@
                       <a:tailEnd type="none" w="med" len="med"/>
                     </a:lnB>
                     <a:solidFill>
-                      <a:srgbClr val="EEF2F5"/>
+                      <a:srgbClr val="EEF3F8"/>
                     </a:solidFill>
                   </a:tcPr>
                 </a:tc>
@@ -18470,7 +18902,7 @@
         <p:spPr>
           <a:xfrm>
             <a:off x="548640" y="320040"/>
-            <a:ext cx="11064240" cy="822960"/>
+            <a:ext cx="9692640" cy="822960"/>
           </a:xfrm>
           <a:prstGeom prst="rect">
             <a:avLst/>
@@ -18482,21 +18914,21 @@
           <a:bodyPr wrap="square" rtlCol="0" anchor="ctr"/>
           <a:lstStyle/>
           <a:p>
-            <a:pPr indent="0" marL="0">
+            <a:pPr algn="l" indent="0" marL="0">
               <a:buNone/>
             </a:pPr>
             <a:r>
-              <a:rPr lang="en-US" sz="2800" b="1" dirty="0">
+              <a:rPr lang="en-US" sz="2600" b="1" dirty="0">
                 <a:solidFill>
                   <a:schemeClr val="tx2"/>
                 </a:solidFill>
-                <a:latin typeface="Cambria" pitchFamily="34" charset="0"/>
-                <a:ea typeface="Cambria" pitchFamily="34" charset="-122"/>
-                <a:cs typeface="Cambria" pitchFamily="34" charset="-120"/>
+                <a:latin typeface="Arial" pitchFamily="34" charset="0"/>
+                <a:ea typeface="Arial" pitchFamily="34" charset="-122"/>
+                <a:cs typeface="Arial" pitchFamily="34" charset="-120"/>
               </a:rPr>
               <a:t>An 18-month roadmap, governance first and memory last</a:t>
             </a:r>
-            <a:endParaRPr lang="en-US" sz="2800" dirty="0"/>
+            <a:endParaRPr lang="en-US" sz="2600" dirty="0"/>
           </a:p>
         </p:txBody>
       </p:sp>
@@ -19652,7 +20084,7 @@
         <p:spPr>
           <a:xfrm>
             <a:off x="548640" y="320040"/>
-            <a:ext cx="11064240" cy="822960"/>
+            <a:ext cx="9692640" cy="822960"/>
           </a:xfrm>
           <a:prstGeom prst="rect">
             <a:avLst/>
@@ -19664,21 +20096,21 @@
           <a:bodyPr wrap="square" rtlCol="0" anchor="ctr"/>
           <a:lstStyle/>
           <a:p>
-            <a:pPr indent="0" marL="0">
+            <a:pPr algn="l" indent="0" marL="0">
               <a:buNone/>
             </a:pPr>
             <a:r>
-              <a:rPr lang="en-US" sz="2800" b="1" dirty="0">
+              <a:rPr lang="en-US" sz="2600" b="1" dirty="0">
                 <a:solidFill>
                   <a:schemeClr val="tx2"/>
                 </a:solidFill>
-                <a:latin typeface="Cambria" pitchFamily="34" charset="0"/>
-                <a:ea typeface="Cambria" pitchFamily="34" charset="-122"/>
-                <a:cs typeface="Cambria" pitchFamily="34" charset="-120"/>
+                <a:latin typeface="Arial" pitchFamily="34" charset="0"/>
+                <a:ea typeface="Arial" pitchFamily="34" charset="-122"/>
+                <a:cs typeface="Arial" pitchFamily="34" charset="-120"/>
               </a:rPr>
               <a:t>Why evaluation comes before the first model call</a:t>
             </a:r>
-            <a:endParaRPr lang="en-US" sz="2800" dirty="0"/>
+            <a:endParaRPr lang="en-US" sz="2600" dirty="0"/>
           </a:p>
         </p:txBody>
       </p:sp>
@@ -20403,7 +20835,7 @@
         <p:spPr>
           <a:xfrm>
             <a:off x="548640" y="320040"/>
-            <a:ext cx="11064240" cy="822960"/>
+            <a:ext cx="9692640" cy="822960"/>
           </a:xfrm>
           <a:prstGeom prst="rect">
             <a:avLst/>
@@ -20415,21 +20847,21 @@
           <a:bodyPr wrap="square" rtlCol="0" anchor="ctr"/>
           <a:lstStyle/>
           <a:p>
-            <a:pPr indent="0" marL="0">
+            <a:pPr algn="l" indent="0" marL="0">
               <a:buNone/>
             </a:pPr>
             <a:r>
-              <a:rPr lang="en-US" sz="2800" b="1" dirty="0">
+              <a:rPr lang="en-US" sz="2600" b="1" dirty="0">
                 <a:solidFill>
                   <a:schemeClr val="tx2"/>
                 </a:solidFill>
-                <a:latin typeface="Cambria" pitchFamily="34" charset="0"/>
-                <a:ea typeface="Cambria" pitchFamily="34" charset="-122"/>
-                <a:cs typeface="Cambria" pitchFamily="34" charset="-120"/>
+                <a:latin typeface="Arial" pitchFamily="34" charset="0"/>
+                <a:ea typeface="Arial" pitchFamily="34" charset="-122"/>
+                <a:cs typeface="Arial" pitchFamily="34" charset="-120"/>
               </a:rPr>
               <a:t>Decisions for the leadership team</a:t>
             </a:r>
-            <a:endParaRPr lang="en-US" sz="2800" dirty="0"/>
+            <a:endParaRPr lang="en-US" sz="2600" dirty="0"/>
           </a:p>
         </p:txBody>
       </p:sp>
@@ -20901,16 +21333,16 @@
       </p:grpSpPr>
       <p:sp>
         <p:nvSpPr>
-          <p:cNvPr id="2" name="Text 0"/>
+          <p:cNvPr id="2" name="Text 2"/>
           <p:cNvSpPr/>
           <p:nvPr>
-            <p:ph idx="100" type="title" hasCustomPrompt="1"/>
+            <p:ph idx="104" type="title" hasCustomPrompt="1"/>
           </p:nvPr>
         </p:nvSpPr>
         <p:spPr>
           <a:xfrm>
-            <a:off x="731520" y="1920240"/>
-            <a:ext cx="10698480" cy="1463040"/>
+            <a:off x="5257800" y="2240280"/>
+            <a:ext cx="6400800" cy="1828800"/>
           </a:xfrm>
           <a:prstGeom prst="rect">
             <a:avLst/>
@@ -20919,65 +21351,90 @@
           <a:ln/>
         </p:spPr>
         <p:txBody>
-          <a:bodyPr wrap="square" rtlCol="0" anchor="b"/>
+          <a:bodyPr wrap="square" rtlCol="0" anchor="t"/>
+          <a:lstStyle/>
+          <a:p>
+            <a:pPr algn="l" indent="0" marL="0">
+              <a:buNone/>
+            </a:pPr>
+            <a:r>
+              <a:rPr lang="en-US" sz="3600" b="1" dirty="0">
+                <a:solidFill>
+                  <a:schemeClr val="bg1"/>
+                </a:solidFill>
+                <a:latin typeface="Arial" pitchFamily="34" charset="0"/>
+                <a:ea typeface="Arial" pitchFamily="34" charset="-122"/>
+                <a:cs typeface="Arial" pitchFamily="34" charset="-120"/>
+              </a:rPr>
+              <a:t>Own the control plane. Rent the components.</a:t>
+            </a:r>
+            <a:endParaRPr lang="en-US" sz="3600" dirty="0"/>
+          </a:p>
+        </p:txBody>
+      </p:sp>
+      <p:sp>
+        <p:nvSpPr>
+          <p:cNvPr id="3" name="Text 2"/>
+          <p:cNvSpPr/>
+          <p:nvPr>
+            <p:ph idx="105" type="body" hasCustomPrompt="1"/>
+          </p:nvPr>
+        </p:nvSpPr>
+        <p:spPr>
+          <a:xfrm>
+            <a:off x="5257800" y="4114800"/>
+            <a:ext cx="6400800" cy="1463040"/>
+          </a:xfrm>
+          <a:prstGeom prst="rect">
+            <a:avLst/>
+          </a:prstGeom>
+          <a:noFill/>
+          <a:ln/>
+        </p:spPr>
+        <p:txBody>
+          <a:bodyPr wrap="square" rtlCol="0" anchor="t"/>
           <a:lstStyle/>
           <a:p>
             <a:pPr indent="0" marL="0">
               <a:buNone/>
             </a:pPr>
             <a:r>
-              <a:rPr lang="en-US" sz="4000" b="1" dirty="0">
+              <a:rPr lang="en-US" sz="1600" dirty="0">
                 <a:solidFill>
-                  <a:schemeClr val="bg1"/>
-                </a:solidFill>
-                <a:latin typeface="Cambria" pitchFamily="34" charset="0"/>
-                <a:ea typeface="Cambria" pitchFamily="34" charset="-122"/>
-                <a:cs typeface="Cambria" pitchFamily="34" charset="-120"/>
-              </a:rPr>
-              <a:t>Own the control plane. Rent the components.</a:t>
-            </a:r>
-            <a:endParaRPr lang="en-US" sz="4000" dirty="0"/>
-          </a:p>
-        </p:txBody>
-      </p:sp>
-      <p:sp>
-        <p:nvSpPr>
-          <p:cNvPr id="3" name="Text 0"/>
-          <p:cNvSpPr/>
-          <p:nvPr>
-            <p:ph idx="101" type="body" hasCustomPrompt="1"/>
-          </p:nvPr>
-        </p:nvSpPr>
-        <p:spPr>
-          <a:xfrm>
-            <a:off x="731520" y="3566160"/>
-            <a:ext cx="10698480" cy="1463040"/>
-          </a:xfrm>
-          <a:prstGeom prst="rect">
-            <a:avLst/>
-          </a:prstGeom>
-          <a:noFill/>
-          <a:ln/>
-        </p:spPr>
-        <p:txBody>
-          <a:bodyPr wrap="square" rtlCol="0" anchor="t"/>
-          <a:lstStyle/>
-          <a:p>
-            <a:pPr indent="0" marL="0">
-              <a:buNone/>
-            </a:pPr>
-            <a:r>
-              <a:rPr lang="en-US" sz="1800" dirty="0">
-                <a:solidFill>
-                  <a:schemeClr val="bg2"/>
+                  <a:schemeClr val="accent5"/>
                 </a:solidFill>
               </a:rPr>
               <a:t>Full evidence: master document (Word/PDF), product technical appendix (138 scored products), offline explorer, dataset and source archive. Every claim is labelled and sourced. Researched and drafted with an Anthropic model; Anthropic items scored on the same rubric, with tiers set by the reader marked.</a:t>
             </a:r>
-            <a:endParaRPr lang="en-US" sz="1800" dirty="0"/>
-          </a:p>
-        </p:txBody>
-      </p:sp>
+            <a:endParaRPr lang="en-US" sz="1600" dirty="0"/>
+          </a:p>
+        </p:txBody>
+      </p:sp>
+    </p:spTree>
+  </p:cSld>
+  <p:clrMapOvr>
+    <a:masterClrMapping/>
+  </p:clrMapOvr>
+</p:sld>
+</file>
+
+<file path=ppt/slides/slide29.xml><?xml version="1.0" encoding="utf-8"?>
+<p:sld xmlns:a="http://schemas.openxmlformats.org/drawingml/2006/main" xmlns:r="http://schemas.openxmlformats.org/officeDocument/2006/relationships" xmlns:p="http://schemas.openxmlformats.org/presentationml/2006/main">
+  <p:cSld name="Slide 29">
+    <p:spTree>
+      <p:nvGrpSpPr>
+        <p:cNvPr id="1" name=""/>
+        <p:cNvGrpSpPr/>
+        <p:nvPr/>
+      </p:nvGrpSpPr>
+      <p:grpSpPr>
+        <a:xfrm>
+          <a:off x="0" y="0"/>
+          <a:ext cx="0" cy="0"/>
+          <a:chOff x="0" y="0"/>
+          <a:chExt cx="0" cy="0"/>
+        </a:xfrm>
+      </p:grpSpPr>
     </p:spTree>
   </p:cSld>
   <p:clrMapOvr>
@@ -21014,7 +21471,7 @@
         <p:spPr>
           <a:xfrm>
             <a:off x="548640" y="320040"/>
-            <a:ext cx="11064240" cy="822960"/>
+            <a:ext cx="9692640" cy="822960"/>
           </a:xfrm>
           <a:prstGeom prst="rect">
             <a:avLst/>
@@ -21026,21 +21483,21 @@
           <a:bodyPr wrap="square" rtlCol="0" anchor="ctr"/>
           <a:lstStyle/>
           <a:p>
-            <a:pPr indent="0" marL="0">
+            <a:pPr algn="l" indent="0" marL="0">
               <a:buNone/>
             </a:pPr>
             <a:r>
-              <a:rPr lang="en-US" sz="2800" b="1" dirty="0">
+              <a:rPr lang="en-US" sz="2600" b="1" dirty="0">
                 <a:solidFill>
                   <a:schemeClr val="tx2"/>
                 </a:solidFill>
-                <a:latin typeface="Cambria" pitchFamily="34" charset="0"/>
-                <a:ea typeface="Cambria" pitchFamily="34" charset="-122"/>
-                <a:cs typeface="Cambria" pitchFamily="34" charset="-120"/>
+                <a:latin typeface="Arial" pitchFamily="34" charset="0"/>
+                <a:ea typeface="Arial" pitchFamily="34" charset="-122"/>
+                <a:cs typeface="Arial" pitchFamily="34" charset="-120"/>
               </a:rPr>
               <a:t>What we reviewed, and how much had moved</a:t>
             </a:r>
-            <a:endParaRPr lang="en-US" sz="2800" dirty="0"/>
+            <a:endParaRPr lang="en-US" sz="2600" dirty="0"/>
           </a:p>
         </p:txBody>
       </p:sp>
@@ -21073,9 +21530,9 @@
                 <a:solidFill>
                   <a:schemeClr val="tx2"/>
                 </a:solidFill>
-                <a:latin typeface="Cambria" pitchFamily="34" charset="0"/>
-                <a:ea typeface="Cambria" pitchFamily="34" charset="-122"/>
-                <a:cs typeface="Cambria" pitchFamily="34" charset="-120"/>
+                <a:latin typeface="Arial" pitchFamily="34" charset="0"/>
+                <a:ea typeface="Arial" pitchFamily="34" charset="-122"/>
+                <a:cs typeface="Arial" pitchFamily="34" charset="-120"/>
               </a:rPr>
               <a:t>80</a:t>
             </a:r>
@@ -21113,7 +21570,7 @@
                   <a:schemeClr val="tx1"/>
                 </a:solidFill>
               </a:rPr>
-              <a:t>tiles in the original graphic</a:t>
+              <a:t>tiles in the popular stack diagram</a:t>
             </a:r>
             <a:endParaRPr lang="en-US" sz="1400" dirty="0"/>
           </a:p>
@@ -21148,9 +21605,9 @@
                 <a:solidFill>
                   <a:schemeClr val="accent6"/>
                 </a:solidFill>
-                <a:latin typeface="Cambria" pitchFamily="34" charset="0"/>
-                <a:ea typeface="Cambria" pitchFamily="34" charset="-122"/>
-                <a:cs typeface="Cambria" pitchFamily="34" charset="-120"/>
+                <a:latin typeface="Arial" pitchFamily="34" charset="0"/>
+                <a:ea typeface="Arial" pitchFamily="34" charset="-122"/>
+                <a:cs typeface="Arial" pitchFamily="34" charset="-120"/>
               </a:rPr>
               <a:t>39</a:t>
             </a:r>
@@ -21223,9 +21680,9 @@
                 <a:solidFill>
                   <a:schemeClr val="accent1"/>
                 </a:solidFill>
-                <a:latin typeface="Cambria" pitchFamily="34" charset="0"/>
-                <a:ea typeface="Cambria" pitchFamily="34" charset="-122"/>
-                <a:cs typeface="Cambria" pitchFamily="34" charset="-120"/>
+                <a:latin typeface="Arial" pitchFamily="34" charset="0"/>
+                <a:ea typeface="Arial" pitchFamily="34" charset="-122"/>
+                <a:cs typeface="Arial" pitchFamily="34" charset="-120"/>
               </a:rPr>
               <a:t>140</a:t>
             </a:r>
@@ -21298,9 +21755,9 @@
                 <a:solidFill>
                   <a:schemeClr val="accent3"/>
                 </a:solidFill>
-                <a:latin typeface="Cambria" pitchFamily="34" charset="0"/>
-                <a:ea typeface="Cambria" pitchFamily="34" charset="-122"/>
-                <a:cs typeface="Cambria" pitchFamily="34" charset="-120"/>
+                <a:latin typeface="Arial" pitchFamily="34" charset="0"/>
+                <a:ea typeface="Arial" pitchFamily="34" charset="-122"/>
+                <a:cs typeface="Arial" pitchFamily="34" charset="-120"/>
               </a:rPr>
               <a:t>1,255</a:t>
             </a:r>
@@ -21537,7 +21994,7 @@
         <p:spPr>
           <a:xfrm>
             <a:off x="548640" y="320040"/>
-            <a:ext cx="11064240" cy="822960"/>
+            <a:ext cx="9692640" cy="822960"/>
           </a:xfrm>
           <a:prstGeom prst="rect">
             <a:avLst/>
@@ -21549,21 +22006,21 @@
           <a:bodyPr wrap="square" rtlCol="0" anchor="ctr"/>
           <a:lstStyle/>
           <a:p>
-            <a:pPr indent="0" marL="0">
+            <a:pPr algn="l" indent="0" marL="0">
               <a:buNone/>
             </a:pPr>
             <a:r>
-              <a:rPr lang="en-US" sz="2800" b="1" dirty="0">
+              <a:rPr lang="en-US" sz="2600" b="1" dirty="0">
                 <a:solidFill>
                   <a:schemeClr val="tx2"/>
                 </a:solidFill>
-                <a:latin typeface="Cambria" pitchFamily="34" charset="0"/>
-                <a:ea typeface="Cambria" pitchFamily="34" charset="-122"/>
-                <a:cs typeface="Cambria" pitchFamily="34" charset="-120"/>
+                <a:latin typeface="Arial" pitchFamily="34" charset="0"/>
+                <a:ea typeface="Arial" pitchFamily="34" charset="-122"/>
+                <a:cs typeface="Arial" pitchFamily="34" charset="-120"/>
               </a:rPr>
               <a:t>Ten findings that change the picture</a:t>
             </a:r>
-            <a:endParaRPr lang="en-US" sz="2800" dirty="0"/>
+            <a:endParaRPr lang="en-US" sz="2600" dirty="0"/>
           </a:p>
         </p:txBody>
       </p:sp>
@@ -21694,7 +22151,7 @@
                   <a:schemeClr val="tx1"/>
                 </a:solidFill>
               </a:rPr>
-              <a:t>None of the eight enterprise controls appears in the graphic.</a:t>
+              <a:t>None of the eight enterprise controls appears in the popular stack diagram.</a:t>
             </a:r>
             <a:endParaRPr lang="en-US" sz="1300" dirty="0"/>
           </a:p>
@@ -22978,7 +23435,7 @@
         <p:spPr>
           <a:xfrm>
             <a:off x="548640" y="320040"/>
-            <a:ext cx="11064240" cy="822960"/>
+            <a:ext cx="9692640" cy="822960"/>
           </a:xfrm>
           <a:prstGeom prst="rect">
             <a:avLst/>
@@ -22990,21 +23447,21 @@
           <a:bodyPr wrap="square" rtlCol="0" anchor="ctr"/>
           <a:lstStyle/>
           <a:p>
-            <a:pPr indent="0" marL="0">
+            <a:pPr algn="l" indent="0" marL="0">
               <a:buNone/>
             </a:pPr>
             <a:r>
-              <a:rPr lang="en-US" sz="2800" b="1" dirty="0">
+              <a:rPr lang="en-US" sz="2600" b="1" dirty="0">
                 <a:solidFill>
                   <a:schemeClr val="tx2"/>
                 </a:solidFill>
-                <a:latin typeface="Cambria" pitchFamily="34" charset="0"/>
-                <a:ea typeface="Cambria" pitchFamily="34" charset="-122"/>
-                <a:cs typeface="Cambria" pitchFamily="34" charset="-120"/>
+                <a:latin typeface="Arial" pitchFamily="34" charset="0"/>
+                <a:ea typeface="Arial" pitchFamily="34" charset="-122"/>
+                <a:cs typeface="Arial" pitchFamily="34" charset="-120"/>
               </a:rPr>
               <a:t>Independence can no longer be assumed from a product's origins</a:t>
             </a:r>
-            <a:endParaRPr lang="en-US" sz="2800" dirty="0"/>
+            <a:endParaRPr lang="en-US" sz="2600" dirty="0"/>
           </a:p>
         </p:txBody>
       </p:sp>
@@ -23100,7 +23557,7 @@
                       <a:tailEnd type="none" w="med" len="med"/>
                     </a:lnB>
                     <a:solidFill>
-                      <a:srgbClr val="1B2A41"/>
+                      <a:srgbClr val="0B1B33"/>
                     </a:solidFill>
                   </a:tcPr>
                 </a:tc>
@@ -23168,7 +23625,7 @@
                       <a:tailEnd type="none" w="med" len="med"/>
                     </a:lnB>
                     <a:solidFill>
-                      <a:srgbClr val="1B2A41"/>
+                      <a:srgbClr val="0B1B33"/>
                     </a:solidFill>
                   </a:tcPr>
                 </a:tc>
@@ -23236,7 +23693,7 @@
                       <a:tailEnd type="none" w="med" len="med"/>
                     </a:lnB>
                     <a:solidFill>
-                      <a:srgbClr val="1B2A41"/>
+                      <a:srgbClr val="0B1B33"/>
                     </a:solidFill>
                   </a:tcPr>
                 </a:tc>
@@ -23253,7 +23710,7 @@
                       <a:r>
                         <a:rPr lang="en-US" sz="1300" dirty="0">
                           <a:solidFill>
-                            <a:srgbClr val="16202E"/>
+                            <a:srgbClr val="0B1B33"/>
                           </a:solidFill>
                           <a:latin typeface="Calibri" pitchFamily="34" charset="0"/>
                           <a:ea typeface="Calibri" pitchFamily="34" charset="-122"/>
@@ -23306,7 +23763,7 @@
                       <a:tailEnd type="none" w="med" len="med"/>
                     </a:lnB>
                     <a:solidFill>
-                      <a:srgbClr val="EEF2F5"/>
+                      <a:srgbClr val="EEF3F8"/>
                     </a:solidFill>
                   </a:tcPr>
                 </a:tc>
@@ -23321,7 +23778,7 @@
                       <a:r>
                         <a:rPr lang="en-US" sz="1300" dirty="0">
                           <a:solidFill>
-                            <a:srgbClr val="16202E"/>
+                            <a:srgbClr val="0B1B33"/>
                           </a:solidFill>
                           <a:latin typeface="Calibri" pitchFamily="34" charset="0"/>
                           <a:ea typeface="Calibri" pitchFamily="34" charset="-122"/>
@@ -23374,7 +23831,7 @@
                       <a:tailEnd type="none" w="med" len="med"/>
                     </a:lnB>
                     <a:solidFill>
-                      <a:srgbClr val="EEF2F5"/>
+                      <a:srgbClr val="EEF3F8"/>
                     </a:solidFill>
                   </a:tcPr>
                 </a:tc>
@@ -23389,7 +23846,7 @@
                       <a:r>
                         <a:rPr lang="en-US" sz="1300" dirty="0">
                           <a:solidFill>
-                            <a:srgbClr val="16202E"/>
+                            <a:srgbClr val="0B1B33"/>
                           </a:solidFill>
                           <a:latin typeface="Calibri" pitchFamily="34" charset="0"/>
                           <a:ea typeface="Calibri" pitchFamily="34" charset="-122"/>
@@ -23442,7 +23899,7 @@
                       <a:tailEnd type="none" w="med" len="med"/>
                     </a:lnB>
                     <a:solidFill>
-                      <a:srgbClr val="EEF2F5"/>
+                      <a:srgbClr val="EEF3F8"/>
                     </a:solidFill>
                   </a:tcPr>
                 </a:tc>
@@ -23459,7 +23916,7 @@
                       <a:r>
                         <a:rPr lang="en-US" sz="1300" dirty="0">
                           <a:solidFill>
-                            <a:srgbClr val="16202E"/>
+                            <a:srgbClr val="0B1B33"/>
                           </a:solidFill>
                           <a:latin typeface="Calibri" pitchFamily="34" charset="0"/>
                           <a:ea typeface="Calibri" pitchFamily="34" charset="-122"/>
@@ -23527,7 +23984,7 @@
                       <a:r>
                         <a:rPr lang="en-US" sz="1300" dirty="0">
                           <a:solidFill>
-                            <a:srgbClr val="16202E"/>
+                            <a:srgbClr val="0B1B33"/>
                           </a:solidFill>
                           <a:latin typeface="Calibri" pitchFamily="34" charset="0"/>
                           <a:ea typeface="Calibri" pitchFamily="34" charset="-122"/>
@@ -23595,7 +24052,7 @@
                       <a:r>
                         <a:rPr lang="en-US" sz="1300" dirty="0">
                           <a:solidFill>
-                            <a:srgbClr val="16202E"/>
+                            <a:srgbClr val="0B1B33"/>
                           </a:solidFill>
                           <a:latin typeface="Calibri" pitchFamily="34" charset="0"/>
                           <a:ea typeface="Calibri" pitchFamily="34" charset="-122"/>
@@ -23665,7 +24122,7 @@
                       <a:r>
                         <a:rPr lang="en-US" sz="1300" dirty="0">
                           <a:solidFill>
-                            <a:srgbClr val="16202E"/>
+                            <a:srgbClr val="0B1B33"/>
                           </a:solidFill>
                           <a:latin typeface="Calibri" pitchFamily="34" charset="0"/>
                           <a:ea typeface="Calibri" pitchFamily="34" charset="-122"/>
@@ -23718,7 +24175,7 @@
                       <a:tailEnd type="none" w="med" len="med"/>
                     </a:lnB>
                     <a:solidFill>
-                      <a:srgbClr val="EEF2F5"/>
+                      <a:srgbClr val="EEF3F8"/>
                     </a:solidFill>
                   </a:tcPr>
                 </a:tc>
@@ -23733,7 +24190,7 @@
                       <a:r>
                         <a:rPr lang="en-US" sz="1300" dirty="0">
                           <a:solidFill>
-                            <a:srgbClr val="16202E"/>
+                            <a:srgbClr val="0B1B33"/>
                           </a:solidFill>
                           <a:latin typeface="Calibri" pitchFamily="34" charset="0"/>
                           <a:ea typeface="Calibri" pitchFamily="34" charset="-122"/>
@@ -23786,7 +24243,7 @@
                       <a:tailEnd type="none" w="med" len="med"/>
                     </a:lnB>
                     <a:solidFill>
-                      <a:srgbClr val="EEF2F5"/>
+                      <a:srgbClr val="EEF3F8"/>
                     </a:solidFill>
                   </a:tcPr>
                 </a:tc>
@@ -23801,7 +24258,7 @@
                       <a:r>
                         <a:rPr lang="en-US" sz="1300" dirty="0">
                           <a:solidFill>
-                            <a:srgbClr val="16202E"/>
+                            <a:srgbClr val="0B1B33"/>
                           </a:solidFill>
                           <a:latin typeface="Calibri" pitchFamily="34" charset="0"/>
                           <a:ea typeface="Calibri" pitchFamily="34" charset="-122"/>
@@ -23854,7 +24311,7 @@
                       <a:tailEnd type="none" w="med" len="med"/>
                     </a:lnB>
                     <a:solidFill>
-                      <a:srgbClr val="EEF2F5"/>
+                      <a:srgbClr val="EEF3F8"/>
                     </a:solidFill>
                   </a:tcPr>
                 </a:tc>
@@ -23871,7 +24328,7 @@
                       <a:r>
                         <a:rPr lang="en-US" sz="1300" dirty="0">
                           <a:solidFill>
-                            <a:srgbClr val="16202E"/>
+                            <a:srgbClr val="0B1B33"/>
                           </a:solidFill>
                           <a:latin typeface="Calibri" pitchFamily="34" charset="0"/>
                           <a:ea typeface="Calibri" pitchFamily="34" charset="-122"/>
@@ -23939,7 +24396,7 @@
                       <a:r>
                         <a:rPr lang="en-US" sz="1300" dirty="0">
                           <a:solidFill>
-                            <a:srgbClr val="16202E"/>
+                            <a:srgbClr val="0B1B33"/>
                           </a:solidFill>
                           <a:latin typeface="Calibri" pitchFamily="34" charset="0"/>
                           <a:ea typeface="Calibri" pitchFamily="34" charset="-122"/>
@@ -24007,7 +24464,7 @@
                       <a:r>
                         <a:rPr lang="en-US" sz="1300" dirty="0">
                           <a:solidFill>
-                            <a:srgbClr val="16202E"/>
+                            <a:srgbClr val="0B1B33"/>
                           </a:solidFill>
                           <a:latin typeface="Calibri" pitchFamily="34" charset="0"/>
                           <a:ea typeface="Calibri" pitchFamily="34" charset="-122"/>
@@ -24077,7 +24534,7 @@
                       <a:r>
                         <a:rPr lang="en-US" sz="1300" dirty="0">
                           <a:solidFill>
-                            <a:srgbClr val="16202E"/>
+                            <a:srgbClr val="0B1B33"/>
                           </a:solidFill>
                           <a:latin typeface="Calibri" pitchFamily="34" charset="0"/>
                           <a:ea typeface="Calibri" pitchFamily="34" charset="-122"/>
@@ -24130,7 +24587,7 @@
                       <a:tailEnd type="none" w="med" len="med"/>
                     </a:lnB>
                     <a:solidFill>
-                      <a:srgbClr val="EEF2F5"/>
+                      <a:srgbClr val="EEF3F8"/>
                     </a:solidFill>
                   </a:tcPr>
                 </a:tc>
@@ -24145,7 +24602,7 @@
                       <a:r>
                         <a:rPr lang="en-US" sz="1300" dirty="0">
                           <a:solidFill>
-                            <a:srgbClr val="16202E"/>
+                            <a:srgbClr val="0B1B33"/>
                           </a:solidFill>
                           <a:latin typeface="Calibri" pitchFamily="34" charset="0"/>
                           <a:ea typeface="Calibri" pitchFamily="34" charset="-122"/>
@@ -24198,7 +24655,7 @@
                       <a:tailEnd type="none" w="med" len="med"/>
                     </a:lnB>
                     <a:solidFill>
-                      <a:srgbClr val="EEF2F5"/>
+                      <a:srgbClr val="EEF3F8"/>
                     </a:solidFill>
                   </a:tcPr>
                 </a:tc>
@@ -24213,7 +24670,7 @@
                       <a:r>
                         <a:rPr lang="en-US" sz="1300" dirty="0">
                           <a:solidFill>
-                            <a:srgbClr val="16202E"/>
+                            <a:srgbClr val="0B1B33"/>
                           </a:solidFill>
                           <a:latin typeface="Calibri" pitchFamily="34" charset="0"/>
                           <a:ea typeface="Calibri" pitchFamily="34" charset="-122"/>
@@ -24266,7 +24723,7 @@
                       <a:tailEnd type="none" w="med" len="med"/>
                     </a:lnB>
                     <a:solidFill>
-                      <a:srgbClr val="EEF2F5"/>
+                      <a:srgbClr val="EEF3F8"/>
                     </a:solidFill>
                   </a:tcPr>
                 </a:tc>
@@ -24283,7 +24740,7 @@
                       <a:r>
                         <a:rPr lang="en-US" sz="1300" dirty="0">
                           <a:solidFill>
-                            <a:srgbClr val="16202E"/>
+                            <a:srgbClr val="0B1B33"/>
                           </a:solidFill>
                           <a:latin typeface="Calibri" pitchFamily="34" charset="0"/>
                           <a:ea typeface="Calibri" pitchFamily="34" charset="-122"/>
@@ -24351,7 +24808,7 @@
                       <a:r>
                         <a:rPr lang="en-US" sz="1300" dirty="0">
                           <a:solidFill>
-                            <a:srgbClr val="16202E"/>
+                            <a:srgbClr val="0B1B33"/>
                           </a:solidFill>
                           <a:latin typeface="Calibri" pitchFamily="34" charset="0"/>
                           <a:ea typeface="Calibri" pitchFamily="34" charset="-122"/>
@@ -24419,7 +24876,7 @@
                       <a:r>
                         <a:rPr lang="en-US" sz="1300" dirty="0">
                           <a:solidFill>
-                            <a:srgbClr val="16202E"/>
+                            <a:srgbClr val="0B1B33"/>
                           </a:solidFill>
                           <a:latin typeface="Calibri" pitchFamily="34" charset="0"/>
                           <a:ea typeface="Calibri" pitchFamily="34" charset="-122"/>
@@ -24489,7 +24946,7 @@
                       <a:r>
                         <a:rPr lang="en-US" sz="1300" dirty="0">
                           <a:solidFill>
-                            <a:srgbClr val="16202E"/>
+                            <a:srgbClr val="0B1B33"/>
                           </a:solidFill>
                           <a:latin typeface="Calibri" pitchFamily="34" charset="0"/>
                           <a:ea typeface="Calibri" pitchFamily="34" charset="-122"/>
@@ -24542,7 +24999,7 @@
                       <a:tailEnd type="none" w="med" len="med"/>
                     </a:lnB>
                     <a:solidFill>
-                      <a:srgbClr val="EEF2F5"/>
+                      <a:srgbClr val="EEF3F8"/>
                     </a:solidFill>
                   </a:tcPr>
                 </a:tc>
@@ -24557,7 +25014,7 @@
                       <a:r>
                         <a:rPr lang="en-US" sz="1300" dirty="0">
                           <a:solidFill>
-                            <a:srgbClr val="16202E"/>
+                            <a:srgbClr val="0B1B33"/>
                           </a:solidFill>
                           <a:latin typeface="Calibri" pitchFamily="34" charset="0"/>
                           <a:ea typeface="Calibri" pitchFamily="34" charset="-122"/>
@@ -24610,7 +25067,7 @@
                       <a:tailEnd type="none" w="med" len="med"/>
                     </a:lnB>
                     <a:solidFill>
-                      <a:srgbClr val="EEF2F5"/>
+                      <a:srgbClr val="EEF3F8"/>
                     </a:solidFill>
                   </a:tcPr>
                 </a:tc>
@@ -24625,7 +25082,7 @@
                       <a:r>
                         <a:rPr lang="en-US" sz="1300" dirty="0">
                           <a:solidFill>
-                            <a:srgbClr val="16202E"/>
+                            <a:srgbClr val="0B1B33"/>
                           </a:solidFill>
                           <a:latin typeface="Calibri" pitchFamily="34" charset="0"/>
                           <a:ea typeface="Calibri" pitchFamily="34" charset="-122"/>
@@ -24678,7 +25135,7 @@
                       <a:tailEnd type="none" w="med" len="med"/>
                     </a:lnB>
                     <a:solidFill>
-                      <a:srgbClr val="EEF2F5"/>
+                      <a:srgbClr val="EEF3F8"/>
                     </a:solidFill>
                   </a:tcPr>
                 </a:tc>
@@ -24695,7 +25152,7 @@
                       <a:r>
                         <a:rPr lang="en-US" sz="1300" dirty="0">
                           <a:solidFill>
-                            <a:srgbClr val="16202E"/>
+                            <a:srgbClr val="0B1B33"/>
                           </a:solidFill>
                           <a:latin typeface="Calibri" pitchFamily="34" charset="0"/>
                           <a:ea typeface="Calibri" pitchFamily="34" charset="-122"/>
@@ -24763,7 +25220,7 @@
                       <a:r>
                         <a:rPr lang="en-US" sz="1300" dirty="0">
                           <a:solidFill>
-                            <a:srgbClr val="16202E"/>
+                            <a:srgbClr val="0B1B33"/>
                           </a:solidFill>
                           <a:latin typeface="Calibri" pitchFamily="34" charset="0"/>
                           <a:ea typeface="Calibri" pitchFamily="34" charset="-122"/>
@@ -24831,7 +25288,7 @@
                       <a:r>
                         <a:rPr lang="en-US" sz="1300" dirty="0">
                           <a:solidFill>
-                            <a:srgbClr val="16202E"/>
+                            <a:srgbClr val="0B1B33"/>
                           </a:solidFill>
                           <a:latin typeface="Calibri" pitchFamily="34" charset="0"/>
                           <a:ea typeface="Calibri" pitchFamily="34" charset="-122"/>
@@ -24901,7 +25358,7 @@
                       <a:r>
                         <a:rPr lang="en-US" sz="1300" dirty="0">
                           <a:solidFill>
-                            <a:srgbClr val="16202E"/>
+                            <a:srgbClr val="0B1B33"/>
                           </a:solidFill>
                           <a:latin typeface="Calibri" pitchFamily="34" charset="0"/>
                           <a:ea typeface="Calibri" pitchFamily="34" charset="-122"/>
@@ -24954,7 +25411,7 @@
                       <a:tailEnd type="none" w="med" len="med"/>
                     </a:lnB>
                     <a:solidFill>
-                      <a:srgbClr val="EEF2F5"/>
+                      <a:srgbClr val="EEF3F8"/>
                     </a:solidFill>
                   </a:tcPr>
                 </a:tc>
@@ -24969,7 +25426,7 @@
                       <a:r>
                         <a:rPr lang="en-US" sz="1300" dirty="0">
                           <a:solidFill>
-                            <a:srgbClr val="16202E"/>
+                            <a:srgbClr val="0B1B33"/>
                           </a:solidFill>
                           <a:latin typeface="Calibri" pitchFamily="34" charset="0"/>
                           <a:ea typeface="Calibri" pitchFamily="34" charset="-122"/>
@@ -25022,7 +25479,7 @@
                       <a:tailEnd type="none" w="med" len="med"/>
                     </a:lnB>
                     <a:solidFill>
-                      <a:srgbClr val="EEF2F5"/>
+                      <a:srgbClr val="EEF3F8"/>
                     </a:solidFill>
                   </a:tcPr>
                 </a:tc>
@@ -25037,7 +25494,7 @@
                       <a:r>
                         <a:rPr lang="en-US" sz="1300" dirty="0">
                           <a:solidFill>
-                            <a:srgbClr val="16202E"/>
+                            <a:srgbClr val="0B1B33"/>
                           </a:solidFill>
                           <a:latin typeface="Calibri" pitchFamily="34" charset="0"/>
                           <a:ea typeface="Calibri" pitchFamily="34" charset="-122"/>
@@ -25090,7 +25547,7 @@
                       <a:tailEnd type="none" w="med" len="med"/>
                     </a:lnB>
                     <a:solidFill>
-                      <a:srgbClr val="EEF2F5"/>
+                      <a:srgbClr val="EEF3F8"/>
                     </a:solidFill>
                   </a:tcPr>
                 </a:tc>
@@ -25107,7 +25564,7 @@
                       <a:r>
                         <a:rPr lang="en-US" sz="1300" dirty="0">
                           <a:solidFill>
-                            <a:srgbClr val="16202E"/>
+                            <a:srgbClr val="0B1B33"/>
                           </a:solidFill>
                           <a:latin typeface="Calibri" pitchFamily="34" charset="0"/>
                           <a:ea typeface="Calibri" pitchFamily="34" charset="-122"/>
@@ -25175,7 +25632,7 @@
                       <a:r>
                         <a:rPr lang="en-US" sz="1300" dirty="0">
                           <a:solidFill>
-                            <a:srgbClr val="16202E"/>
+                            <a:srgbClr val="0B1B33"/>
                           </a:solidFill>
                           <a:latin typeface="Calibri" pitchFamily="34" charset="0"/>
                           <a:ea typeface="Calibri" pitchFamily="34" charset="-122"/>
@@ -25243,7 +25700,7 @@
                       <a:r>
                         <a:rPr lang="en-US" sz="1300" dirty="0">
                           <a:solidFill>
-                            <a:srgbClr val="16202E"/>
+                            <a:srgbClr val="0B1B33"/>
                           </a:solidFill>
                           <a:latin typeface="Calibri" pitchFamily="34" charset="0"/>
                           <a:ea typeface="Calibri" pitchFamily="34" charset="-122"/>
@@ -25584,7 +26041,7 @@
         <p:spPr>
           <a:xfrm>
             <a:off x="548640" y="320040"/>
-            <a:ext cx="11064240" cy="822960"/>
+            <a:ext cx="9692640" cy="822960"/>
           </a:xfrm>
           <a:prstGeom prst="rect">
             <a:avLst/>
@@ -25596,21 +26053,21 @@
           <a:bodyPr wrap="square" rtlCol="0" anchor="ctr"/>
           <a:lstStyle/>
           <a:p>
-            <a:pPr indent="0" marL="0">
+            <a:pPr algn="l" indent="0" marL="0">
               <a:buNone/>
             </a:pPr>
             <a:r>
-              <a:rPr lang="en-US" sz="2800" b="1" dirty="0">
+              <a:rPr lang="en-US" sz="2600" b="1" dirty="0">
                 <a:solidFill>
                   <a:schemeClr val="tx2"/>
                 </a:solidFill>
-                <a:latin typeface="Cambria" pitchFamily="34" charset="0"/>
-                <a:ea typeface="Cambria" pitchFamily="34" charset="-122"/>
-                <a:cs typeface="Cambria" pitchFamily="34" charset="-120"/>
+                <a:latin typeface="Arial" pitchFamily="34" charset="0"/>
+                <a:ea typeface="Arial" pitchFamily="34" charset="-122"/>
+                <a:cs typeface="Arial" pitchFamily="34" charset="-120"/>
               </a:rPr>
               <a:t>The regulatory anchors moved in 2026</a:t>
             </a:r>
-            <a:endParaRPr lang="en-US" sz="2800" dirty="0"/>
+            <a:endParaRPr lang="en-US" sz="2600" dirty="0"/>
           </a:p>
         </p:txBody>
       </p:sp>
@@ -25691,9 +26148,9 @@
                 <a:solidFill>
                   <a:schemeClr val="tx2"/>
                 </a:solidFill>
-                <a:latin typeface="Cambria" pitchFamily="34" charset="0"/>
-                <a:ea typeface="Cambria" pitchFamily="34" charset="-122"/>
-                <a:cs typeface="Cambria" pitchFamily="34" charset="-120"/>
+                <a:latin typeface="Arial" pitchFamily="34" charset="0"/>
+                <a:ea typeface="Arial" pitchFamily="34" charset="-122"/>
+                <a:cs typeface="Arial" pitchFamily="34" charset="-120"/>
               </a:rPr>
               <a:t>17 Apr 2026</a:t>
             </a:r>
@@ -25827,9 +26284,9 @@
                 <a:solidFill>
                   <a:schemeClr val="tx2"/>
                 </a:solidFill>
-                <a:latin typeface="Cambria" pitchFamily="34" charset="0"/>
-                <a:ea typeface="Cambria" pitchFamily="34" charset="-122"/>
-                <a:cs typeface="Cambria" pitchFamily="34" charset="-120"/>
+                <a:latin typeface="Arial" pitchFamily="34" charset="0"/>
+                <a:ea typeface="Arial" pitchFamily="34" charset="-122"/>
+                <a:cs typeface="Arial" pitchFamily="34" charset="-120"/>
               </a:rPr>
               <a:t>2 Aug 2026</a:t>
             </a:r>
@@ -25963,9 +26420,9 @@
                 <a:solidFill>
                   <a:schemeClr val="tx2"/>
                 </a:solidFill>
-                <a:latin typeface="Cambria" pitchFamily="34" charset="0"/>
-                <a:ea typeface="Cambria" pitchFamily="34" charset="-122"/>
-                <a:cs typeface="Cambria" pitchFamily="34" charset="-120"/>
+                <a:latin typeface="Arial" pitchFamily="34" charset="0"/>
+                <a:ea typeface="Arial" pitchFamily="34" charset="-122"/>
+                <a:cs typeface="Arial" pitchFamily="34" charset="-120"/>
               </a:rPr>
               <a:t>18 Mar 2027</a:t>
             </a:r>
@@ -26099,9 +26556,9 @@
                 <a:solidFill>
                   <a:schemeClr val="tx2"/>
                 </a:solidFill>
-                <a:latin typeface="Cambria" pitchFamily="34" charset="0"/>
-                <a:ea typeface="Cambria" pitchFamily="34" charset="-122"/>
-                <a:cs typeface="Cambria" pitchFamily="34" charset="-120"/>
+                <a:latin typeface="Arial" pitchFamily="34" charset="0"/>
+                <a:ea typeface="Arial" pitchFamily="34" charset="-122"/>
+                <a:cs typeface="Arial" pitchFamily="34" charset="-120"/>
               </a:rPr>
               <a:t>2 Dec 2027</a:t>
             </a:r>
@@ -26352,16 +26809,57 @@
       </p:grpSpPr>
       <p:sp>
         <p:nvSpPr>
-          <p:cNvPr id="2" name="Text 0"/>
+          <p:cNvPr id="2" name="Text 1"/>
           <p:cNvSpPr/>
           <p:nvPr>
-            <p:ph idx="100" type="title" hasCustomPrompt="1"/>
+            <p:ph idx="103" type="title" hasCustomPrompt="1"/>
           </p:nvPr>
         </p:nvSpPr>
         <p:spPr>
           <a:xfrm>
-            <a:off x="731520" y="2377440"/>
-            <a:ext cx="10698480" cy="1097280"/>
+            <a:off x="731520" y="2331720"/>
+            <a:ext cx="7315200" cy="1097280"/>
+          </a:xfrm>
+          <a:prstGeom prst="rect">
+            <a:avLst/>
+          </a:prstGeom>
+          <a:noFill/>
+          <a:ln/>
+        </p:spPr>
+        <p:txBody>
+          <a:bodyPr wrap="square" rtlCol="0" anchor="b"/>
+          <a:lstStyle/>
+          <a:p>
+            <a:pPr algn="l" indent="0" marL="0">
+              <a:buNone/>
+            </a:pPr>
+            <a:r>
+              <a:rPr lang="en-US" sz="3400" b="1" dirty="0">
+                <a:solidFill>
+                  <a:schemeClr val="bg1"/>
+                </a:solidFill>
+                <a:latin typeface="Arial" pitchFamily="34" charset="0"/>
+                <a:ea typeface="Arial" pitchFamily="34" charset="-122"/>
+                <a:cs typeface="Arial" pitchFamily="34" charset="-120"/>
+              </a:rPr>
+              <a:t>The architecture</a:t>
+            </a:r>
+            <a:endParaRPr lang="en-US" sz="3400" dirty="0"/>
+          </a:p>
+        </p:txBody>
+      </p:sp>
+      <p:sp>
+        <p:nvSpPr>
+          <p:cNvPr id="3" name="Text 1"/>
+          <p:cNvSpPr/>
+          <p:nvPr>
+            <p:ph idx="104" type="body" hasCustomPrompt="1"/>
+          </p:nvPr>
+        </p:nvSpPr>
+        <p:spPr>
+          <a:xfrm>
+            <a:off x="731520" y="3703320"/>
+            <a:ext cx="7315200" cy="1097280"/>
           </a:xfrm>
           <a:prstGeom prst="rect">
             <a:avLst/>
@@ -26377,55 +26875,14 @@
               <a:buNone/>
             </a:pPr>
             <a:r>
-              <a:rPr lang="en-US" sz="3600" b="1" dirty="0">
-                <a:solidFill>
-                  <a:schemeClr val="bg1"/>
-                </a:solidFill>
-                <a:latin typeface="Cambria" pitchFamily="34" charset="0"/>
-                <a:ea typeface="Cambria" pitchFamily="34" charset="-122"/>
-                <a:cs typeface="Cambria" pitchFamily="34" charset="-120"/>
-              </a:rPr>
-              <a:t>The architecture</a:t>
-            </a:r>
-            <a:endParaRPr lang="en-US" sz="3600" dirty="0"/>
-          </a:p>
-        </p:txBody>
-      </p:sp>
-      <p:sp>
-        <p:nvSpPr>
-          <p:cNvPr id="3" name="Text 0"/>
-          <p:cNvSpPr/>
-          <p:nvPr>
-            <p:ph idx="101" type="body" hasCustomPrompt="1"/>
-          </p:nvPr>
-        </p:nvSpPr>
-        <p:spPr>
-          <a:xfrm>
-            <a:off x="731520" y="3566160"/>
-            <a:ext cx="10698480" cy="914400"/>
-          </a:xfrm>
-          <a:prstGeom prst="rect">
-            <a:avLst/>
-          </a:prstGeom>
-          <a:noFill/>
-          <a:ln/>
-        </p:spPr>
-        <p:txBody>
-          <a:bodyPr wrap="square" rtlCol="0"/>
-          <a:lstStyle/>
-          <a:p>
-            <a:pPr indent="0" marL="0">
-              <a:buNone/>
-            </a:pPr>
-            <a:r>
-              <a:rPr lang="en-US" sz="1800" dirty="0">
+              <a:rPr lang="en-US" sz="1700" dirty="0">
                 <a:solidFill>
                   <a:schemeClr val="accent5"/>
                 </a:solidFill>
               </a:rPr>
               <a:t>Eight hypotheses tested; nine layers renamed, split or merged; one control plane added</a:t>
             </a:r>
-            <a:endParaRPr lang="en-US" sz="1800" dirty="0"/>
+            <a:endParaRPr lang="en-US" sz="1700" dirty="0"/>
           </a:p>
         </p:txBody>
       </p:sp>
@@ -26465,7 +26922,7 @@
         <p:spPr>
           <a:xfrm>
             <a:off x="548640" y="320040"/>
-            <a:ext cx="11064240" cy="822960"/>
+            <a:ext cx="9692640" cy="822960"/>
           </a:xfrm>
           <a:prstGeom prst="rect">
             <a:avLst/>
@@ -26477,21 +26934,21 @@
           <a:bodyPr wrap="square" rtlCol="0" anchor="ctr"/>
           <a:lstStyle/>
           <a:p>
-            <a:pPr indent="0" marL="0">
+            <a:pPr algn="l" indent="0" marL="0">
               <a:buNone/>
             </a:pPr>
             <a:r>
-              <a:rPr lang="en-US" sz="2800" b="1" dirty="0">
+              <a:rPr lang="en-US" sz="2600" b="1" dirty="0">
                 <a:solidFill>
                   <a:schemeClr val="tx2"/>
                 </a:solidFill>
-                <a:latin typeface="Cambria" pitchFamily="34" charset="0"/>
-                <a:ea typeface="Cambria" pitchFamily="34" charset="-122"/>
-                <a:cs typeface="Cambria" pitchFamily="34" charset="-120"/>
+                <a:latin typeface="Arial" pitchFamily="34" charset="0"/>
+                <a:ea typeface="Arial" pitchFamily="34" charset="-122"/>
+                <a:cs typeface="Arial" pitchFamily="34" charset="-120"/>
               </a:rPr>
               <a:t>Four planes under one firm-owned control plane</a:t>
             </a:r>
-            <a:endParaRPr lang="en-US" sz="2800" dirty="0"/>
+            <a:endParaRPr lang="en-US" sz="2600" dirty="0"/>
           </a:p>
         </p:txBody>
       </p:sp>
@@ -27190,7 +27647,7 @@
         <p:spPr>
           <a:xfrm>
             <a:off x="548640" y="320040"/>
-            <a:ext cx="11064240" cy="822960"/>
+            <a:ext cx="9692640" cy="822960"/>
           </a:xfrm>
           <a:prstGeom prst="rect">
             <a:avLst/>
@@ -27202,21 +27659,21 @@
           <a:bodyPr wrap="square" rtlCol="0" anchor="ctr"/>
           <a:lstStyle/>
           <a:p>
-            <a:pPr indent="0" marL="0">
+            <a:pPr algn="l" indent="0" marL="0">
               <a:buNone/>
             </a:pPr>
             <a:r>
-              <a:rPr lang="en-US" sz="2800" b="1" dirty="0">
+              <a:rPr lang="en-US" sz="2600" b="1" dirty="0">
                 <a:solidFill>
                   <a:schemeClr val="tx2"/>
                 </a:solidFill>
-                <a:latin typeface="Cambria" pitchFamily="34" charset="0"/>
-                <a:ea typeface="Cambria" pitchFamily="34" charset="-122"/>
-                <a:cs typeface="Cambria" pitchFamily="34" charset="-120"/>
+                <a:latin typeface="Arial" pitchFamily="34" charset="0"/>
+                <a:ea typeface="Arial" pitchFamily="34" charset="-122"/>
+                <a:cs typeface="Arial" pitchFamily="34" charset="-120"/>
               </a:rPr>
               <a:t>Hypothesis verdicts: what the evidence did to the nine layers</a:t>
             </a:r>
-            <a:endParaRPr lang="en-US" sz="2800" dirty="0"/>
+            <a:endParaRPr lang="en-US" sz="2600" dirty="0"/>
           </a:p>
         </p:txBody>
       </p:sp>
@@ -27312,7 +27769,7 @@
                       <a:tailEnd type="none" w="med" len="med"/>
                     </a:lnB>
                     <a:solidFill>
-                      <a:srgbClr val="1B2A41"/>
+                      <a:srgbClr val="0B1B33"/>
                     </a:solidFill>
                   </a:tcPr>
                 </a:tc>
@@ -27380,7 +27837,7 @@
                       <a:tailEnd type="none" w="med" len="med"/>
                     </a:lnB>
                     <a:solidFill>
-                      <a:srgbClr val="1B2A41"/>
+                      <a:srgbClr val="0B1B33"/>
                     </a:solidFill>
                   </a:tcPr>
                 </a:tc>
@@ -27448,7 +27905,7 @@
                       <a:tailEnd type="none" w="med" len="med"/>
                     </a:lnB>
                     <a:solidFill>
-                      <a:srgbClr val="1B2A41"/>
+                      <a:srgbClr val="0B1B33"/>
                     </a:solidFill>
                   </a:tcPr>
                 </a:tc>
@@ -27465,7 +27922,7 @@
                       <a:r>
                         <a:rPr lang="en-US" sz="1600" dirty="0">
                           <a:solidFill>
-                            <a:srgbClr val="16202E"/>
+                            <a:srgbClr val="0B1B33"/>
                           </a:solidFill>
                           <a:latin typeface="Calibri" pitchFamily="34" charset="0"/>
                           <a:ea typeface="Calibri" pitchFamily="34" charset="-122"/>
@@ -27518,7 +27975,7 @@
                       <a:tailEnd type="none" w="med" len="med"/>
                     </a:lnB>
                     <a:solidFill>
-                      <a:srgbClr val="EEF2F5"/>
+                      <a:srgbClr val="EEF3F8"/>
                     </a:solidFill>
                   </a:tcPr>
                 </a:tc>
@@ -27533,7 +27990,7 @@
                       <a:r>
                         <a:rPr lang="en-US" sz="1600" dirty="0">
                           <a:solidFill>
-                            <a:srgbClr val="16202E"/>
+                            <a:srgbClr val="0B1B33"/>
                           </a:solidFill>
                           <a:latin typeface="Calibri" pitchFamily="34" charset="0"/>
                           <a:ea typeface="Calibri" pitchFamily="34" charset="-122"/>
@@ -27586,7 +28043,7 @@
                       <a:tailEnd type="none" w="med" len="med"/>
                     </a:lnB>
                     <a:solidFill>
-                      <a:srgbClr val="EEF2F5"/>
+                      <a:srgbClr val="EEF3F8"/>
                     </a:solidFill>
                   </a:tcPr>
                 </a:tc>
@@ -27601,7 +28058,7 @@
                       <a:r>
                         <a:rPr lang="en-US" sz="1600" dirty="0">
                           <a:solidFill>
-                            <a:srgbClr val="16202E"/>
+                            <a:srgbClr val="0B1B33"/>
                           </a:solidFill>
                           <a:latin typeface="Calibri" pitchFamily="34" charset="0"/>
                           <a:ea typeface="Calibri" pitchFamily="34" charset="-122"/>
@@ -27654,7 +28111,7 @@
                       <a:tailEnd type="none" w="med" len="med"/>
                     </a:lnB>
                     <a:solidFill>
-                      <a:srgbClr val="EEF2F5"/>
+                      <a:srgbClr val="EEF3F8"/>
                     </a:solidFill>
                   </a:tcPr>
                 </a:tc>
@@ -27671,7 +28128,7 @@
                       <a:r>
                         <a:rPr lang="en-US" sz="1600" dirty="0">
                           <a:solidFill>
-                            <a:srgbClr val="16202E"/>
+                            <a:srgbClr val="0B1B33"/>
                           </a:solidFill>
                           <a:latin typeface="Calibri" pitchFamily="34" charset="0"/>
                           <a:ea typeface="Calibri" pitchFamily="34" charset="-122"/>
@@ -27739,7 +28196,7 @@
                       <a:r>
                         <a:rPr lang="en-US" sz="1600" dirty="0">
                           <a:solidFill>
-                            <a:srgbClr val="16202E"/>
+                            <a:srgbClr val="0B1B33"/>
                           </a:solidFill>
                           <a:latin typeface="Calibri" pitchFamily="34" charset="0"/>
                           <a:ea typeface="Calibri" pitchFamily="34" charset="-122"/>
@@ -27807,7 +28264,7 @@
                       <a:r>
                         <a:rPr lang="en-US" sz="1600" dirty="0">
                           <a:solidFill>
-                            <a:srgbClr val="16202E"/>
+                            <a:srgbClr val="0B1B33"/>
                           </a:solidFill>
                           <a:latin typeface="Calibri" pitchFamily="34" charset="0"/>
                           <a:ea typeface="Calibri" pitchFamily="34" charset="-122"/>
@@ -27877,7 +28334,7 @@
                       <a:r>
                         <a:rPr lang="en-US" sz="1600" dirty="0">
                           <a:solidFill>
-                            <a:srgbClr val="16202E"/>
+                            <a:srgbClr val="0B1B33"/>
                           </a:solidFill>
                           <a:latin typeface="Calibri" pitchFamily="34" charset="0"/>
                           <a:ea typeface="Calibri" pitchFamily="34" charset="-122"/>
@@ -27930,7 +28387,7 @@
                       <a:tailEnd type="none" w="med" len="med"/>
                     </a:lnB>
                     <a:solidFill>
-                      <a:srgbClr val="EEF2F5"/>
+                      <a:srgbClr val="EEF3F8"/>
                     </a:solidFill>
                   </a:tcPr>
                 </a:tc>
@@ -27945,7 +28402,7 @@
                       <a:r>
                         <a:rPr lang="en-US" sz="1600" dirty="0">
                           <a:solidFill>
-                            <a:srgbClr val="16202E"/>
+                            <a:srgbClr val="0B1B33"/>
                           </a:solidFill>
                           <a:latin typeface="Calibri" pitchFamily="34" charset="0"/>
                           <a:ea typeface="Calibri" pitchFamily="34" charset="-122"/>
@@ -27998,7 +28455,7 @@
                       <a:tailEnd type="none" w="med" len="med"/>
                     </a:lnB>
                     <a:solidFill>
-                      <a:srgbClr val="EEF2F5"/>
+                      <a:srgbClr val="EEF3F8"/>
                     </a:solidFill>
                   </a:tcPr>
                 </a:tc>
@@ -28013,7 +28470,7 @@
                       <a:r>
                         <a:rPr lang="en-US" sz="1600" dirty="0">
                           <a:solidFill>
-                            <a:srgbClr val="16202E"/>
+                            <a:srgbClr val="0B1B33"/>
                           </a:solidFill>
                           <a:latin typeface="Calibri" pitchFamily="34" charset="0"/>
                           <a:ea typeface="Calibri" pitchFamily="34" charset="-122"/>
@@ -28066,7 +28523,7 @@
                       <a:tailEnd type="none" w="med" len="med"/>
                     </a:lnB>
                     <a:solidFill>
-                      <a:srgbClr val="EEF2F5"/>
+                      <a:srgbClr val="EEF3F8"/>
                     </a:solidFill>
                   </a:tcPr>
                 </a:tc>
@@ -28083,7 +28540,7 @@
                       <a:r>
                         <a:rPr lang="en-US" sz="1600" dirty="0">
                           <a:solidFill>
-                            <a:srgbClr val="16202E"/>
+                            <a:srgbClr val="0B1B33"/>
                           </a:solidFill>
                           <a:latin typeface="Calibri" pitchFamily="34" charset="0"/>
                           <a:ea typeface="Calibri" pitchFamily="34" charset="-122"/>
@@ -28151,7 +28608,7 @@
                       <a:r>
                         <a:rPr lang="en-US" sz="1600" dirty="0">
                           <a:solidFill>
-                            <a:srgbClr val="16202E"/>
+                            <a:srgbClr val="0B1B33"/>
                           </a:solidFill>
                           <a:latin typeface="Calibri" pitchFamily="34" charset="0"/>
                           <a:ea typeface="Calibri" pitchFamily="34" charset="-122"/>
@@ -28219,7 +28676,7 @@
                       <a:r>
                         <a:rPr lang="en-US" sz="1600" dirty="0">
                           <a:solidFill>
-                            <a:srgbClr val="16202E"/>
+                            <a:srgbClr val="0B1B33"/>
                           </a:solidFill>
                           <a:latin typeface="Calibri" pitchFamily="34" charset="0"/>
                           <a:ea typeface="Calibri" pitchFamily="34" charset="-122"/>
@@ -28289,7 +28746,7 @@
                       <a:r>
                         <a:rPr lang="en-US" sz="1600" dirty="0">
                           <a:solidFill>
-                            <a:srgbClr val="16202E"/>
+                            <a:srgbClr val="0B1B33"/>
                           </a:solidFill>
                           <a:latin typeface="Calibri" pitchFamily="34" charset="0"/>
                           <a:ea typeface="Calibri" pitchFamily="34" charset="-122"/>
@@ -28342,7 +28799,7 @@
                       <a:tailEnd type="none" w="med" len="med"/>
                     </a:lnB>
                     <a:solidFill>
-                      <a:srgbClr val="EEF2F5"/>
+                      <a:srgbClr val="EEF3F8"/>
                     </a:solidFill>
                   </a:tcPr>
                 </a:tc>
@@ -28357,7 +28814,7 @@
                       <a:r>
                         <a:rPr lang="en-US" sz="1600" dirty="0">
                           <a:solidFill>
-                            <a:srgbClr val="16202E"/>
+                            <a:srgbClr val="0B1B33"/>
                           </a:solidFill>
                           <a:latin typeface="Calibri" pitchFamily="34" charset="0"/>
                           <a:ea typeface="Calibri" pitchFamily="34" charset="-122"/>
@@ -28410,7 +28867,7 @@
                       <a:tailEnd type="none" w="med" len="med"/>
                     </a:lnB>
                     <a:solidFill>
-                      <a:srgbClr val="EEF2F5"/>
+                      <a:srgbClr val="EEF3F8"/>
                     </a:solidFill>
                   </a:tcPr>
                 </a:tc>
@@ -28425,7 +28882,7 @@
                       <a:r>
                         <a:rPr lang="en-US" sz="1600" dirty="0">
                           <a:solidFill>
-                            <a:srgbClr val="16202E"/>
+                            <a:srgbClr val="0B1B33"/>
                           </a:solidFill>
                           <a:latin typeface="Calibri" pitchFamily="34" charset="0"/>
                           <a:ea typeface="Calibri" pitchFamily="34" charset="-122"/>
@@ -28478,7 +28935,7 @@
                       <a:tailEnd type="none" w="med" len="med"/>
                     </a:lnB>
                     <a:solidFill>
-                      <a:srgbClr val="EEF2F5"/>
+                      <a:srgbClr val="EEF3F8"/>
                     </a:solidFill>
                   </a:tcPr>
                 </a:tc>
@@ -28495,7 +28952,7 @@
                       <a:r>
                         <a:rPr lang="en-US" sz="1600" dirty="0">
                           <a:solidFill>
-                            <a:srgbClr val="16202E"/>
+                            <a:srgbClr val="0B1B33"/>
                           </a:solidFill>
                           <a:latin typeface="Calibri" pitchFamily="34" charset="0"/>
                           <a:ea typeface="Calibri" pitchFamily="34" charset="-122"/>
@@ -28563,7 +29020,7 @@
                       <a:r>
                         <a:rPr lang="en-US" sz="1600" dirty="0">
                           <a:solidFill>
-                            <a:srgbClr val="16202E"/>
+                            <a:srgbClr val="0B1B33"/>
                           </a:solidFill>
                           <a:latin typeface="Calibri" pitchFamily="34" charset="0"/>
                           <a:ea typeface="Calibri" pitchFamily="34" charset="-122"/>
@@ -28631,7 +29088,7 @@
                       <a:r>
                         <a:rPr lang="en-US" sz="1600" dirty="0">
                           <a:solidFill>
-                            <a:srgbClr val="16202E"/>
+                            <a:srgbClr val="0B1B33"/>
                           </a:solidFill>
                           <a:latin typeface="Calibri" pitchFamily="34" charset="0"/>
                           <a:ea typeface="Calibri" pitchFamily="34" charset="-122"/>
@@ -28701,7 +29158,7 @@
                       <a:r>
                         <a:rPr lang="en-US" sz="1600" dirty="0">
                           <a:solidFill>
-                            <a:srgbClr val="16202E"/>
+                            <a:srgbClr val="0B1B33"/>
                           </a:solidFill>
                           <a:latin typeface="Calibri" pitchFamily="34" charset="0"/>
                           <a:ea typeface="Calibri" pitchFamily="34" charset="-122"/>
@@ -28754,7 +29211,7 @@
                       <a:tailEnd type="none" w="med" len="med"/>
                     </a:lnB>
                     <a:solidFill>
-                      <a:srgbClr val="EEF2F5"/>
+                      <a:srgbClr val="EEF3F8"/>
                     </a:solidFill>
                   </a:tcPr>
                 </a:tc>
@@ -28769,7 +29226,7 @@
                       <a:r>
                         <a:rPr lang="en-US" sz="1600" dirty="0">
                           <a:solidFill>
-                            <a:srgbClr val="16202E"/>
+                            <a:srgbClr val="0B1B33"/>
                           </a:solidFill>
                           <a:latin typeface="Calibri" pitchFamily="34" charset="0"/>
                           <a:ea typeface="Calibri" pitchFamily="34" charset="-122"/>
@@ -28822,7 +29279,7 @@
                       <a:tailEnd type="none" w="med" len="med"/>
                     </a:lnB>
                     <a:solidFill>
-                      <a:srgbClr val="EEF2F5"/>
+                      <a:srgbClr val="EEF3F8"/>
                     </a:solidFill>
                   </a:tcPr>
                 </a:tc>
@@ -28837,7 +29294,7 @@
                       <a:r>
                         <a:rPr lang="en-US" sz="1600" dirty="0">
                           <a:solidFill>
-                            <a:srgbClr val="16202E"/>
+                            <a:srgbClr val="0B1B33"/>
                           </a:solidFill>
                           <a:latin typeface="Calibri" pitchFamily="34" charset="0"/>
                           <a:ea typeface="Calibri" pitchFamily="34" charset="-122"/>
@@ -28890,7 +29347,7 @@
                       <a:tailEnd type="none" w="med" len="med"/>
                     </a:lnB>
                     <a:solidFill>
-                      <a:srgbClr val="EEF2F5"/>
+                      <a:srgbClr val="EEF3F8"/>
                     </a:solidFill>
                   </a:tcPr>
                 </a:tc>
@@ -28907,7 +29364,7 @@
                       <a:r>
                         <a:rPr lang="en-US" sz="1600" dirty="0">
                           <a:solidFill>
-                            <a:srgbClr val="16202E"/>
+                            <a:srgbClr val="0B1B33"/>
                           </a:solidFill>
                           <a:latin typeface="Calibri" pitchFamily="34" charset="0"/>
                           <a:ea typeface="Calibri" pitchFamily="34" charset="-122"/>
@@ -28975,7 +29432,7 @@
                       <a:r>
                         <a:rPr lang="en-US" sz="1600" dirty="0">
                           <a:solidFill>
-                            <a:srgbClr val="16202E"/>
+                            <a:srgbClr val="0B1B33"/>
                           </a:solidFill>
                           <a:latin typeface="Calibri" pitchFamily="34" charset="0"/>
                           <a:ea typeface="Calibri" pitchFamily="34" charset="-122"/>
@@ -29043,7 +29500,7 @@
                       <a:r>
                         <a:rPr lang="en-US" sz="1600" dirty="0">
                           <a:solidFill>
-                            <a:srgbClr val="16202E"/>
+                            <a:srgbClr val="0B1B33"/>
                           </a:solidFill>
                           <a:latin typeface="Calibri" pitchFamily="34" charset="0"/>
                           <a:ea typeface="Calibri" pitchFamily="34" charset="-122"/>
@@ -29159,49 +29616,49 @@
 </file>
 
 <file path=ppt/theme/theme1.xml><?xml version="1.0" encoding="utf-8"?>
-<a:theme xmlns:a="http://schemas.openxmlformats.org/drawingml/2006/main" name="Regulated GenAI">
+<a:theme xmlns:a="http://schemas.openxmlformats.org/drawingml/2006/main" name="Veyan">
   <a:themeElements>
-    <a:clrScheme name="Regulated GenAI">
+    <a:clrScheme name="Veyan">
       <a:dk1>
-        <a:srgbClr val="16202E"/>
+        <a:srgbClr val="0B1B33"/>
       </a:dk1>
       <a:lt1>
         <a:srgbClr val="FFFFFF"/>
       </a:lt1>
       <a:dk2>
-        <a:srgbClr val="1B2A41"/>
+        <a:srgbClr val="0B1B33"/>
       </a:dk2>
       <a:lt2>
-        <a:srgbClr val="EEF2F5"/>
+        <a:srgbClr val="F5F1E8"/>
       </a:lt2>
       <a:accent1>
-        <a:srgbClr val="0E7C7B"/>
+        <a:srgbClr val="2E6DA4"/>
       </a:accent1>
       <a:accent2>
-        <a:srgbClr val="1B2A41"/>
+        <a:srgbClr val="0B1B33"/>
       </a:accent2>
       <a:accent3>
-        <a:srgbClr val="C9822B"/>
+        <a:srgbClr val="D4A13A"/>
       </a:accent3>
       <a:accent4>
         <a:srgbClr val="6B7A8F"/>
       </a:accent4>
       <a:accent5>
-        <a:srgbClr val="8FB9B8"/>
+        <a:srgbClr val="9DBBDB"/>
       </a:accent5>
       <a:accent6>
         <a:srgbClr val="B3474B"/>
       </a:accent6>
       <a:hlink>
-        <a:srgbClr val="0E7C7B"/>
+        <a:srgbClr val="2E6DA4"/>
       </a:hlink>
       <a:folHlink>
         <a:srgbClr val="6B7A8F"/>
       </a:folHlink>
     </a:clrScheme>
-    <a:fontScheme name="Regulated GenAI">
+    <a:fontScheme name="Veyan">
       <a:majorFont>
-        <a:latin typeface="Cambria"/>
+        <a:latin typeface="Arial"/>
         <a:ea typeface=""/>
         <a:cs typeface=""/>
         <a:font script="Jpan" typeface="游ゴシック Light"/>

</xml_diff>

<commit_message>
Seven views in the appendix (fit by view), deck (Seven lenses section, 38 slides) and Explorer (view selector, Seven views tab); new-baseline wording in deck, explorer, appendix and graphics; master and appendix make a PDF only with --pdf; ZIP and Word-PDF mentions removed from the run guides, README, CONTEXT and publishing kits; source count 1,449
Co-Authored-By: Claude Opus 5.5 <noreply@anthropic.com>
Claude-Session: https://claude.ai/code/session_01GYt6k15P64MhHqeyveeQ6D
</commit_message>
<xml_diff>
--- a/Enterprise_GenAI_Stack_Oct2026/03_Slides/Executive_Deck.pptx
+++ b/Enterprise_GenAI_Stack_Oct2026/03_Slides/Executive_Deck.pptx
@@ -144,21 +144,21 @@
   <p:extLst>
     <p:ext uri="{521415D9-36F7-43E2-AB2F-B90AF26B5E84}">
       <p14:sectionLst xmlns:p14="http://schemas.microsoft.com/office/powerpoint/2010/main">
-        <p14:section name="Opening" id="{7b79db13-a7d6-3f3a-15b3-205e626ac969}">
+        <p14:section name="Opening" id="{e6acd63b-70ee-c9cf-6030-9ed8e70ea6e2}">
           <p14:sldIdLst>
             <p14:sldId id="256"/>
             <p14:sldId id="257"/>
             <p14:sldId id="258"/>
           </p14:sldIdLst>
         </p14:section>
-        <p14:section name="The view at end of Q3 2026" id="{82e34b5e-9b7f-2ac4-9dbc-b097380173d2}">
+        <p14:section name="The view at end of Q3 2026" id="{a1f9c98e-1336-62e4-7963-7dc7d4d24641}">
           <p14:sldIdLst>
             <p14:sldId id="259"/>
             <p14:sldId id="260"/>
             <p14:sldId id="261"/>
           </p14:sldIdLst>
         </p14:section>
-        <p14:section name="The architecture" id="{9d8f5921-dc94-9bd0-3431-df33b19ae8aa}">
+        <p14:section name="The architecture" id="{8c3b0f41-0109-23ff-2777-ab21391731bc}">
           <p14:sldIdLst>
             <p14:sldId id="262"/>
             <p14:sldId id="263"/>
@@ -166,7 +166,7 @@
             <p14:sldId id="265"/>
           </p14:sldIdLst>
         </p14:section>
-        <p14:section name="What to select" id="{81031efc-1d2a-76e0-db8b-6164f4ba560c}">
+        <p14:section name="What to select" id="{e180c7f9-890e-0209-8330-7ce36528fc1e}">
           <p14:sldIdLst>
             <p14:sldId id="266"/>
             <p14:sldId id="267"/>
@@ -176,7 +176,7 @@
             <p14:sldId id="271"/>
           </p14:sldIdLst>
         </p14:section>
-        <p14:section name="Regulated view" id="{96407f2a-33da-70c9-16d6-4c0d78996da7}">
+        <p14:section name="Regulated view" id="{f04a1fd3-449f-095a-3158-98d03d013ddc}">
           <p14:sldIdLst>
             <p14:sldId id="272"/>
             <p14:sldId id="273"/>
@@ -184,7 +184,7 @@
             <p14:sldId id="275"/>
           </p14:sldIdLst>
         </p14:section>
-        <p14:section name="Delivery" id="{6ad8da4c-adf0-b791-fc10-77c959c002de}">
+        <p14:section name="Delivery" id="{e00210ba-06cb-1d32-98c1-28256ad7db4f}">
           <p14:sldIdLst>
             <p14:sldId id="276"/>
             <p14:sldId id="277"/>
@@ -194,7 +194,7 @@
             <p14:sldId id="281"/>
           </p14:sldIdLst>
         </p14:section>
-        <p14:section name="Seven lenses" id="{d09e6d31-22fd-62bf-0aed-b24c6c51c3af}">
+        <p14:section name="Seven lenses" id="{d053cff1-470f-74fc-d556-37013a10acb1}">
           <p14:sldIdLst>
             <p14:sldId id="282"/>
             <p14:sldId id="283"/>
@@ -207,7 +207,7 @@
             <p14:sldId id="290"/>
           </p14:sldIdLst>
         </p14:section>
-        <p14:section name="Close" id="{f6a7e7bf-784e-558f-b79f-c789cee88646}">
+        <p14:section name="Close" id="{95b90602-2b24-f954-4b61-e6920d619965}">
           <p14:sldIdLst>
             <p14:sldId id="291"/>
             <p14:sldId id="292"/>
@@ -1610,7 +1610,7 @@
           <a:p>
             <a:r>
               <a:rPr lang="en-US" dirty="0"/>
-              <a:t>Purpose: give the leadership team one decision-ready view of the 2026 GenAI stack. The full evidence (about 230,000 words, 1,255 sources) sits in the master document and appendix. Disclosure: researched and drafted with an Anthropic model; Anthropic items were scored on the same rubric, borderline calls resolved against them, and tiers set by the reader are marked.</a:t>
+              <a:t>Purpose: give the leadership team one decision-ready view of the 2026 GenAI stack. The full evidence (about 230,000 words, 1,449 sources) sits in the master document and appendix. Disclosure: researched and drafted with an Anthropic model; Anthropic items were scored on the same rubric, borderline calls resolved against them, and tiers set by the reader are marked.</a:t>
             </a:r>
             <a:endParaRPr lang="en-US" dirty="0"/>
           </a:p>
@@ -2138,7 +2138,7 @@
           <a:p>
             <a:r>
               <a:rPr lang="en-US" dirty="0"/>
-              <a:t>The baseline this review sets, stated on its own terms. Layer and control definitions: synthesis Part IV; product status (current, retired, renamed, acquired, unverifiable) in each record of 05_Data/products.json and the product technical appendix.</a:t>
+              <a:t>The baseline this review sets, stated on its own terms (master document Part XII, 'The new baseline at a glance'). Layer and control definitions: Part IV; product status (current, retired, renamed, acquired, unverifiable) in each record of 05_Data/products.json and the product technical appendix.</a:t>
             </a:r>
             <a:endParaRPr lang="en-US" dirty="0"/>
           </a:p>
@@ -6112,7 +6112,7 @@
                   <a:schemeClr val="accent5"/>
                 </a:solidFill>
               </a:rPr>
-              <a:t>Reference architecture · 9 layers · 8 enterprise controls · 140 products · 1,255 sources</a:t>
+              <a:t>Reference architecture · 9 layers · 8 enterprise controls · 140 products · 1,449 sources</a:t>
             </a:r>
             <a:endParaRPr lang="en-US" sz="1100" dirty="0"/>
           </a:p>
@@ -25735,7 +25735,7 @@
                 <a:ea typeface="Arial" pitchFamily="34" charset="-122"/>
                 <a:cs typeface="Arial" pitchFamily="34" charset="-120"/>
               </a:rPr>
-              <a:t>1,255</a:t>
+              <a:t>1,449</a:t>
             </a:r>
             <a:endParaRPr lang="en-US" sz="6000" dirty="0"/>
           </a:p>

</xml_diff>

<commit_message>
Full rebuild: dataset, views, figures, explorer, LinkedIn calendar and series, deck (38 slides) and deck PDF, master, print and Kindle edition (Interior.docx), LinkedIn book with Part IV, appendix; no ZIP, no PDF from any Word document
Co-Authored-By: Claude Opus 5.5 <noreply@anthropic.com>
Claude-Session: https://claude.ai/code/session_01GYt6k15P64MhHqeyveeQ6D
</commit_message>
<xml_diff>
--- a/Enterprise_GenAI_Stack_Oct2026/03_Slides/Executive_Deck.pptx
+++ b/Enterprise_GenAI_Stack_Oct2026/03_Slides/Executive_Deck.pptx
@@ -144,21 +144,21 @@
   <p:extLst>
     <p:ext uri="{521415D9-36F7-43E2-AB2F-B90AF26B5E84}">
       <p14:sectionLst xmlns:p14="http://schemas.microsoft.com/office/powerpoint/2010/main">
-        <p14:section name="Opening" id="{e6acd63b-70ee-c9cf-6030-9ed8e70ea6e2}">
+        <p14:section name="Opening" id="{ddf2c6f2-520a-6b03-1b81-5a1371cda191}">
           <p14:sldIdLst>
             <p14:sldId id="256"/>
             <p14:sldId id="257"/>
             <p14:sldId id="258"/>
           </p14:sldIdLst>
         </p14:section>
-        <p14:section name="The view at end of Q3 2026" id="{a1f9c98e-1336-62e4-7963-7dc7d4d24641}">
+        <p14:section name="The view at end of Q3 2026" id="{bf39984f-26c7-2f4e-c75d-e1fb63701dab}">
           <p14:sldIdLst>
             <p14:sldId id="259"/>
             <p14:sldId id="260"/>
             <p14:sldId id="261"/>
           </p14:sldIdLst>
         </p14:section>
-        <p14:section name="The architecture" id="{8c3b0f41-0109-23ff-2777-ab21391731bc}">
+        <p14:section name="The architecture" id="{5fffc106-4d3e-3c98-31e2-6924cf655ea4}">
           <p14:sldIdLst>
             <p14:sldId id="262"/>
             <p14:sldId id="263"/>
@@ -166,7 +166,7 @@
             <p14:sldId id="265"/>
           </p14:sldIdLst>
         </p14:section>
-        <p14:section name="What to select" id="{e180c7f9-890e-0209-8330-7ce36528fc1e}">
+        <p14:section name="What to select" id="{67ebfb36-793a-5e49-2a6d-1668d66a1ea5}">
           <p14:sldIdLst>
             <p14:sldId id="266"/>
             <p14:sldId id="267"/>
@@ -176,7 +176,7 @@
             <p14:sldId id="271"/>
           </p14:sldIdLst>
         </p14:section>
-        <p14:section name="Regulated view" id="{f04a1fd3-449f-095a-3158-98d03d013ddc}">
+        <p14:section name="Regulated view" id="{5165249f-8a6f-6e08-f56a-da9262d8dff9}">
           <p14:sldIdLst>
             <p14:sldId id="272"/>
             <p14:sldId id="273"/>
@@ -184,7 +184,7 @@
             <p14:sldId id="275"/>
           </p14:sldIdLst>
         </p14:section>
-        <p14:section name="Delivery" id="{e00210ba-06cb-1d32-98c1-28256ad7db4f}">
+        <p14:section name="Delivery" id="{b044b596-8973-f8fd-97cb-9fafcb738d1c}">
           <p14:sldIdLst>
             <p14:sldId id="276"/>
             <p14:sldId id="277"/>
@@ -194,7 +194,7 @@
             <p14:sldId id="281"/>
           </p14:sldIdLst>
         </p14:section>
-        <p14:section name="Seven lenses" id="{d053cff1-470f-74fc-d556-37013a10acb1}">
+        <p14:section name="Seven lenses" id="{595d6527-4361-92e6-c607-768511cd7346}">
           <p14:sldIdLst>
             <p14:sldId id="282"/>
             <p14:sldId id="283"/>
@@ -207,7 +207,7 @@
             <p14:sldId id="290"/>
           </p14:sldIdLst>
         </p14:section>
-        <p14:section name="Close" id="{95b90602-2b24-f954-4b61-e6920d619965}">
+        <p14:section name="Close" id="{78041970-7c97-07e6-ede9-72098950cb70}">
           <p14:sldIdLst>
             <p14:sldId id="291"/>
             <p14:sldId id="292"/>

</xml_diff>

<commit_message>
Edition setting: edition.json read by every tool; new_edition.py, check_edition.py; deck counts from dataset_stats.json
</commit_message>
<xml_diff>
--- a/Enterprise_GenAI_Stack_Oct2026/03_Slides/Executive_Deck.pptx
+++ b/Enterprise_GenAI_Stack_Oct2026/03_Slides/Executive_Deck.pptx
@@ -144,21 +144,21 @@
   <p:extLst>
     <p:ext uri="{521415D9-36F7-43E2-AB2F-B90AF26B5E84}">
       <p14:sectionLst xmlns:p14="http://schemas.microsoft.com/office/powerpoint/2010/main">
-        <p14:section name="Opening" id="{e6acd63b-70ee-c9cf-6030-9ed8e70ea6e2}">
+        <p14:section name="Opening" id="{1ca3184d-998c-bba8-62da-7decbe03a2d0}">
           <p14:sldIdLst>
             <p14:sldId id="256"/>
             <p14:sldId id="257"/>
             <p14:sldId id="258"/>
           </p14:sldIdLst>
         </p14:section>
-        <p14:section name="The view at end of Q3 2026" id="{a1f9c98e-1336-62e4-7963-7dc7d4d24641}">
+        <p14:section name="The view at end of Q3 2026" id="{87f46e3d-0273-5913-5b49-50281e041c1d}">
           <p14:sldIdLst>
             <p14:sldId id="259"/>
             <p14:sldId id="260"/>
             <p14:sldId id="261"/>
           </p14:sldIdLst>
         </p14:section>
-        <p14:section name="The architecture" id="{8c3b0f41-0109-23ff-2777-ab21391731bc}">
+        <p14:section name="The architecture" id="{d7c668b7-1a33-00fe-bd9a-f162541ffdf7}">
           <p14:sldIdLst>
             <p14:sldId id="262"/>
             <p14:sldId id="263"/>
@@ -166,7 +166,7 @@
             <p14:sldId id="265"/>
           </p14:sldIdLst>
         </p14:section>
-        <p14:section name="What to select" id="{e180c7f9-890e-0209-8330-7ce36528fc1e}">
+        <p14:section name="What to select" id="{898503fb-dac6-987f-e31b-3688c63fdd38}">
           <p14:sldIdLst>
             <p14:sldId id="266"/>
             <p14:sldId id="267"/>
@@ -176,7 +176,7 @@
             <p14:sldId id="271"/>
           </p14:sldIdLst>
         </p14:section>
-        <p14:section name="Regulated view" id="{f04a1fd3-449f-095a-3158-98d03d013ddc}">
+        <p14:section name="Regulated view" id="{2f87ea7f-3a60-33cb-e723-c63fccc6d0f1}">
           <p14:sldIdLst>
             <p14:sldId id="272"/>
             <p14:sldId id="273"/>
@@ -184,7 +184,7 @@
             <p14:sldId id="275"/>
           </p14:sldIdLst>
         </p14:section>
-        <p14:section name="Delivery" id="{e00210ba-06cb-1d32-98c1-28256ad7db4f}">
+        <p14:section name="Delivery" id="{c18b9147-cad4-1fc6-7b1a-cdeb9cafa024}">
           <p14:sldIdLst>
             <p14:sldId id="276"/>
             <p14:sldId id="277"/>
@@ -194,7 +194,7 @@
             <p14:sldId id="281"/>
           </p14:sldIdLst>
         </p14:section>
-        <p14:section name="Seven lenses" id="{d053cff1-470f-74fc-d556-37013a10acb1}">
+        <p14:section name="Seven lenses" id="{6e03f205-fa77-c7d5-aedc-2c26195ee55b}">
           <p14:sldIdLst>
             <p14:sldId id="282"/>
             <p14:sldId id="283"/>
@@ -207,7 +207,7 @@
             <p14:sldId id="290"/>
           </p14:sldIdLst>
         </p14:section>
-        <p14:section name="Close" id="{95b90602-2b24-f954-4b61-e6920d619965}">
+        <p14:section name="Close" id="{1b50a85d-d0c6-15b7-4462-8d9b519b4a76}">
           <p14:sldIdLst>
             <p14:sldId id="291"/>
             <p14:sldId id="292"/>
@@ -1610,7 +1610,7 @@
           <a:p>
             <a:r>
               <a:rPr lang="en-US" dirty="0"/>
-              <a:t>Purpose: give the leadership team one decision-ready view of the 2026 GenAI stack. The full evidence (about 230,000 words, 1,449 sources) sits in the master document and appendix. Disclosure: researched and drafted with an Anthropic model; Anthropic items were scored on the same rubric, borderline calls resolved against them, and tiers set by the reader are marked.</a:t>
+              <a:t>Purpose: give the leadership team one decision-ready view of the 2026 GenAI stack. The full evidence (1,449 sources) sits in the master document and appendix. Disclosure: researched and drafted with an Anthropic model; Anthropic items were scored on the same rubric, borderline calls resolved against them, and tiers set by the reader are marked.</a:t>
             </a:r>
             <a:endParaRPr lang="en-US" dirty="0"/>
           </a:p>

</xml_diff>